<commit_message>
Update capstone demo deck
Co-authored-by: Copilot <223556219+Copilot@users.noreply.github.com>
</commit_message>
<xml_diff>
--- a/demo/AIOps_Guardian_Pro_Capstone.pptx
+++ b/demo/AIOps_Guardian_Pro_Capstone.pptx
@@ -1,31 +1,127 @@
 
 <file path=ppt/presentation.xml><?xml version="1.0" encoding="utf-8"?>
-<p:presentation xmlns:p="http://schemas.openxmlformats.org/presentationml/2006/main">
+<p:presentation xmlns:a="http://schemas.openxmlformats.org/drawingml/2006/main" xmlns:r="http://schemas.openxmlformats.org/officeDocument/2006/relationships" xmlns:p="http://schemas.openxmlformats.org/presentationml/2006/main">
   <p:sldMasterIdLst>
-    <p:sldMasterId xmlns:r="http://schemas.openxmlformats.org/officeDocument/2006/relationships" id="2147483648" r:id="Rb5df0f6724174911"/>
+    <p:sldMasterId id="2147483648" r:id="rId1"/>
   </p:sldMasterIdLst>
   <p:notesMasterIdLst>
-    <p:notesMasterId xmlns:r="http://schemas.openxmlformats.org/officeDocument/2006/relationships" r:id="R421c27f9e6204ac5"/>
+    <p:notesMasterId r:id="rId9"/>
   </p:notesMasterIdLst>
   <p:sldIdLst>
-    <p:sldId xmlns:r="http://schemas.openxmlformats.org/officeDocument/2006/relationships" id="256" r:id="Ra6c857662a4a4dbc"/>
-    <p:sldId xmlns:r="http://schemas.openxmlformats.org/officeDocument/2006/relationships" id="257" r:id="R10123c00acb94117"/>
-    <p:sldId xmlns:r="http://schemas.openxmlformats.org/officeDocument/2006/relationships" id="258" r:id="Re4436b223f324954"/>
-    <p:sldId xmlns:r="http://schemas.openxmlformats.org/officeDocument/2006/relationships" id="259" r:id="Rdd49be337dbc4c42"/>
-    <p:sldId xmlns:r="http://schemas.openxmlformats.org/officeDocument/2006/relationships" id="260" r:id="Racefc3b1fe944b71"/>
-    <p:sldId xmlns:r="http://schemas.openxmlformats.org/officeDocument/2006/relationships" id="261" r:id="Raf6979bc2bf14b60"/>
+    <p:sldId id="256" r:id="rId2"/>
+    <p:sldId id="257" r:id="rId3"/>
+    <p:sldId id="258" r:id="rId4"/>
+    <p:sldId id="259" r:id="rId5"/>
+    <p:sldId id="260" r:id="rId6"/>
+    <p:sldId id="262" r:id="rId7"/>
+    <p:sldId id="261" r:id="rId8"/>
   </p:sldIdLst>
   <p:sldSz cx="12192000" cy="6858000"/>
   <p:notesSz cx="6858000" cy="9144000"/>
+  <p:defaultTextStyle>
+    <a:defPPr>
+      <a:defRPr lang="en-US"/>
+    </a:defPPr>
+    <a:lvl1pPr marL="0" algn="l" defTabSz="914400" rtl="0" eaLnBrk="1" latinLnBrk="0" hangingPunct="1">
+      <a:defRPr sz="1800" kern="1200">
+        <a:solidFill>
+          <a:schemeClr val="tx1"/>
+        </a:solidFill>
+        <a:latin typeface="+mn-lt"/>
+        <a:ea typeface="+mn-ea"/>
+        <a:cs typeface="+mn-cs"/>
+      </a:defRPr>
+    </a:lvl1pPr>
+    <a:lvl2pPr marL="457200" algn="l" defTabSz="914400" rtl="0" eaLnBrk="1" latinLnBrk="0" hangingPunct="1">
+      <a:defRPr sz="1800" kern="1200">
+        <a:solidFill>
+          <a:schemeClr val="tx1"/>
+        </a:solidFill>
+        <a:latin typeface="+mn-lt"/>
+        <a:ea typeface="+mn-ea"/>
+        <a:cs typeface="+mn-cs"/>
+      </a:defRPr>
+    </a:lvl2pPr>
+    <a:lvl3pPr marL="914400" algn="l" defTabSz="914400" rtl="0" eaLnBrk="1" latinLnBrk="0" hangingPunct="1">
+      <a:defRPr sz="1800" kern="1200">
+        <a:solidFill>
+          <a:schemeClr val="tx1"/>
+        </a:solidFill>
+        <a:latin typeface="+mn-lt"/>
+        <a:ea typeface="+mn-ea"/>
+        <a:cs typeface="+mn-cs"/>
+      </a:defRPr>
+    </a:lvl3pPr>
+    <a:lvl4pPr marL="1371600" algn="l" defTabSz="914400" rtl="0" eaLnBrk="1" latinLnBrk="0" hangingPunct="1">
+      <a:defRPr sz="1800" kern="1200">
+        <a:solidFill>
+          <a:schemeClr val="tx1"/>
+        </a:solidFill>
+        <a:latin typeface="+mn-lt"/>
+        <a:ea typeface="+mn-ea"/>
+        <a:cs typeface="+mn-cs"/>
+      </a:defRPr>
+    </a:lvl4pPr>
+    <a:lvl5pPr marL="1828800" algn="l" defTabSz="914400" rtl="0" eaLnBrk="1" latinLnBrk="0" hangingPunct="1">
+      <a:defRPr sz="1800" kern="1200">
+        <a:solidFill>
+          <a:schemeClr val="tx1"/>
+        </a:solidFill>
+        <a:latin typeface="+mn-lt"/>
+        <a:ea typeface="+mn-ea"/>
+        <a:cs typeface="+mn-cs"/>
+      </a:defRPr>
+    </a:lvl5pPr>
+    <a:lvl6pPr marL="2286000" algn="l" defTabSz="914400" rtl="0" eaLnBrk="1" latinLnBrk="0" hangingPunct="1">
+      <a:defRPr sz="1800" kern="1200">
+        <a:solidFill>
+          <a:schemeClr val="tx1"/>
+        </a:solidFill>
+        <a:latin typeface="+mn-lt"/>
+        <a:ea typeface="+mn-ea"/>
+        <a:cs typeface="+mn-cs"/>
+      </a:defRPr>
+    </a:lvl6pPr>
+    <a:lvl7pPr marL="2743200" algn="l" defTabSz="914400" rtl="0" eaLnBrk="1" latinLnBrk="0" hangingPunct="1">
+      <a:defRPr sz="1800" kern="1200">
+        <a:solidFill>
+          <a:schemeClr val="tx1"/>
+        </a:solidFill>
+        <a:latin typeface="+mn-lt"/>
+        <a:ea typeface="+mn-ea"/>
+        <a:cs typeface="+mn-cs"/>
+      </a:defRPr>
+    </a:lvl7pPr>
+    <a:lvl8pPr marL="3200400" algn="l" defTabSz="914400" rtl="0" eaLnBrk="1" latinLnBrk="0" hangingPunct="1">
+      <a:defRPr sz="1800" kern="1200">
+        <a:solidFill>
+          <a:schemeClr val="tx1"/>
+        </a:solidFill>
+        <a:latin typeface="+mn-lt"/>
+        <a:ea typeface="+mn-ea"/>
+        <a:cs typeface="+mn-cs"/>
+      </a:defRPr>
+    </a:lvl8pPr>
+    <a:lvl9pPr marL="3657600" algn="l" defTabSz="914400" rtl="0" eaLnBrk="1" latinLnBrk="0" hangingPunct="1">
+      <a:defRPr sz="1800" kern="1200">
+        <a:solidFill>
+          <a:schemeClr val="tx1"/>
+        </a:solidFill>
+        <a:latin typeface="+mn-lt"/>
+        <a:ea typeface="+mn-ea"/>
+        <a:cs typeface="+mn-cs"/>
+      </a:defRPr>
+    </a:lvl9pPr>
+  </p:defaultTextStyle>
 </p:presentation>
 </file>
 
 <file path=ppt/notesMasters/notesMaster1.xml><?xml version="1.0" encoding="utf-8"?>
-<p:notesMaster xmlns:p="http://schemas.openxmlformats.org/presentationml/2006/main">
+<p:notesMaster xmlns:a="http://schemas.openxmlformats.org/drawingml/2006/main" xmlns:r="http://schemas.openxmlformats.org/officeDocument/2006/relationships" xmlns:p="http://schemas.openxmlformats.org/presentationml/2006/main">
   <p:cSld>
     <p:bg>
       <p:bgRef idx="1001">
-        <a:schemeClr xmlns:a="http://schemas.openxmlformats.org/drawingml/2006/main" val="bg1"/>
+        <a:schemeClr val="bg1"/>
       </p:bgRef>
     </p:bg>
     <p:spTree>
@@ -35,380 +131,164 @@
         <p:nvPr/>
       </p:nvGrpSpPr>
       <p:grpSpPr>
-        <a:xfrm xmlns:a="http://schemas.openxmlformats.org/drawingml/2006/main"/>
+        <a:xfrm>
+          <a:off x="0" y="0"/>
+          <a:ext cx="0" cy="0"/>
+          <a:chOff x="0" y="0"/>
+          <a:chExt cx="0" cy="0"/>
+        </a:xfrm>
       </p:grpSpPr>
       <p:sp>
         <p:nvSpPr>
           <p:cNvPr id="2" name="Header Placeholder"/>
-          <p:cNvSpPr/>
+          <p:cNvSpPr>
+            <a:spLocks noGrp="1"/>
+          </p:cNvSpPr>
           <p:nvPr>
             <p:ph type="hdr" sz="quarter"/>
           </p:nvPr>
         </p:nvSpPr>
         <p:spPr>
-          <a:prstGeom xmlns:a="http://schemas.openxmlformats.org/drawingml/2006/main" prst="rect">
+          <a:prstGeom prst="rect">
             <a:avLst/>
           </a:prstGeom>
         </p:spPr>
         <p:txBody>
-          <a:bodyPr xmlns:a="http://schemas.openxmlformats.org/drawingml/2006/main"/>
-          <a:lstStyle xmlns:a="http://schemas.openxmlformats.org/drawingml/2006/main"/>
-          <a:p xmlns:a="http://schemas.openxmlformats.org/drawingml/2006/main"/>
+          <a:bodyPr/>
+          <a:lstStyle/>
+          <a:p>
+            <a:endParaRPr/>
+          </a:p>
         </p:txBody>
       </p:sp>
       <p:sp>
         <p:nvSpPr>
           <p:cNvPr id="3" name="Date Placeholder"/>
-          <p:cNvSpPr/>
+          <p:cNvSpPr>
+            <a:spLocks noGrp="1"/>
+          </p:cNvSpPr>
           <p:nvPr>
             <p:ph type="dt" sz="quarter" idx="1"/>
           </p:nvPr>
         </p:nvSpPr>
         <p:spPr>
-          <a:prstGeom xmlns:a="http://schemas.openxmlformats.org/drawingml/2006/main" prst="rect">
+          <a:prstGeom prst="rect">
             <a:avLst/>
           </a:prstGeom>
         </p:spPr>
         <p:txBody>
-          <a:bodyPr xmlns:a="http://schemas.openxmlformats.org/drawingml/2006/main"/>
-          <a:lstStyle xmlns:a="http://schemas.openxmlformats.org/drawingml/2006/main"/>
-          <a:p xmlns:a="http://schemas.openxmlformats.org/drawingml/2006/main"/>
+          <a:bodyPr/>
+          <a:lstStyle/>
+          <a:p>
+            <a:endParaRPr/>
+          </a:p>
         </p:txBody>
       </p:sp>
       <p:sp>
         <p:nvSpPr>
           <p:cNvPr id="4" name="Slide Image Placeholder"/>
-          <p:cNvSpPr/>
+          <p:cNvSpPr>
+            <a:spLocks noGrp="1" noRot="1" noChangeAspect="1"/>
+          </p:cNvSpPr>
           <p:nvPr>
             <p:ph type="sldImg" idx="2"/>
           </p:nvPr>
         </p:nvSpPr>
         <p:spPr>
-          <a:prstGeom xmlns:a="http://schemas.openxmlformats.org/drawingml/2006/main" prst="rect">
+          <a:prstGeom prst="rect">
             <a:avLst/>
           </a:prstGeom>
         </p:spPr>
         <p:txBody>
-          <a:bodyPr xmlns:a="http://schemas.openxmlformats.org/drawingml/2006/main"/>
-          <a:lstStyle xmlns:a="http://schemas.openxmlformats.org/drawingml/2006/main"/>
-          <a:p xmlns:a="http://schemas.openxmlformats.org/drawingml/2006/main"/>
+          <a:bodyPr/>
+          <a:lstStyle/>
+          <a:p>
+            <a:endParaRPr/>
+          </a:p>
         </p:txBody>
       </p:sp>
       <p:sp>
         <p:nvSpPr>
           <p:cNvPr id="5" name="Notes Placeholder"/>
-          <p:cNvSpPr/>
+          <p:cNvSpPr>
+            <a:spLocks noGrp="1"/>
+          </p:cNvSpPr>
           <p:nvPr>
             <p:ph type="body" sz="quarter" idx="3"/>
           </p:nvPr>
         </p:nvSpPr>
         <p:spPr>
-          <a:prstGeom xmlns:a="http://schemas.openxmlformats.org/drawingml/2006/main" prst="rect">
+          <a:prstGeom prst="rect">
             <a:avLst/>
           </a:prstGeom>
         </p:spPr>
         <p:txBody>
-          <a:bodyPr xmlns:a="http://schemas.openxmlformats.org/drawingml/2006/main"/>
-          <a:lstStyle xmlns:a="http://schemas.openxmlformats.org/drawingml/2006/main"/>
-          <a:p xmlns:a="http://schemas.openxmlformats.org/drawingml/2006/main"/>
+          <a:bodyPr/>
+          <a:lstStyle/>
+          <a:p>
+            <a:endParaRPr/>
+          </a:p>
         </p:txBody>
       </p:sp>
       <p:sp>
         <p:nvSpPr>
           <p:cNvPr id="6" name="Footer Placeholder"/>
-          <p:cNvSpPr/>
+          <p:cNvSpPr>
+            <a:spLocks noGrp="1"/>
+          </p:cNvSpPr>
           <p:nvPr>
             <p:ph type="ftr" sz="quarter" idx="4"/>
           </p:nvPr>
         </p:nvSpPr>
         <p:spPr>
-          <a:prstGeom xmlns:a="http://schemas.openxmlformats.org/drawingml/2006/main" prst="rect">
+          <a:prstGeom prst="rect">
             <a:avLst/>
           </a:prstGeom>
         </p:spPr>
         <p:txBody>
-          <a:bodyPr xmlns:a="http://schemas.openxmlformats.org/drawingml/2006/main"/>
-          <a:lstStyle xmlns:a="http://schemas.openxmlformats.org/drawingml/2006/main"/>
-          <a:p xmlns:a="http://schemas.openxmlformats.org/drawingml/2006/main"/>
+          <a:bodyPr/>
+          <a:lstStyle/>
+          <a:p>
+            <a:endParaRPr/>
+          </a:p>
         </p:txBody>
       </p:sp>
       <p:sp>
         <p:nvSpPr>
           <p:cNvPr id="7" name="Slide Number Placeholder"/>
-          <p:cNvSpPr/>
+          <p:cNvSpPr>
+            <a:spLocks noGrp="1"/>
+          </p:cNvSpPr>
           <p:nvPr>
             <p:ph type="sldNum" sz="quarter" idx="5"/>
           </p:nvPr>
         </p:nvSpPr>
         <p:spPr>
-          <a:prstGeom xmlns:a="http://schemas.openxmlformats.org/drawingml/2006/main" prst="rect">
+          <a:prstGeom prst="rect">
             <a:avLst/>
           </a:prstGeom>
         </p:spPr>
         <p:txBody>
-          <a:bodyPr xmlns:a="http://schemas.openxmlformats.org/drawingml/2006/main"/>
-          <a:lstStyle xmlns:a="http://schemas.openxmlformats.org/drawingml/2006/main"/>
-          <a:p xmlns:a="http://schemas.openxmlformats.org/drawingml/2006/main"/>
+          <a:bodyPr/>
+          <a:lstStyle/>
+          <a:p>
+            <a:endParaRPr/>
+          </a:p>
         </p:txBody>
       </p:sp>
     </p:spTree>
   </p:cSld>
   <p:clrMap bg1="lt1" tx1="dk1" bg2="lt2" tx2="dk2" accent1="accent1" accent2="accent2" accent3="accent3" accent4="accent4" accent5="accent5" accent6="accent6" hlink="hlink" folHlink="folHlink"/>
   <p:notesStyle>
-    <a:lvl1pPr xmlns:a="http://schemas.openxmlformats.org/drawingml/2006/main" marL="0" algn="l" defTabSz="914400" rtl="0" eaLnBrk="1" latinLnBrk="0" hangingPunct="1">
+    <a:lvl1pPr marL="0" algn="l" defTabSz="914400" rtl="0" eaLnBrk="1" latinLnBrk="0" hangingPunct="1">
       <a:defRPr sz="1200" kern="1200"/>
     </a:lvl1pPr>
   </p:notesStyle>
 </p:notesMaster>
 </file>
 
-<file path=ppt/notesMasters/theme/theme3.xml><?xml version="1.0" encoding="utf-8"?>
-<a:theme xmlns:a="http://schemas.openxmlformats.org/drawingml/2006/main" name="ChatGPT">
-  <a:themeElements>
-    <a:clrScheme name="ChatGPT">
-      <a:dk1>
-        <a:srgbClr val="000000"/>
-      </a:dk1>
-      <a:lt1>
-        <a:srgbClr val="FFFFFF"/>
-      </a:lt1>
-      <a:dk2>
-        <a:srgbClr val="0E2841"/>
-      </a:dk2>
-      <a:lt2>
-        <a:srgbClr val="E8E8E8"/>
-      </a:lt2>
-      <a:accent1>
-        <a:srgbClr val="156082"/>
-      </a:accent1>
-      <a:accent2>
-        <a:srgbClr val="E97132"/>
-      </a:accent2>
-      <a:accent3>
-        <a:srgbClr val="196B24"/>
-      </a:accent3>
-      <a:accent4>
-        <a:srgbClr val="0F9ED5"/>
-      </a:accent4>
-      <a:accent5>
-        <a:srgbClr val="A02B93"/>
-      </a:accent5>
-      <a:accent6>
-        <a:srgbClr val="4EA72E"/>
-      </a:accent6>
-      <a:hlink>
-        <a:srgbClr val="467886"/>
-      </a:hlink>
-      <a:folHlink>
-        <a:srgbClr val="96607D"/>
-      </a:folHlink>
-    </a:clrScheme>
-    <a:fontScheme name="Office">
-      <a:majorFont>
-        <a:latin typeface="Calibri Light"/>
-        <a:ea typeface="Calibri Light"/>
-        <a:cs typeface="Calibri Light"/>
-      </a:majorFont>
-      <a:minorFont>
-        <a:latin typeface="Calibri"/>
-        <a:ea typeface="Calibri"/>
-        <a:cs typeface="Calibri"/>
-      </a:minorFont>
-    </a:fontScheme>
-    <a:fmtScheme name="ChatGPT">
-      <a:fillStyleLst>
-        <a:solidFill>
-          <a:schemeClr val="phClr"/>
-        </a:solidFill>
-        <a:gradFill>
-          <a:gsLst>
-            <a:gs pos="0">
-              <a:schemeClr val="phClr">
-                <a:tint val="67000"/>
-                <a:lumMod val="110000"/>
-                <a:satMod val="105000"/>
-              </a:schemeClr>
-            </a:gs>
-            <a:gs pos="50000">
-              <a:schemeClr val="phClr">
-                <a:tint val="73000"/>
-                <a:lumMod val="105000"/>
-                <a:satMod val="103000"/>
-              </a:schemeClr>
-            </a:gs>
-            <a:gs pos="100000">
-              <a:schemeClr val="phClr">
-                <a:tint val="81000"/>
-                <a:lumMod val="105000"/>
-                <a:satMod val="109000"/>
-              </a:schemeClr>
-            </a:gs>
-          </a:gsLst>
-          <a:lin ang="5400000" scaled="0"/>
-        </a:gradFill>
-        <a:gradFill>
-          <a:gsLst>
-            <a:gs pos="0">
-              <a:schemeClr val="phClr">
-                <a:tint val="94000"/>
-                <a:lumMod val="102000"/>
-                <a:satMod val="103000"/>
-              </a:schemeClr>
-            </a:gs>
-            <a:gs pos="50000">
-              <a:schemeClr val="phClr">
-                <a:shade val="100000"/>
-                <a:lumMod val="100000"/>
-                <a:satMod val="110000"/>
-              </a:schemeClr>
-            </a:gs>
-            <a:gs pos="100000">
-              <a:schemeClr val="phClr">
-                <a:shade val="78000"/>
-                <a:lumMod val="99000"/>
-                <a:satMod val="120000"/>
-              </a:schemeClr>
-            </a:gs>
-          </a:gsLst>
-          <a:lin ang="5400000" scaled="0"/>
-        </a:gradFill>
-      </a:fillStyleLst>
-      <a:lnStyleLst>
-        <a:ln w="12700">
-          <a:solidFill>
-            <a:schemeClr val="phClr"/>
-          </a:solidFill>
-          <a:prstDash val="solid"/>
-        </a:ln>
-        <a:ln w="19050">
-          <a:solidFill>
-            <a:schemeClr val="phClr"/>
-          </a:solidFill>
-          <a:prstDash val="solid"/>
-        </a:ln>
-        <a:ln w="25400">
-          <a:solidFill>
-            <a:schemeClr val="phClr"/>
-          </a:solidFill>
-          <a:prstDash val="solid"/>
-        </a:ln>
-      </a:lnStyleLst>
-      <a:effectStyleLst>
-        <a:effectStyle>
-          <a:effectLst/>
-        </a:effectStyle>
-        <a:effectStyle>
-          <a:effectLst/>
-        </a:effectStyle>
-        <a:effectStyle>
-          <a:effectLst>
-            <a:outerShdw blurRad="57150" dist="19050" dir="5400000">
-              <a:srgbClr val="000000">
-                <a:alpha val="16000"/>
-              </a:srgbClr>
-            </a:outerShdw>
-          </a:effectLst>
-        </a:effectStyle>
-        <a:effectStyle>
-          <a:effectLst>
-            <a:outerShdw blurRad="19050" dist="9525" dir="5400000">
-              <a:srgbClr val="000000">
-                <a:alpha val="6000"/>
-              </a:srgbClr>
-            </a:outerShdw>
-          </a:effectLst>
-        </a:effectStyle>
-        <a:effectStyle>
-          <a:effectLst>
-            <a:outerShdw blurRad="28575" dist="9525" dir="5400000">
-              <a:srgbClr val="000000">
-                <a:alpha val="8000"/>
-              </a:srgbClr>
-            </a:outerShdw>
-          </a:effectLst>
-        </a:effectStyle>
-        <a:effectStyle>
-          <a:effectLst>
-            <a:outerShdw blurRad="57150" dist="19050" dir="5400000">
-              <a:srgbClr val="000000">
-                <a:alpha val="10000"/>
-              </a:srgbClr>
-            </a:outerShdw>
-          </a:effectLst>
-        </a:effectStyle>
-        <a:effectStyle>
-          <a:effectLst>
-            <a:outerShdw blurRad="114300" dist="38100" dir="5400000">
-              <a:srgbClr val="000000">
-                <a:alpha val="12000"/>
-              </a:srgbClr>
-            </a:outerShdw>
-          </a:effectLst>
-        </a:effectStyle>
-        <a:effectStyle>
-          <a:effectLst>
-            <a:outerShdw blurRad="171450" dist="57150" dir="5400000">
-              <a:srgbClr val="000000">
-                <a:alpha val="16000"/>
-              </a:srgbClr>
-            </a:outerShdw>
-          </a:effectLst>
-        </a:effectStyle>
-        <a:effectStyle>
-          <a:effectLst>
-            <a:outerShdw blurRad="266700" dist="95250" dir="5400000">
-              <a:srgbClr val="000000">
-                <a:alpha val="24000"/>
-              </a:srgbClr>
-            </a:outerShdw>
-          </a:effectLst>
-        </a:effectStyle>
-      </a:effectStyleLst>
-      <a:bgFillStyleLst>
-        <a:solidFill>
-          <a:schemeClr val="phClr"/>
-        </a:solidFill>
-        <a:solidFill>
-          <a:schemeClr val="phClr">
-            <a:tint val="95000"/>
-            <a:satMod val="170000"/>
-          </a:schemeClr>
-        </a:solidFill>
-        <a:gradFill>
-          <a:gsLst>
-            <a:gs pos="0">
-              <a:schemeClr val="phClr">
-                <a:tint val="93000"/>
-                <a:shade val="98000"/>
-                <a:lumMod val="102000"/>
-                <a:satMod val="150000"/>
-              </a:schemeClr>
-            </a:gs>
-            <a:gs pos="50000">
-              <a:schemeClr val="phClr">
-                <a:tint val="98000"/>
-                <a:shade val="90000"/>
-                <a:lumMod val="103000"/>
-                <a:satMod val="130000"/>
-              </a:schemeClr>
-            </a:gs>
-            <a:gs pos="100000">
-              <a:schemeClr val="phClr">
-                <a:shade val="63000"/>
-                <a:satMod val="120000"/>
-              </a:schemeClr>
-            </a:gs>
-          </a:gsLst>
-          <a:lin ang="5400000" scaled="0"/>
-        </a:gradFill>
-      </a:bgFillStyleLst>
-    </a:fmtScheme>
-  </a:themeElements>
-</a:theme>
-</file>
-
 <file path=ppt/notesSlides/notesSlide1.xml><?xml version="1.0" encoding="utf-8"?>
-<p:notes xmlns:p="http://schemas.openxmlformats.org/presentationml/2006/main">
+<p:notes xmlns:a="http://schemas.openxmlformats.org/drawingml/2006/main" xmlns:r="http://schemas.openxmlformats.org/officeDocument/2006/relationships" xmlns:p="http://schemas.openxmlformats.org/presentationml/2006/main">
   <p:cSld>
     <p:spTree>
       <p:nvGrpSpPr>
@@ -417,16 +297,21 @@
         <p:nvPr/>
       </p:nvGrpSpPr>
       <p:grpSpPr>
-        <a:xfrm xmlns:a="http://schemas.openxmlformats.org/drawingml/2006/main"/>
+        <a:xfrm>
+          <a:off x="0" y="0"/>
+          <a:ext cx="0" cy="0"/>
+          <a:chOff x="0" y="0"/>
+          <a:chExt cx="0" cy="0"/>
+        </a:xfrm>
       </p:grpSpPr>
       <p:sp>
         <p:nvSpPr>
           <p:cNvPr id="2" name="Slide Image Placeholder 1"/>
           <p:cNvSpPr>
-            <a:spLocks xmlns:a="http://schemas.openxmlformats.org/drawingml/2006/main" noGrp="1"/>
+            <a:spLocks noGrp="1" noRot="1" noChangeAspect="1"/>
           </p:cNvSpPr>
           <p:nvPr>
-            <p:ph type="sldImg" idx="0"/>
+            <p:ph type="sldImg"/>
           </p:nvPr>
         </p:nvSpPr>
         <p:spPr/>
@@ -435,7 +320,7 @@
         <p:nvSpPr>
           <p:cNvPr id="3" name="Notes Placeholder 2"/>
           <p:cNvSpPr>
-            <a:spLocks xmlns:a="http://schemas.openxmlformats.org/drawingml/2006/main" noGrp="1"/>
+            <a:spLocks noGrp="1"/>
           </p:cNvSpPr>
           <p:nvPr>
             <p:ph type="body" idx="1"/>
@@ -443,29 +328,25 @@
         </p:nvSpPr>
         <p:spPr/>
         <p:txBody>
-          <a:bodyPr xmlns:a="http://schemas.openxmlformats.org/drawingml/2006/main"/>
-          <a:lstStyle xmlns:a="http://schemas.openxmlformats.org/drawingml/2006/main"/>
-          <a:p xmlns:a="http://schemas.openxmlformats.org/drawingml/2006/main">
+          <a:bodyPr/>
+          <a:lstStyle/>
+          <a:p>
             <a:r>
               <a:t>Good morning, everyone. Today I’m presenting my capstone project, AIOps Guardian Pro, an AI-assisted investigation platform for SRE and cloud operations teams.</a:t>
             </a:r>
           </a:p>
-          <a:p xmlns:a="http://schemas.openxmlformats.org/drawingml/2006/main">
-            <a:r>
-              <a:t/>
-            </a:r>
-          </a:p>
-          <a:p xmlns:a="http://schemas.openxmlformats.org/drawingml/2006/main">
+          <a:p>
+            <a:endParaRPr/>
+          </a:p>
+          <a:p>
             <a:r>
               <a:t>The project grew beyond my initial scope, but I kept the additional components to demonstrate a realistic SRE workflow. I’ll briefly cover the use case, technology stack, architecture, and a demo.</a:t>
             </a:r>
           </a:p>
-          <a:p xmlns:a="http://schemas.openxmlformats.org/drawingml/2006/main">
-            <a:r>
-              <a:t/>
-            </a:r>
-          </a:p>
-          <a:p xmlns:a="http://schemas.openxmlformats.org/drawingml/2006/main">
+          <a:p>
+            <a:endParaRPr/>
+          </a:p>
+          <a:p>
             <a:r>
               <a:t>Source: Presenter-provided shortened capstone script.</a:t>
             </a:r>
@@ -476,7 +357,7 @@
         <p:nvSpPr>
           <p:cNvPr id="4" name="Slide Number Placeholder 3"/>
           <p:cNvSpPr>
-            <a:spLocks xmlns:a="http://schemas.openxmlformats.org/drawingml/2006/main" noGrp="1"/>
+            <a:spLocks noGrp="1"/>
           </p:cNvSpPr>
           <p:nvPr>
             <p:ph type="sldNum" idx="5"/>
@@ -484,21 +365,23 @@
         </p:nvSpPr>
         <p:spPr/>
         <p:txBody>
-          <a:bodyPr xmlns:a="http://schemas.openxmlformats.org/drawingml/2006/main"/>
-          <a:lstStyle xmlns:a="http://schemas.openxmlformats.org/drawingml/2006/main"/>
-          <a:p xmlns:a="http://schemas.openxmlformats.org/drawingml/2006/main"/>
+          <a:bodyPr/>
+          <a:lstStyle/>
+          <a:p>
+            <a:endParaRPr/>
+          </a:p>
         </p:txBody>
       </p:sp>
     </p:spTree>
   </p:cSld>
   <p:clrMapOvr>
-    <a:masterClrMapping xmlns:a="http://schemas.openxmlformats.org/drawingml/2006/main"/>
+    <a:masterClrMapping/>
   </p:clrMapOvr>
 </p:notes>
 </file>
 
 <file path=ppt/notesSlides/notesSlide2.xml><?xml version="1.0" encoding="utf-8"?>
-<p:notes xmlns:p="http://schemas.openxmlformats.org/presentationml/2006/main">
+<p:notes xmlns:a="http://schemas.openxmlformats.org/drawingml/2006/main" xmlns:r="http://schemas.openxmlformats.org/officeDocument/2006/relationships" xmlns:p="http://schemas.openxmlformats.org/presentationml/2006/main">
   <p:cSld>
     <p:spTree>
       <p:nvGrpSpPr>
@@ -507,16 +390,21 @@
         <p:nvPr/>
       </p:nvGrpSpPr>
       <p:grpSpPr>
-        <a:xfrm xmlns:a="http://schemas.openxmlformats.org/drawingml/2006/main"/>
+        <a:xfrm>
+          <a:off x="0" y="0"/>
+          <a:ext cx="0" cy="0"/>
+          <a:chOff x="0" y="0"/>
+          <a:chExt cx="0" cy="0"/>
+        </a:xfrm>
       </p:grpSpPr>
       <p:sp>
         <p:nvSpPr>
           <p:cNvPr id="2" name="Slide Image Placeholder 1"/>
           <p:cNvSpPr>
-            <a:spLocks xmlns:a="http://schemas.openxmlformats.org/drawingml/2006/main" noGrp="1"/>
+            <a:spLocks noGrp="1" noRot="1" noChangeAspect="1"/>
           </p:cNvSpPr>
           <p:nvPr>
-            <p:ph type="sldImg" idx="0"/>
+            <p:ph type="sldImg"/>
           </p:nvPr>
         </p:nvSpPr>
         <p:spPr/>
@@ -525,7 +413,7 @@
         <p:nvSpPr>
           <p:cNvPr id="3" name="Notes Placeholder 2"/>
           <p:cNvSpPr>
-            <a:spLocks xmlns:a="http://schemas.openxmlformats.org/drawingml/2006/main" noGrp="1"/>
+            <a:spLocks noGrp="1"/>
           </p:cNvSpPr>
           <p:nvPr>
             <p:ph type="body" idx="1"/>
@@ -533,29 +421,25 @@
         </p:nvSpPr>
         <p:spPr/>
         <p:txBody>
-          <a:bodyPr xmlns:a="http://schemas.openxmlformats.org/drawingml/2006/main"/>
-          <a:lstStyle xmlns:a="http://schemas.openxmlformats.org/drawingml/2006/main"/>
-          <a:p xmlns:a="http://schemas.openxmlformats.org/drawingml/2006/main">
+          <a:bodyPr/>
+          <a:lstStyle/>
+          <a:p>
             <a:r>
               <a:t>Imagine an on-call engineer receives an alert that checkout requests are failing after a deployment. Finding the cause requires gathering evidence from metrics, logs, deployment history, and runbooks.</a:t>
             </a:r>
           </a:p>
-          <a:p xmlns:a="http://schemas.openxmlformats.org/drawingml/2006/main">
-            <a:r>
-              <a:t/>
-            </a:r>
-          </a:p>
-          <a:p xmlns:a="http://schemas.openxmlformats.org/drawingml/2006/main">
+          <a:p>
+            <a:endParaRPr/>
+          </a:p>
+          <a:p>
             <a:r>
               <a:t>I designed Guardian to support that investigation through a conversational interface. It reviews available evidence, asks clarifying questions, and suggests the next useful check.</a:t>
             </a:r>
           </a:p>
-          <a:p xmlns:a="http://schemas.openxmlformats.org/drawingml/2006/main">
-            <a:r>
-              <a:t/>
-            </a:r>
-          </a:p>
-          <a:p xmlns:a="http://schemas.openxmlformats.org/drawingml/2006/main">
+          <a:p>
+            <a:endParaRPr/>
+          </a:p>
+          <a:p>
             <a:r>
               <a:t>Source: Presenter-provided shortened capstone script.</a:t>
             </a:r>
@@ -566,7 +450,7 @@
         <p:nvSpPr>
           <p:cNvPr id="4" name="Slide Number Placeholder 3"/>
           <p:cNvSpPr>
-            <a:spLocks xmlns:a="http://schemas.openxmlformats.org/drawingml/2006/main" noGrp="1"/>
+            <a:spLocks noGrp="1"/>
           </p:cNvSpPr>
           <p:nvPr>
             <p:ph type="sldNum" idx="5"/>
@@ -574,21 +458,23 @@
         </p:nvSpPr>
         <p:spPr/>
         <p:txBody>
-          <a:bodyPr xmlns:a="http://schemas.openxmlformats.org/drawingml/2006/main"/>
-          <a:lstStyle xmlns:a="http://schemas.openxmlformats.org/drawingml/2006/main"/>
-          <a:p xmlns:a="http://schemas.openxmlformats.org/drawingml/2006/main"/>
+          <a:bodyPr/>
+          <a:lstStyle/>
+          <a:p>
+            <a:endParaRPr/>
+          </a:p>
         </p:txBody>
       </p:sp>
     </p:spTree>
   </p:cSld>
   <p:clrMapOvr>
-    <a:masterClrMapping xmlns:a="http://schemas.openxmlformats.org/drawingml/2006/main"/>
+    <a:masterClrMapping/>
   </p:clrMapOvr>
 </p:notes>
 </file>
 
 <file path=ppt/notesSlides/notesSlide3.xml><?xml version="1.0" encoding="utf-8"?>
-<p:notes xmlns:p="http://schemas.openxmlformats.org/presentationml/2006/main">
+<p:notes xmlns:a="http://schemas.openxmlformats.org/drawingml/2006/main" xmlns:r="http://schemas.openxmlformats.org/officeDocument/2006/relationships" xmlns:p="http://schemas.openxmlformats.org/presentationml/2006/main">
   <p:cSld>
     <p:spTree>
       <p:nvGrpSpPr>
@@ -597,16 +483,21 @@
         <p:nvPr/>
       </p:nvGrpSpPr>
       <p:grpSpPr>
-        <a:xfrm xmlns:a="http://schemas.openxmlformats.org/drawingml/2006/main"/>
+        <a:xfrm>
+          <a:off x="0" y="0"/>
+          <a:ext cx="0" cy="0"/>
+          <a:chOff x="0" y="0"/>
+          <a:chExt cx="0" cy="0"/>
+        </a:xfrm>
       </p:grpSpPr>
       <p:sp>
         <p:nvSpPr>
           <p:cNvPr id="2" name="Slide Image Placeholder 1"/>
           <p:cNvSpPr>
-            <a:spLocks xmlns:a="http://schemas.openxmlformats.org/drawingml/2006/main" noGrp="1"/>
+            <a:spLocks noGrp="1" noRot="1" noChangeAspect="1"/>
           </p:cNvSpPr>
           <p:nvPr>
-            <p:ph type="sldImg" idx="0"/>
+            <p:ph type="sldImg"/>
           </p:nvPr>
         </p:nvSpPr>
         <p:spPr/>
@@ -615,7 +506,7 @@
         <p:nvSpPr>
           <p:cNvPr id="3" name="Notes Placeholder 2"/>
           <p:cNvSpPr>
-            <a:spLocks xmlns:a="http://schemas.openxmlformats.org/drawingml/2006/main" noGrp="1"/>
+            <a:spLocks noGrp="1"/>
           </p:cNvSpPr>
           <p:nvPr>
             <p:ph type="body" idx="1"/>
@@ -623,29 +514,25 @@
         </p:nvSpPr>
         <p:spPr/>
         <p:txBody>
-          <a:bodyPr xmlns:a="http://schemas.openxmlformats.org/drawingml/2006/main"/>
-          <a:lstStyle xmlns:a="http://schemas.openxmlformats.org/drawingml/2006/main"/>
-          <a:p xmlns:a="http://schemas.openxmlformats.org/drawingml/2006/main">
+          <a:bodyPr/>
+          <a:lstStyle/>
+          <a:p>
             <a:r>
               <a:t>For the technology stack, I use React for the frontend and Python with FastAPI for the backend. LangGraph coordinates specialist agents, while MCP connects them to operational tools.</a:t>
             </a:r>
           </a:p>
-          <a:p xmlns:a="http://schemas.openxmlformats.org/drawingml/2006/main">
-            <a:r>
-              <a:t/>
-            </a:r>
-          </a:p>
-          <a:p xmlns:a="http://schemas.openxmlformats.org/drawingml/2006/main">
+          <a:p>
+            <a:endParaRPr/>
+          </a:p>
+          <a:p>
             <a:r>
               <a:t>PostgreSQL stores operational records and conversations, and FAISS supports knowledge retrieval. A local Qwen model through Ollama supports conversational reasoning. I use Prometheus and Grafana for monitoring and visualization, with the application running in Kubernetes.</a:t>
             </a:r>
           </a:p>
-          <a:p xmlns:a="http://schemas.openxmlformats.org/drawingml/2006/main">
-            <a:r>
-              <a:t/>
-            </a:r>
-          </a:p>
-          <a:p xmlns:a="http://schemas.openxmlformats.org/drawingml/2006/main">
+          <a:p>
+            <a:endParaRPr/>
+          </a:p>
+          <a:p>
             <a:r>
               <a:t>Source: Presenter-provided shortened capstone script.</a:t>
             </a:r>
@@ -656,7 +543,7 @@
         <p:nvSpPr>
           <p:cNvPr id="4" name="Slide Number Placeholder 3"/>
           <p:cNvSpPr>
-            <a:spLocks xmlns:a="http://schemas.openxmlformats.org/drawingml/2006/main" noGrp="1"/>
+            <a:spLocks noGrp="1"/>
           </p:cNvSpPr>
           <p:nvPr>
             <p:ph type="sldNum" idx="5"/>
@@ -664,21 +551,23 @@
         </p:nvSpPr>
         <p:spPr/>
         <p:txBody>
-          <a:bodyPr xmlns:a="http://schemas.openxmlformats.org/drawingml/2006/main"/>
-          <a:lstStyle xmlns:a="http://schemas.openxmlformats.org/drawingml/2006/main"/>
-          <a:p xmlns:a="http://schemas.openxmlformats.org/drawingml/2006/main"/>
+          <a:bodyPr/>
+          <a:lstStyle/>
+          <a:p>
+            <a:endParaRPr/>
+          </a:p>
         </p:txBody>
       </p:sp>
     </p:spTree>
   </p:cSld>
   <p:clrMapOvr>
-    <a:masterClrMapping xmlns:a="http://schemas.openxmlformats.org/drawingml/2006/main"/>
+    <a:masterClrMapping/>
   </p:clrMapOvr>
 </p:notes>
 </file>
 
 <file path=ppt/notesSlides/notesSlide4.xml><?xml version="1.0" encoding="utf-8"?>
-<p:notes xmlns:p="http://schemas.openxmlformats.org/presentationml/2006/main">
+<p:notes xmlns:a="http://schemas.openxmlformats.org/drawingml/2006/main" xmlns:r="http://schemas.openxmlformats.org/officeDocument/2006/relationships" xmlns:p="http://schemas.openxmlformats.org/presentationml/2006/main">
   <p:cSld>
     <p:spTree>
       <p:nvGrpSpPr>
@@ -687,16 +576,21 @@
         <p:nvPr/>
       </p:nvGrpSpPr>
       <p:grpSpPr>
-        <a:xfrm xmlns:a="http://schemas.openxmlformats.org/drawingml/2006/main"/>
+        <a:xfrm>
+          <a:off x="0" y="0"/>
+          <a:ext cx="0" cy="0"/>
+          <a:chOff x="0" y="0"/>
+          <a:chExt cx="0" cy="0"/>
+        </a:xfrm>
       </p:grpSpPr>
       <p:sp>
         <p:nvSpPr>
           <p:cNvPr id="2" name="Slide Image Placeholder 1"/>
           <p:cNvSpPr>
-            <a:spLocks xmlns:a="http://schemas.openxmlformats.org/drawingml/2006/main" noGrp="1"/>
+            <a:spLocks noGrp="1" noRot="1" noChangeAspect="1"/>
           </p:cNvSpPr>
           <p:nvPr>
-            <p:ph type="sldImg" idx="0"/>
+            <p:ph type="sldImg"/>
           </p:nvPr>
         </p:nvSpPr>
         <p:spPr/>
@@ -705,7 +599,7 @@
         <p:nvSpPr>
           <p:cNvPr id="3" name="Notes Placeholder 2"/>
           <p:cNvSpPr>
-            <a:spLocks xmlns:a="http://schemas.openxmlformats.org/drawingml/2006/main" noGrp="1"/>
+            <a:spLocks noGrp="1"/>
           </p:cNvSpPr>
           <p:nvPr>
             <p:ph type="body" idx="1"/>
@@ -713,29 +607,25 @@
         </p:nvSpPr>
         <p:spPr/>
         <p:txBody>
-          <a:bodyPr xmlns:a="http://schemas.openxmlformats.org/drawingml/2006/main"/>
-          <a:lstStyle xmlns:a="http://schemas.openxmlformats.org/drawingml/2006/main"/>
-          <a:p xmlns:a="http://schemas.openxmlformats.org/drawingml/2006/main">
+          <a:bodyPr/>
+          <a:lstStyle/>
+          <a:p>
             <a:r>
               <a:t>Architecturally, the flow starts with an engineer’s question. Guardian identifies the application and environment, gathers relevant evidence, and uses the conversation context to explain findings or request more information.</a:t>
             </a:r>
           </a:p>
-          <a:p xmlns:a="http://schemas.openxmlformats.org/drawingml/2006/main">
-            <a:r>
-              <a:t/>
-            </a:r>
-          </a:p>
-          <a:p xmlns:a="http://schemas.openxmlformats.org/drawingml/2006/main">
+          <a:p>
+            <a:endParaRPr/>
+          </a:p>
+          <a:p>
             <a:r>
               <a:t>[Pause briefly to trace the four stages.]</a:t>
             </a:r>
           </a:p>
-          <a:p xmlns:a="http://schemas.openxmlformats.org/drawingml/2006/main">
-            <a:r>
-              <a:t/>
-            </a:r>
-          </a:p>
-          <a:p xmlns:a="http://schemas.openxmlformats.org/drawingml/2006/main">
+          <a:p>
+            <a:endParaRPr/>
+          </a:p>
+          <a:p>
             <a:r>
               <a:t>Source: Presenter-provided shortened capstone script.</a:t>
             </a:r>
@@ -746,7 +636,7 @@
         <p:nvSpPr>
           <p:cNvPr id="4" name="Slide Number Placeholder 3"/>
           <p:cNvSpPr>
-            <a:spLocks xmlns:a="http://schemas.openxmlformats.org/drawingml/2006/main" noGrp="1"/>
+            <a:spLocks noGrp="1"/>
           </p:cNvSpPr>
           <p:nvPr>
             <p:ph type="sldNum" idx="5"/>
@@ -754,21 +644,23 @@
         </p:nvSpPr>
         <p:spPr/>
         <p:txBody>
-          <a:bodyPr xmlns:a="http://schemas.openxmlformats.org/drawingml/2006/main"/>
-          <a:lstStyle xmlns:a="http://schemas.openxmlformats.org/drawingml/2006/main"/>
-          <a:p xmlns:a="http://schemas.openxmlformats.org/drawingml/2006/main"/>
+          <a:bodyPr/>
+          <a:lstStyle/>
+          <a:p>
+            <a:endParaRPr/>
+          </a:p>
         </p:txBody>
       </p:sp>
     </p:spTree>
   </p:cSld>
   <p:clrMapOvr>
-    <a:masterClrMapping xmlns:a="http://schemas.openxmlformats.org/drawingml/2006/main"/>
+    <a:masterClrMapping/>
   </p:clrMapOvr>
 </p:notes>
 </file>
 
 <file path=ppt/notesSlides/notesSlide5.xml><?xml version="1.0" encoding="utf-8"?>
-<p:notes xmlns:p="http://schemas.openxmlformats.org/presentationml/2006/main">
+<p:notes xmlns:a="http://schemas.openxmlformats.org/drawingml/2006/main" xmlns:r="http://schemas.openxmlformats.org/officeDocument/2006/relationships" xmlns:p="http://schemas.openxmlformats.org/presentationml/2006/main">
   <p:cSld>
     <p:spTree>
       <p:nvGrpSpPr>
@@ -777,16 +669,21 @@
         <p:nvPr/>
       </p:nvGrpSpPr>
       <p:grpSpPr>
-        <a:xfrm xmlns:a="http://schemas.openxmlformats.org/drawingml/2006/main"/>
+        <a:xfrm>
+          <a:off x="0" y="0"/>
+          <a:ext cx="0" cy="0"/>
+          <a:chOff x="0" y="0"/>
+          <a:chExt cx="0" cy="0"/>
+        </a:xfrm>
       </p:grpSpPr>
       <p:sp>
         <p:nvSpPr>
           <p:cNvPr id="2" name="Slide Image Placeholder 1"/>
           <p:cNvSpPr>
-            <a:spLocks xmlns:a="http://schemas.openxmlformats.org/drawingml/2006/main" noGrp="1"/>
+            <a:spLocks noGrp="1" noRot="1" noChangeAspect="1"/>
           </p:cNvSpPr>
           <p:nvPr>
-            <p:ph type="sldImg" idx="0"/>
+            <p:ph type="sldImg"/>
           </p:nvPr>
         </p:nvSpPr>
         <p:spPr/>
@@ -795,7 +692,7 @@
         <p:nvSpPr>
           <p:cNvPr id="3" name="Notes Placeholder 2"/>
           <p:cNvSpPr>
-            <a:spLocks xmlns:a="http://schemas.openxmlformats.org/drawingml/2006/main" noGrp="1"/>
+            <a:spLocks noGrp="1"/>
           </p:cNvSpPr>
           <p:nvPr>
             <p:ph type="body" idx="1"/>
@@ -803,29 +700,25 @@
         </p:nvSpPr>
         <p:spPr/>
         <p:txBody>
-          <a:bodyPr xmlns:a="http://schemas.openxmlformats.org/drawingml/2006/main"/>
-          <a:lstStyle xmlns:a="http://schemas.openxmlformats.org/drawingml/2006/main"/>
-          <a:p xmlns:a="http://schemas.openxmlformats.org/drawingml/2006/main">
+          <a:bodyPr/>
+          <a:lstStyle/>
+          <a:p>
             <a:r>
               <a:t>I kept the guardrail layer separate from the reasoning layer. The model can recommend an action, but risky changes require human approval. Any executed action must also be verified and recorded.</a:t>
             </a:r>
           </a:p>
-          <a:p xmlns:a="http://schemas.openxmlformats.org/drawingml/2006/main">
-            <a:r>
-              <a:t/>
-            </a:r>
-          </a:p>
-          <a:p xmlns:a="http://schemas.openxmlformats.org/drawingml/2006/main">
+          <a:p>
+            <a:endParaRPr/>
+          </a:p>
+          <a:p>
             <a:r>
               <a:t>[If showing the approval queue, explain that a request does not mean execution.]</a:t>
             </a:r>
           </a:p>
-          <a:p xmlns:a="http://schemas.openxmlformats.org/drawingml/2006/main">
-            <a:r>
-              <a:t/>
-            </a:r>
-          </a:p>
-          <a:p xmlns:a="http://schemas.openxmlformats.org/drawingml/2006/main">
+          <a:p>
+            <a:endParaRPr/>
+          </a:p>
+          <a:p>
             <a:r>
               <a:t>Source: Presenter-provided shortened capstone script.</a:t>
             </a:r>
@@ -836,7 +729,7 @@
         <p:nvSpPr>
           <p:cNvPr id="4" name="Slide Number Placeholder 3"/>
           <p:cNvSpPr>
-            <a:spLocks xmlns:a="http://schemas.openxmlformats.org/drawingml/2006/main" noGrp="1"/>
+            <a:spLocks noGrp="1"/>
           </p:cNvSpPr>
           <p:nvPr>
             <p:ph type="sldNum" idx="5"/>
@@ -844,21 +737,23 @@
         </p:nvSpPr>
         <p:spPr/>
         <p:txBody>
-          <a:bodyPr xmlns:a="http://schemas.openxmlformats.org/drawingml/2006/main"/>
-          <a:lstStyle xmlns:a="http://schemas.openxmlformats.org/drawingml/2006/main"/>
-          <a:p xmlns:a="http://schemas.openxmlformats.org/drawingml/2006/main"/>
+          <a:bodyPr/>
+          <a:lstStyle/>
+          <a:p>
+            <a:endParaRPr/>
+          </a:p>
         </p:txBody>
       </p:sp>
     </p:spTree>
   </p:cSld>
   <p:clrMapOvr>
-    <a:masterClrMapping xmlns:a="http://schemas.openxmlformats.org/drawingml/2006/main"/>
+    <a:masterClrMapping/>
   </p:clrMapOvr>
 </p:notes>
 </file>
 
 <file path=ppt/notesSlides/notesSlide6.xml><?xml version="1.0" encoding="utf-8"?>
-<p:notes xmlns:p="http://schemas.openxmlformats.org/presentationml/2006/main">
+<p:notes xmlns:a="http://schemas.openxmlformats.org/drawingml/2006/main" xmlns:r="http://schemas.openxmlformats.org/officeDocument/2006/relationships" xmlns:p="http://schemas.openxmlformats.org/presentationml/2006/main">
   <p:cSld>
     <p:spTree>
       <p:nvGrpSpPr>
@@ -867,16 +762,21 @@
         <p:nvPr/>
       </p:nvGrpSpPr>
       <p:grpSpPr>
-        <a:xfrm xmlns:a="http://schemas.openxmlformats.org/drawingml/2006/main"/>
+        <a:xfrm>
+          <a:off x="0" y="0"/>
+          <a:ext cx="0" cy="0"/>
+          <a:chOff x="0" y="0"/>
+          <a:chExt cx="0" cy="0"/>
+        </a:xfrm>
       </p:grpSpPr>
       <p:sp>
         <p:nvSpPr>
           <p:cNvPr id="2" name="Slide Image Placeholder 1"/>
           <p:cNvSpPr>
-            <a:spLocks xmlns:a="http://schemas.openxmlformats.org/drawingml/2006/main" noGrp="1"/>
+            <a:spLocks noGrp="1" noRot="1" noChangeAspect="1"/>
           </p:cNvSpPr>
           <p:nvPr>
-            <p:ph type="sldImg" idx="0"/>
+            <p:ph type="sldImg"/>
           </p:nvPr>
         </p:nvSpPr>
         <p:spPr/>
@@ -885,7 +785,7 @@
         <p:nvSpPr>
           <p:cNvPr id="3" name="Notes Placeholder 2"/>
           <p:cNvSpPr>
-            <a:spLocks xmlns:a="http://schemas.openxmlformats.org/drawingml/2006/main" noGrp="1"/>
+            <a:spLocks noGrp="1"/>
           </p:cNvSpPr>
           <p:nvPr>
             <p:ph type="body" idx="1"/>
@@ -893,49 +793,41 @@
         </p:nvSpPr>
         <p:spPr/>
         <p:txBody>
-          <a:bodyPr xmlns:a="http://schemas.openxmlformats.org/drawingml/2006/main"/>
-          <a:lstStyle xmlns:a="http://schemas.openxmlformats.org/drawingml/2006/main"/>
-          <a:p xmlns:a="http://schemas.openxmlformats.org/drawingml/2006/main">
+          <a:bodyPr/>
+          <a:lstStyle/>
+          <a:p>
             <a:r>
               <a:t>For this demonstration, I use a local checkout application with live Prometheus measurements. I’ll also show a clearly labelled simulated memory-failure scenario to illustrate knowledge retrieval and approval policies.</a:t>
             </a:r>
           </a:p>
-          <a:p xmlns:a="http://schemas.openxmlformats.org/drawingml/2006/main">
-            <a:r>
-              <a:t/>
-            </a:r>
-          </a:p>
-          <a:p xmlns:a="http://schemas.openxmlformats.org/drawingml/2006/main">
+          <a:p>
+            <a:endParaRPr/>
+          </a:p>
+          <a:p>
             <a:r>
               <a:t>The goal is to help engineers investigate more efficiently while keeping uncertainty visible and operational decisions under human control.</a:t>
             </a:r>
           </a:p>
-          <a:p xmlns:a="http://schemas.openxmlformats.org/drawingml/2006/main">
-            <a:r>
-              <a:t/>
-            </a:r>
-          </a:p>
-          <a:p xmlns:a="http://schemas.openxmlformats.org/drawingml/2006/main">
+          <a:p>
+            <a:endParaRPr/>
+          </a:p>
+          <a:p>
             <a:r>
               <a:t>With that overview, I’ll now walk through the checkout incident.</a:t>
             </a:r>
           </a:p>
-          <a:p xmlns:a="http://schemas.openxmlformats.org/drawingml/2006/main">
-            <a:r>
-              <a:t/>
-            </a:r>
-          </a:p>
-          <a:p xmlns:a="http://schemas.openxmlformats.org/drawingml/2006/main">
+          <a:p>
+            <a:endParaRPr/>
+          </a:p>
+          <a:p>
             <a:r>
               <a:t>[Open the local Guardian interface. Keep live measurements separate from simulated evidence.]</a:t>
             </a:r>
           </a:p>
-          <a:p xmlns:a="http://schemas.openxmlformats.org/drawingml/2006/main">
-            <a:r>
-              <a:t/>
-            </a:r>
-          </a:p>
-          <a:p xmlns:a="http://schemas.openxmlformats.org/drawingml/2006/main">
+          <a:p>
+            <a:endParaRPr/>
+          </a:p>
+          <a:p>
             <a:r>
               <a:t>Source: Presenter-provided shortened capstone script.</a:t>
             </a:r>
@@ -946,7 +838,7 @@
         <p:nvSpPr>
           <p:cNvPr id="4" name="Slide Number Placeholder 3"/>
           <p:cNvSpPr>
-            <a:spLocks xmlns:a="http://schemas.openxmlformats.org/drawingml/2006/main" noGrp="1"/>
+            <a:spLocks noGrp="1"/>
           </p:cNvSpPr>
           <p:nvPr>
             <p:ph type="sldNum" idx="5"/>
@@ -954,21 +846,23 @@
         </p:nvSpPr>
         <p:spPr/>
         <p:txBody>
-          <a:bodyPr xmlns:a="http://schemas.openxmlformats.org/drawingml/2006/main"/>
-          <a:lstStyle xmlns:a="http://schemas.openxmlformats.org/drawingml/2006/main"/>
-          <a:p xmlns:a="http://schemas.openxmlformats.org/drawingml/2006/main"/>
+          <a:bodyPr/>
+          <a:lstStyle/>
+          <a:p>
+            <a:endParaRPr/>
+          </a:p>
         </p:txBody>
       </p:sp>
     </p:spTree>
   </p:cSld>
   <p:clrMapOvr>
-    <a:masterClrMapping xmlns:a="http://schemas.openxmlformats.org/drawingml/2006/main"/>
+    <a:masterClrMapping/>
   </p:clrMapOvr>
 </p:notes>
 </file>
 
 <file path=ppt/slideLayouts/slideLayout1.xml><?xml version="1.0" encoding="utf-8"?>
-<p:sldLayout xmlns:p="http://schemas.openxmlformats.org/presentationml/2006/main" type="title">
+<p:sldLayout xmlns:a="http://schemas.openxmlformats.org/drawingml/2006/main" xmlns:r="http://schemas.openxmlformats.org/officeDocument/2006/relationships" xmlns:p="http://schemas.openxmlformats.org/presentationml/2006/main" type="title">
   <p:cSld name="Title Slide">
     <p:spTree>
       <p:nvGrpSpPr>
@@ -977,19 +871,27 @@
         <p:nvPr/>
       </p:nvGrpSpPr>
       <p:grpSpPr>
-        <a:xfrm xmlns:a="http://schemas.openxmlformats.org/drawingml/2006/main"/>
+        <a:xfrm>
+          <a:off x="0" y="0"/>
+          <a:ext cx="0" cy="0"/>
+          <a:chOff x="0" y="0"/>
+          <a:chExt cx="0" cy="0"/>
+        </a:xfrm>
       </p:grpSpPr>
     </p:spTree>
   </p:cSld>
+  <p:clrMapOvr>
+    <a:masterClrMapping/>
+  </p:clrMapOvr>
 </p:sldLayout>
 </file>
 
 <file path=ppt/slideMasters/slideMaster1.xml><?xml version="1.0" encoding="utf-8"?>
-<p:sldMaster xmlns:p="http://schemas.openxmlformats.org/presentationml/2006/main">
+<p:sldMaster xmlns:a="http://schemas.openxmlformats.org/drawingml/2006/main" xmlns:r="http://schemas.openxmlformats.org/officeDocument/2006/relationships" xmlns:p="http://schemas.openxmlformats.org/presentationml/2006/main">
   <p:cSld name="Master">
     <p:bg>
       <p:bgRef idx="1001">
-        <a:schemeClr xmlns:a="http://schemas.openxmlformats.org/drawingml/2006/main" val="bg1"/>
+        <a:schemeClr val="bg1"/>
       </p:bgRef>
     </p:bg>
     <p:spTree>
@@ -999,17 +901,22 @@
         <p:nvPr/>
       </p:nvGrpSpPr>
       <p:grpSpPr>
-        <a:xfrm xmlns:a="http://schemas.openxmlformats.org/drawingml/2006/main"/>
+        <a:xfrm>
+          <a:off x="0" y="0"/>
+          <a:ext cx="0" cy="0"/>
+          <a:chOff x="0" y="0"/>
+          <a:chExt cx="0" cy="0"/>
+        </a:xfrm>
       </p:grpSpPr>
     </p:spTree>
   </p:cSld>
   <p:clrMap bg1="lt1" tx1="dk1" bg2="lt2" tx2="dk2" accent1="accent1" accent2="accent2" accent3="accent3" accent4="accent4" accent5="accent5" accent6="accent6" hlink="hlink" folHlink="folHlink"/>
   <p:sldLayoutIdLst>
-    <p:sldLayoutId xmlns:r="http://schemas.openxmlformats.org/officeDocument/2006/relationships" id="2147483649" r:id="R3fb3bd3845444aca"/>
+    <p:sldLayoutId id="2147483649" r:id="rId1"/>
   </p:sldLayoutIdLst>
   <p:txStyles>
     <p:titleStyle>
-      <a:lvl1pPr xmlns:a="http://schemas.openxmlformats.org/drawingml/2006/main" algn="l">
+      <a:lvl1pPr algn="l">
         <a:lnSpc>
           <a:spcPct val="90000"/>
         </a:lnSpc>
@@ -1028,7 +935,7 @@
       </a:lvl1pPr>
     </p:titleStyle>
     <p:bodyStyle>
-      <a:lvl1pPr xmlns:a="http://schemas.openxmlformats.org/drawingml/2006/main" marL="228600" indent="-228600" algn="l">
+      <a:lvl1pPr marL="228600" indent="-228600" algn="l">
         <a:lnSpc>
           <a:spcPct val="90000"/>
         </a:lnSpc>
@@ -1045,7 +952,7 @@
           <a:cs typeface="+mn-lt"/>
         </a:defRPr>
       </a:lvl1pPr>
-      <a:lvl2pPr xmlns:a="http://schemas.openxmlformats.org/drawingml/2006/main" marL="685800" indent="-228600" algn="l">
+      <a:lvl2pPr marL="685800" indent="-228600" algn="l">
         <a:lnSpc>
           <a:spcPct val="90000"/>
         </a:lnSpc>
@@ -1062,7 +969,7 @@
           <a:cs typeface="+mn-lt"/>
         </a:defRPr>
       </a:lvl2pPr>
-      <a:lvl3pPr xmlns:a="http://schemas.openxmlformats.org/drawingml/2006/main" marL="1143000" indent="-228600" algn="l">
+      <a:lvl3pPr marL="1143000" indent="-228600" algn="l">
         <a:lnSpc>
           <a:spcPct val="90000"/>
         </a:lnSpc>
@@ -1079,7 +986,7 @@
           <a:cs typeface="+mn-lt"/>
         </a:defRPr>
       </a:lvl3pPr>
-      <a:lvl4pPr xmlns:a="http://schemas.openxmlformats.org/drawingml/2006/main" marL="1600200" indent="-228600" algn="l">
+      <a:lvl4pPr marL="1600200" indent="-228600" algn="l">
         <a:lnSpc>
           <a:spcPct val="90000"/>
         </a:lnSpc>
@@ -1096,7 +1003,7 @@
           <a:cs typeface="+mn-lt"/>
         </a:defRPr>
       </a:lvl4pPr>
-      <a:lvl5pPr xmlns:a="http://schemas.openxmlformats.org/drawingml/2006/main" marL="2057400" indent="-228600" algn="l">
+      <a:lvl5pPr marL="2057400" indent="-228600" algn="l">
         <a:lnSpc>
           <a:spcPct val="90000"/>
         </a:lnSpc>
@@ -1113,7 +1020,7 @@
           <a:cs typeface="+mn-lt"/>
         </a:defRPr>
       </a:lvl5pPr>
-      <a:lvl6pPr xmlns:a="http://schemas.openxmlformats.org/drawingml/2006/main" marL="2514600" indent="-228600" algn="l">
+      <a:lvl6pPr marL="2514600" indent="-228600" algn="l">
         <a:lnSpc>
           <a:spcPct val="90000"/>
         </a:lnSpc>
@@ -1130,7 +1037,7 @@
           <a:cs typeface="+mn-lt"/>
         </a:defRPr>
       </a:lvl6pPr>
-      <a:lvl7pPr xmlns:a="http://schemas.openxmlformats.org/drawingml/2006/main" marL="2971800" indent="-228600" algn="l">
+      <a:lvl7pPr marL="2971800" indent="-228600" algn="l">
         <a:lnSpc>
           <a:spcPct val="90000"/>
         </a:lnSpc>
@@ -1147,7 +1054,7 @@
           <a:cs typeface="+mn-lt"/>
         </a:defRPr>
       </a:lvl7pPr>
-      <a:lvl8pPr xmlns:a="http://schemas.openxmlformats.org/drawingml/2006/main" marL="3429000" indent="-228600" algn="l">
+      <a:lvl8pPr marL="3429000" indent="-228600" algn="l">
         <a:lnSpc>
           <a:spcPct val="90000"/>
         </a:lnSpc>
@@ -1164,7 +1071,7 @@
           <a:cs typeface="+mn-lt"/>
         </a:defRPr>
       </a:lvl8pPr>
-      <a:lvl9pPr xmlns:a="http://schemas.openxmlformats.org/drawingml/2006/main" marL="3886200" indent="-228600" algn="l">
+      <a:lvl9pPr marL="3886200" indent="-228600" algn="l">
         <a:lnSpc>
           <a:spcPct val="90000"/>
         </a:lnSpc>
@@ -1183,7 +1090,7 @@
       </a:lvl9pPr>
     </p:bodyStyle>
     <p:otherStyle>
-      <a:lvl1pPr xmlns:a="http://schemas.openxmlformats.org/drawingml/2006/main" marL="0" algn="l">
+      <a:lvl1pPr marL="0" algn="l">
         <a:buNone/>
         <a:defRPr sz="1800">
           <a:solidFill>
@@ -1194,7 +1101,7 @@
           <a:cs typeface="+mn-lt"/>
         </a:defRPr>
       </a:lvl1pPr>
-      <a:lvl2pPr xmlns:a="http://schemas.openxmlformats.org/drawingml/2006/main" marL="457200" algn="l">
+      <a:lvl2pPr marL="457200" algn="l">
         <a:buNone/>
         <a:defRPr sz="1800">
           <a:solidFill>
@@ -1205,7 +1112,7 @@
           <a:cs typeface="+mn-lt"/>
         </a:defRPr>
       </a:lvl2pPr>
-      <a:lvl3pPr xmlns:a="http://schemas.openxmlformats.org/drawingml/2006/main" marL="914400" algn="l">
+      <a:lvl3pPr marL="914400" algn="l">
         <a:buNone/>
         <a:defRPr sz="1800">
           <a:solidFill>
@@ -1216,7 +1123,7 @@
           <a:cs typeface="+mn-lt"/>
         </a:defRPr>
       </a:lvl3pPr>
-      <a:lvl4pPr xmlns:a="http://schemas.openxmlformats.org/drawingml/2006/main" marL="1371600" algn="l">
+      <a:lvl4pPr marL="1371600" algn="l">
         <a:buNone/>
         <a:defRPr sz="1800">
           <a:solidFill>
@@ -1227,7 +1134,7 @@
           <a:cs typeface="+mn-lt"/>
         </a:defRPr>
       </a:lvl4pPr>
-      <a:lvl5pPr xmlns:a="http://schemas.openxmlformats.org/drawingml/2006/main" marL="1828800" algn="l">
+      <a:lvl5pPr marL="1828800" algn="l">
         <a:buNone/>
         <a:defRPr sz="1800">
           <a:solidFill>
@@ -1238,7 +1145,7 @@
           <a:cs typeface="+mn-lt"/>
         </a:defRPr>
       </a:lvl5pPr>
-      <a:lvl6pPr xmlns:a="http://schemas.openxmlformats.org/drawingml/2006/main" marL="2286000" algn="l">
+      <a:lvl6pPr marL="2286000" algn="l">
         <a:buNone/>
         <a:defRPr sz="1800">
           <a:solidFill>
@@ -1249,7 +1156,7 @@
           <a:cs typeface="+mn-lt"/>
         </a:defRPr>
       </a:lvl6pPr>
-      <a:lvl7pPr xmlns:a="http://schemas.openxmlformats.org/drawingml/2006/main" marL="2743200" algn="l">
+      <a:lvl7pPr marL="2743200" algn="l">
         <a:buNone/>
         <a:defRPr sz="1800">
           <a:solidFill>
@@ -1260,7 +1167,7 @@
           <a:cs typeface="+mn-lt"/>
         </a:defRPr>
       </a:lvl7pPr>
-      <a:lvl8pPr xmlns:a="http://schemas.openxmlformats.org/drawingml/2006/main" marL="3200400" algn="l">
+      <a:lvl8pPr marL="3200400" algn="l">
         <a:buNone/>
         <a:defRPr sz="1800">
           <a:solidFill>
@@ -1271,7 +1178,7 @@
           <a:cs typeface="+mn-lt"/>
         </a:defRPr>
       </a:lvl8pPr>
-      <a:lvl9pPr xmlns:a="http://schemas.openxmlformats.org/drawingml/2006/main" marL="3657600" algn="l">
+      <a:lvl9pPr marL="3657600" algn="l">
         <a:buNone/>
         <a:defRPr sz="1800">
           <a:solidFill>
@@ -1287,259 +1194,15 @@
 </p:sldMaster>
 </file>
 
-<file path=ppt/slideMasters/theme/theme2.xml><?xml version="1.0" encoding="utf-8"?>
-<a:theme xmlns:a="http://schemas.openxmlformats.org/drawingml/2006/main" name="ChatGPT">
-  <a:themeElements>
-    <a:clrScheme name="ChatGPT">
-      <a:dk1>
-        <a:srgbClr val="000000"/>
-      </a:dk1>
-      <a:lt1>
-        <a:srgbClr val="FFFFFF"/>
-      </a:lt1>
-      <a:dk2>
-        <a:srgbClr val="0E2841"/>
-      </a:dk2>
-      <a:lt2>
-        <a:srgbClr val="E8E8E8"/>
-      </a:lt2>
-      <a:accent1>
-        <a:srgbClr val="156082"/>
-      </a:accent1>
-      <a:accent2>
-        <a:srgbClr val="E97132"/>
-      </a:accent2>
-      <a:accent3>
-        <a:srgbClr val="196B24"/>
-      </a:accent3>
-      <a:accent4>
-        <a:srgbClr val="0F9ED5"/>
-      </a:accent4>
-      <a:accent5>
-        <a:srgbClr val="A02B93"/>
-      </a:accent5>
-      <a:accent6>
-        <a:srgbClr val="4EA72E"/>
-      </a:accent6>
-      <a:hlink>
-        <a:srgbClr val="467886"/>
-      </a:hlink>
-      <a:folHlink>
-        <a:srgbClr val="96607D"/>
-      </a:folHlink>
-    </a:clrScheme>
-    <a:fontScheme name="Office">
-      <a:majorFont>
-        <a:latin typeface="Calibri Light"/>
-        <a:ea typeface="Calibri Light"/>
-        <a:cs typeface="Calibri Light"/>
-      </a:majorFont>
-      <a:minorFont>
-        <a:latin typeface="Calibri"/>
-        <a:ea typeface="Calibri"/>
-        <a:cs typeface="Calibri"/>
-      </a:minorFont>
-    </a:fontScheme>
-    <a:fmtScheme name="ChatGPT">
-      <a:fillStyleLst>
-        <a:solidFill>
-          <a:schemeClr val="phClr"/>
-        </a:solidFill>
-        <a:gradFill>
-          <a:gsLst>
-            <a:gs pos="0">
-              <a:schemeClr val="phClr">
-                <a:tint val="67000"/>
-                <a:lumMod val="110000"/>
-                <a:satMod val="105000"/>
-              </a:schemeClr>
-            </a:gs>
-            <a:gs pos="50000">
-              <a:schemeClr val="phClr">
-                <a:tint val="73000"/>
-                <a:lumMod val="105000"/>
-                <a:satMod val="103000"/>
-              </a:schemeClr>
-            </a:gs>
-            <a:gs pos="100000">
-              <a:schemeClr val="phClr">
-                <a:tint val="81000"/>
-                <a:lumMod val="105000"/>
-                <a:satMod val="109000"/>
-              </a:schemeClr>
-            </a:gs>
-          </a:gsLst>
-          <a:lin ang="5400000" scaled="0"/>
-        </a:gradFill>
-        <a:gradFill>
-          <a:gsLst>
-            <a:gs pos="0">
-              <a:schemeClr val="phClr">
-                <a:tint val="94000"/>
-                <a:lumMod val="102000"/>
-                <a:satMod val="103000"/>
-              </a:schemeClr>
-            </a:gs>
-            <a:gs pos="50000">
-              <a:schemeClr val="phClr">
-                <a:shade val="100000"/>
-                <a:lumMod val="100000"/>
-                <a:satMod val="110000"/>
-              </a:schemeClr>
-            </a:gs>
-            <a:gs pos="100000">
-              <a:schemeClr val="phClr">
-                <a:shade val="78000"/>
-                <a:lumMod val="99000"/>
-                <a:satMod val="120000"/>
-              </a:schemeClr>
-            </a:gs>
-          </a:gsLst>
-          <a:lin ang="5400000" scaled="0"/>
-        </a:gradFill>
-      </a:fillStyleLst>
-      <a:lnStyleLst>
-        <a:ln w="12700">
-          <a:solidFill>
-            <a:schemeClr val="phClr"/>
-          </a:solidFill>
-          <a:prstDash val="solid"/>
-        </a:ln>
-        <a:ln w="19050">
-          <a:solidFill>
-            <a:schemeClr val="phClr"/>
-          </a:solidFill>
-          <a:prstDash val="solid"/>
-        </a:ln>
-        <a:ln w="25400">
-          <a:solidFill>
-            <a:schemeClr val="phClr"/>
-          </a:solidFill>
-          <a:prstDash val="solid"/>
-        </a:ln>
-      </a:lnStyleLst>
-      <a:effectStyleLst>
-        <a:effectStyle>
-          <a:effectLst/>
-        </a:effectStyle>
-        <a:effectStyle>
-          <a:effectLst/>
-        </a:effectStyle>
-        <a:effectStyle>
-          <a:effectLst>
-            <a:outerShdw blurRad="57150" dist="19050" dir="5400000">
-              <a:srgbClr val="000000">
-                <a:alpha val="16000"/>
-              </a:srgbClr>
-            </a:outerShdw>
-          </a:effectLst>
-        </a:effectStyle>
-        <a:effectStyle>
-          <a:effectLst>
-            <a:outerShdw blurRad="19050" dist="9525" dir="5400000">
-              <a:srgbClr val="000000">
-                <a:alpha val="6000"/>
-              </a:srgbClr>
-            </a:outerShdw>
-          </a:effectLst>
-        </a:effectStyle>
-        <a:effectStyle>
-          <a:effectLst>
-            <a:outerShdw blurRad="28575" dist="9525" dir="5400000">
-              <a:srgbClr val="000000">
-                <a:alpha val="8000"/>
-              </a:srgbClr>
-            </a:outerShdw>
-          </a:effectLst>
-        </a:effectStyle>
-        <a:effectStyle>
-          <a:effectLst>
-            <a:outerShdw blurRad="57150" dist="19050" dir="5400000">
-              <a:srgbClr val="000000">
-                <a:alpha val="10000"/>
-              </a:srgbClr>
-            </a:outerShdw>
-          </a:effectLst>
-        </a:effectStyle>
-        <a:effectStyle>
-          <a:effectLst>
-            <a:outerShdw blurRad="114300" dist="38100" dir="5400000">
-              <a:srgbClr val="000000">
-                <a:alpha val="12000"/>
-              </a:srgbClr>
-            </a:outerShdw>
-          </a:effectLst>
-        </a:effectStyle>
-        <a:effectStyle>
-          <a:effectLst>
-            <a:outerShdw blurRad="171450" dist="57150" dir="5400000">
-              <a:srgbClr val="000000">
-                <a:alpha val="16000"/>
-              </a:srgbClr>
-            </a:outerShdw>
-          </a:effectLst>
-        </a:effectStyle>
-        <a:effectStyle>
-          <a:effectLst>
-            <a:outerShdw blurRad="266700" dist="95250" dir="5400000">
-              <a:srgbClr val="000000">
-                <a:alpha val="24000"/>
-              </a:srgbClr>
-            </a:outerShdw>
-          </a:effectLst>
-        </a:effectStyle>
-      </a:effectStyleLst>
-      <a:bgFillStyleLst>
-        <a:solidFill>
-          <a:schemeClr val="phClr"/>
-        </a:solidFill>
-        <a:solidFill>
-          <a:schemeClr val="phClr">
-            <a:tint val="95000"/>
-            <a:satMod val="170000"/>
-          </a:schemeClr>
-        </a:solidFill>
-        <a:gradFill>
-          <a:gsLst>
-            <a:gs pos="0">
-              <a:schemeClr val="phClr">
-                <a:tint val="93000"/>
-                <a:shade val="98000"/>
-                <a:lumMod val="102000"/>
-                <a:satMod val="150000"/>
-              </a:schemeClr>
-            </a:gs>
-            <a:gs pos="50000">
-              <a:schemeClr val="phClr">
-                <a:tint val="98000"/>
-                <a:shade val="90000"/>
-                <a:lumMod val="103000"/>
-                <a:satMod val="130000"/>
-              </a:schemeClr>
-            </a:gs>
-            <a:gs pos="100000">
-              <a:schemeClr val="phClr">
-                <a:shade val="63000"/>
-                <a:satMod val="120000"/>
-              </a:schemeClr>
-            </a:gs>
-          </a:gsLst>
-          <a:lin ang="5400000" scaled="0"/>
-        </a:gradFill>
-      </a:bgFillStyleLst>
-    </a:fmtScheme>
-  </a:themeElements>
-</a:theme>
-</file>
-
 <file path=ppt/slides/slide1.xml><?xml version="1.0" encoding="utf-8"?>
-<p:sld xmlns:p="http://schemas.openxmlformats.org/presentationml/2006/main">
+<p:sld xmlns:a="http://schemas.openxmlformats.org/drawingml/2006/main" xmlns:r="http://schemas.openxmlformats.org/officeDocument/2006/relationships" xmlns:p="http://schemas.openxmlformats.org/presentationml/2006/main">
   <p:cSld>
     <p:bg>
       <p:bgPr>
-        <a:solidFill xmlns:a="http://schemas.openxmlformats.org/drawingml/2006/main">
+        <a:solidFill>
           <a:srgbClr val="0B1425"/>
         </a:solidFill>
+        <a:effectLst/>
       </p:bgPr>
     </p:bg>
     <p:spTree>
@@ -1549,41 +1212,46 @@
         <p:nvPr/>
       </p:nvGrpSpPr>
       <p:grpSpPr>
-        <a:xfrm xmlns:a="http://schemas.openxmlformats.org/drawingml/2006/main"/>
+        <a:xfrm>
+          <a:off x="0" y="0"/>
+          <a:ext cx="0" cy="0"/>
+          <a:chOff x="0" y="0"/>
+          <a:chExt cx="0" cy="0"/>
+        </a:xfrm>
       </p:grpSpPr>
       <p:sp>
         <p:nvSpPr>
-          <p:cNvPr id="4" name="">
-            <a:extLst xmlns:a="http://schemas.openxmlformats.org/drawingml/2006/main">
+          <p:cNvPr id="4" name="Rectangle 3">
+            <a:extLst>
               <a:ext uri="{FF2B5EF4-FFF2-40B4-BE49-F238E27FC236}">
                 <a16:creationId xmlns:a16="http://schemas.microsoft.com/office/drawing/2014/main" id="{5DF98A02-D385-412D-BBED-A903047092A7}"/>
               </a:ext>
             </a:extLst>
           </p:cNvPr>
           <p:cNvSpPr>
-            <a:spLocks xmlns:a="http://schemas.openxmlformats.org/drawingml/2006/main" noGrp="1"/>
+            <a:spLocks noGrp="1"/>
           </p:cNvSpPr>
           <p:nvPr/>
         </p:nvSpPr>
         <p:spPr>
-          <a:xfrm xmlns:a="http://schemas.openxmlformats.org/drawingml/2006/main">
-            <a:off x="723900" y="838200"/>
-            <a:ext cx="8572500" cy="381000"/>
+          <a:xfrm>
+            <a:off x="9987643" y="6196014"/>
+            <a:ext cx="2476500" cy="381000"/>
           </a:xfrm>
-          <a:prstGeom xmlns:a="http://schemas.openxmlformats.org/drawingml/2006/main" prst="rect">
+          <a:prstGeom prst="rect">
             <a:avLst/>
           </a:prstGeom>
-          <a:noFill xmlns:a="http://schemas.openxmlformats.org/drawingml/2006/main"/>
-          <a:ln xmlns:a="http://schemas.openxmlformats.org/drawingml/2006/main" w="0">
+          <a:noFill/>
+          <a:ln w="0">
             <a:noFill/>
           </a:ln>
         </p:spPr>
         <p:txBody>
-          <a:bodyPr xmlns:a="http://schemas.openxmlformats.org/drawingml/2006/main">
+          <a:bodyPr>
             <a:noAutofit/>
           </a:bodyPr>
-          <a:lstStyle xmlns:a="http://schemas.openxmlformats.org/drawingml/2006/main"/>
-          <a:p xmlns:a="http://schemas.openxmlformats.org/drawingml/2006/main">
+          <a:lstStyle/>
+          <a:p>
             <a:pPr>
               <a:defRPr sz="1875" b="0">
                 <a:solidFill>
@@ -1610,37 +1278,37 @@
       </p:sp>
       <p:sp>
         <p:nvSpPr>
-          <p:cNvPr id="2" name="">
-            <a:extLst xmlns:a="http://schemas.openxmlformats.org/drawingml/2006/main">
+          <p:cNvPr id="2" name="Rectangle 1">
+            <a:extLst>
               <a:ext uri="{FF2B5EF4-FFF2-40B4-BE49-F238E27FC236}">
                 <a16:creationId xmlns:a16="http://schemas.microsoft.com/office/drawing/2014/main" id="{AB1157EB-F271-4840-9565-6BA19BAB29BF}"/>
               </a:ext>
             </a:extLst>
           </p:cNvPr>
           <p:cNvSpPr>
-            <a:spLocks xmlns:a="http://schemas.openxmlformats.org/drawingml/2006/main" noGrp="1"/>
+            <a:spLocks noGrp="1"/>
           </p:cNvSpPr>
           <p:nvPr/>
         </p:nvSpPr>
         <p:spPr>
-          <a:xfrm xmlns:a="http://schemas.openxmlformats.org/drawingml/2006/main">
-            <a:off x="685800" y="1790700"/>
+          <a:xfrm>
+            <a:off x="979714" y="1155926"/>
             <a:ext cx="10668000" cy="2076450"/>
           </a:xfrm>
-          <a:prstGeom xmlns:a="http://schemas.openxmlformats.org/drawingml/2006/main" prst="rect">
+          <a:prstGeom prst="rect">
             <a:avLst/>
           </a:prstGeom>
-          <a:noFill xmlns:a="http://schemas.openxmlformats.org/drawingml/2006/main"/>
-          <a:ln xmlns:a="http://schemas.openxmlformats.org/drawingml/2006/main" w="0">
+          <a:noFill/>
+          <a:ln w="0">
             <a:noFill/>
           </a:ln>
         </p:spPr>
         <p:txBody>
-          <a:bodyPr xmlns:a="http://schemas.openxmlformats.org/drawingml/2006/main">
+          <a:bodyPr>
             <a:noAutofit/>
           </a:bodyPr>
-          <a:lstStyle xmlns:a="http://schemas.openxmlformats.org/drawingml/2006/main"/>
-          <a:p xmlns:a="http://schemas.openxmlformats.org/drawingml/2006/main">
+          <a:lstStyle/>
+          <a:p>
             <a:pPr>
               <a:defRPr sz="6150" b="1">
                 <a:solidFill>
@@ -1663,7 +1331,7 @@
               <a:t>AIOps</a:t>
             </a:r>
           </a:p>
-          <a:p xmlns:a="http://schemas.openxmlformats.org/drawingml/2006/main">
+          <a:p>
             <a:pPr>
               <a:defRPr sz="6150" b="1">
                 <a:solidFill>
@@ -1690,37 +1358,37 @@
       </p:sp>
       <p:sp>
         <p:nvSpPr>
-          <p:cNvPr id="3" name="">
-            <a:extLst xmlns:a="http://schemas.openxmlformats.org/drawingml/2006/main">
+          <p:cNvPr id="3" name="Rectangle 2">
+            <a:extLst>
               <a:ext uri="{FF2B5EF4-FFF2-40B4-BE49-F238E27FC236}">
                 <a16:creationId xmlns:a16="http://schemas.microsoft.com/office/drawing/2014/main" id="{30E7042D-75E1-4C07-9496-EDAB308DF34E}"/>
               </a:ext>
             </a:extLst>
           </p:cNvPr>
           <p:cNvSpPr>
-            <a:spLocks xmlns:a="http://schemas.openxmlformats.org/drawingml/2006/main" noGrp="1"/>
+            <a:spLocks noGrp="1"/>
           </p:cNvSpPr>
           <p:nvPr/>
         </p:nvSpPr>
         <p:spPr>
-          <a:xfrm xmlns:a="http://schemas.openxmlformats.org/drawingml/2006/main">
-            <a:off x="723900" y="4352925"/>
+          <a:xfrm>
+            <a:off x="979714" y="3113315"/>
             <a:ext cx="9906000" cy="1000125"/>
           </a:xfrm>
-          <a:prstGeom xmlns:a="http://schemas.openxmlformats.org/drawingml/2006/main" prst="rect">
+          <a:prstGeom prst="rect">
             <a:avLst/>
           </a:prstGeom>
-          <a:noFill xmlns:a="http://schemas.openxmlformats.org/drawingml/2006/main"/>
-          <a:ln xmlns:a="http://schemas.openxmlformats.org/drawingml/2006/main" w="0">
+          <a:noFill/>
+          <a:ln w="0">
             <a:noFill/>
           </a:ln>
         </p:spPr>
         <p:txBody>
-          <a:bodyPr xmlns:a="http://schemas.openxmlformats.org/drawingml/2006/main">
+          <a:bodyPr>
             <a:noAutofit/>
           </a:bodyPr>
-          <a:lstStyle xmlns:a="http://schemas.openxmlformats.org/drawingml/2006/main"/>
-          <a:p xmlns:a="http://schemas.openxmlformats.org/drawingml/2006/main">
+          <a:lstStyle/>
+          <a:p>
             <a:pPr>
               <a:defRPr sz="2550" b="0">
                 <a:solidFill>
@@ -1743,7 +1411,7 @@
               <a:t>AI-assisted investigation for SRE</a:t>
             </a:r>
           </a:p>
-          <a:p xmlns:a="http://schemas.openxmlformats.org/drawingml/2006/main">
+          <a:p>
             <a:pPr>
               <a:defRPr sz="2550" b="0">
                 <a:solidFill>
@@ -1765,6 +1433,71 @@
               </a:rPr>
               <a:t>and cloud operations teams</a:t>
             </a:r>
+          </a:p>
+        </p:txBody>
+      </p:sp>
+      <p:sp>
+        <p:nvSpPr>
+          <p:cNvPr id="5" name="Rectangle 4">
+            <a:extLst>
+              <a:ext uri="{FF2B5EF4-FFF2-40B4-BE49-F238E27FC236}">
+                <a16:creationId xmlns:a16="http://schemas.microsoft.com/office/drawing/2014/main" id="{2AC580F8-2FDD-F82A-D2AE-FE8ABDFAE4B3}"/>
+              </a:ext>
+            </a:extLst>
+          </p:cNvPr>
+          <p:cNvSpPr>
+            <a:spLocks noGrp="1"/>
+          </p:cNvSpPr>
+          <p:nvPr/>
+        </p:nvSpPr>
+        <p:spPr>
+          <a:xfrm>
+            <a:off x="979714" y="5389791"/>
+            <a:ext cx="6019800" cy="681038"/>
+          </a:xfrm>
+          <a:prstGeom prst="rect">
+            <a:avLst/>
+          </a:prstGeom>
+          <a:noFill/>
+          <a:ln w="0">
+            <a:noFill/>
+          </a:ln>
+        </p:spPr>
+        <p:txBody>
+          <a:bodyPr>
+            <a:noAutofit/>
+          </a:bodyPr>
+          <a:lstStyle/>
+          <a:p>
+            <a:pPr>
+              <a:defRPr sz="2550" b="0">
+                <a:solidFill>
+                  <a:srgbClr val="BAC8DA"/>
+                </a:solidFill>
+                <a:latin typeface="Helvetica Neue"/>
+                <a:ea typeface="Helvetica Neue"/>
+                <a:cs typeface="Helvetica Neue"/>
+              </a:defRPr>
+            </a:pPr>
+            <a:r>
+              <a:rPr lang="en-US" sz="2550" b="0">
+                <a:solidFill>
+                  <a:srgbClr val="BAC8DA"/>
+                </a:solidFill>
+                <a:latin typeface="Helvetica Neue"/>
+                <a:ea typeface="Helvetica Neue"/>
+                <a:cs typeface="Helvetica Neue"/>
+              </a:rPr>
+              <a:t>Presented By : Dani Chakiath Varghese</a:t>
+            </a:r>
+            <a:endParaRPr sz="2550" b="0">
+              <a:solidFill>
+                <a:srgbClr val="BAC8DA"/>
+              </a:solidFill>
+              <a:latin typeface="Helvetica Neue"/>
+              <a:ea typeface="Helvetica Neue"/>
+              <a:cs typeface="Helvetica Neue"/>
+            </a:endParaRPr>
           </a:p>
         </p:txBody>
       </p:sp>
@@ -1775,17 +1508,21 @@
       </p:ext>
     </p:extLst>
   </p:cSld>
+  <p:clrMapOvr>
+    <a:masterClrMapping/>
+  </p:clrMapOvr>
 </p:sld>
 </file>
 
 <file path=ppt/slides/slide2.xml><?xml version="1.0" encoding="utf-8"?>
-<p:sld xmlns:p="http://schemas.openxmlformats.org/presentationml/2006/main">
+<p:sld xmlns:a="http://schemas.openxmlformats.org/drawingml/2006/main" xmlns:r="http://schemas.openxmlformats.org/officeDocument/2006/relationships" xmlns:p="http://schemas.openxmlformats.org/presentationml/2006/main">
   <p:cSld>
     <p:bg>
       <p:bgPr>
-        <a:solidFill xmlns:a="http://schemas.openxmlformats.org/drawingml/2006/main">
+        <a:solidFill>
           <a:srgbClr val="0B1425"/>
         </a:solidFill>
+        <a:effectLst/>
       </p:bgPr>
     </p:bg>
     <p:spTree>
@@ -1795,41 +1532,46 @@
         <p:nvPr/>
       </p:nvGrpSpPr>
       <p:grpSpPr>
-        <a:xfrm xmlns:a="http://schemas.openxmlformats.org/drawingml/2006/main"/>
+        <a:xfrm>
+          <a:off x="0" y="0"/>
+          <a:ext cx="0" cy="0"/>
+          <a:chOff x="0" y="0"/>
+          <a:chExt cx="0" cy="0"/>
+        </a:xfrm>
       </p:grpSpPr>
       <p:sp>
         <p:nvSpPr>
-          <p:cNvPr id="11" name="">
-            <a:extLst xmlns:a="http://schemas.openxmlformats.org/drawingml/2006/main">
+          <p:cNvPr id="11" name="Rectangle 10">
+            <a:extLst>
               <a:ext uri="{FF2B5EF4-FFF2-40B4-BE49-F238E27FC236}">
                 <a16:creationId xmlns:a16="http://schemas.microsoft.com/office/drawing/2014/main" id="{F14EA90F-DFB4-4AD5-B228-5C20B6F898DC}"/>
               </a:ext>
             </a:extLst>
           </p:cNvPr>
           <p:cNvSpPr>
-            <a:spLocks xmlns:a="http://schemas.openxmlformats.org/drawingml/2006/main" noGrp="1"/>
+            <a:spLocks noGrp="1"/>
           </p:cNvSpPr>
           <p:nvPr/>
         </p:nvSpPr>
         <p:spPr>
-          <a:xfrm xmlns:a="http://schemas.openxmlformats.org/drawingml/2006/main">
+          <a:xfrm>
             <a:off x="685800" y="495300"/>
             <a:ext cx="10820400" cy="762000"/>
           </a:xfrm>
-          <a:prstGeom xmlns:a="http://schemas.openxmlformats.org/drawingml/2006/main" prst="rect">
+          <a:prstGeom prst="rect">
             <a:avLst/>
           </a:prstGeom>
-          <a:noFill xmlns:a="http://schemas.openxmlformats.org/drawingml/2006/main"/>
-          <a:ln xmlns:a="http://schemas.openxmlformats.org/drawingml/2006/main" w="0">
+          <a:noFill/>
+          <a:ln w="0">
             <a:noFill/>
           </a:ln>
         </p:spPr>
         <p:txBody>
-          <a:bodyPr xmlns:a="http://schemas.openxmlformats.org/drawingml/2006/main">
+          <a:bodyPr>
             <a:noAutofit/>
           </a:bodyPr>
-          <a:lstStyle xmlns:a="http://schemas.openxmlformats.org/drawingml/2006/main"/>
-          <a:p xmlns:a="http://schemas.openxmlformats.org/drawingml/2006/main">
+          <a:lstStyle/>
+          <a:p>
             <a:pPr>
               <a:defRPr sz="3450" b="1">
                 <a:solidFill>
@@ -1856,37 +1598,37 @@
       </p:sp>
       <p:sp>
         <p:nvSpPr>
-          <p:cNvPr id="2" name="">
-            <a:extLst xmlns:a="http://schemas.openxmlformats.org/drawingml/2006/main">
+          <p:cNvPr id="2" name="Rectangle 1">
+            <a:extLst>
               <a:ext uri="{FF2B5EF4-FFF2-40B4-BE49-F238E27FC236}">
                 <a16:creationId xmlns:a16="http://schemas.microsoft.com/office/drawing/2014/main" id="{45A025DD-7E98-459E-8309-2D73B1E655B6}"/>
               </a:ext>
             </a:extLst>
           </p:cNvPr>
           <p:cNvSpPr>
-            <a:spLocks xmlns:a="http://schemas.openxmlformats.org/drawingml/2006/main" noGrp="1"/>
+            <a:spLocks noGrp="1"/>
           </p:cNvSpPr>
           <p:nvPr/>
         </p:nvSpPr>
         <p:spPr>
-          <a:xfrm xmlns:a="http://schemas.openxmlformats.org/drawingml/2006/main">
+          <a:xfrm>
             <a:off x="11049000" y="6286500"/>
             <a:ext cx="476250" cy="266700"/>
           </a:xfrm>
-          <a:prstGeom xmlns:a="http://schemas.openxmlformats.org/drawingml/2006/main" prst="rect">
+          <a:prstGeom prst="rect">
             <a:avLst/>
           </a:prstGeom>
-          <a:noFill xmlns:a="http://schemas.openxmlformats.org/drawingml/2006/main"/>
-          <a:ln xmlns:a="http://schemas.openxmlformats.org/drawingml/2006/main" w="0">
+          <a:noFill/>
+          <a:ln w="0">
             <a:noFill/>
           </a:ln>
         </p:spPr>
         <p:txBody>
-          <a:bodyPr xmlns:a="http://schemas.openxmlformats.org/drawingml/2006/main">
+          <a:bodyPr>
             <a:noAutofit/>
           </a:bodyPr>
-          <a:lstStyle xmlns:a="http://schemas.openxmlformats.org/drawingml/2006/main"/>
-          <a:p xmlns:a="http://schemas.openxmlformats.org/drawingml/2006/main">
+          <a:lstStyle/>
+          <a:p>
             <a:pPr>
               <a:defRPr sz="1350" b="0">
                 <a:solidFill>
@@ -1913,37 +1655,37 @@
       </p:sp>
       <p:sp>
         <p:nvSpPr>
-          <p:cNvPr id="3" name="">
-            <a:extLst xmlns:a="http://schemas.openxmlformats.org/drawingml/2006/main">
+          <p:cNvPr id="3" name="Rectangle 2">
+            <a:extLst>
               <a:ext uri="{FF2B5EF4-FFF2-40B4-BE49-F238E27FC236}">
                 <a16:creationId xmlns:a16="http://schemas.microsoft.com/office/drawing/2014/main" id="{8CFFA244-0A17-404E-98AF-6BBB6D7C5C87}"/>
               </a:ext>
             </a:extLst>
           </p:cNvPr>
           <p:cNvSpPr>
-            <a:spLocks xmlns:a="http://schemas.openxmlformats.org/drawingml/2006/main" noGrp="1"/>
+            <a:spLocks noGrp="1"/>
           </p:cNvSpPr>
           <p:nvPr/>
         </p:nvSpPr>
         <p:spPr>
-          <a:xfrm xmlns:a="http://schemas.openxmlformats.org/drawingml/2006/main">
+          <a:xfrm>
             <a:off x="685800" y="1695450"/>
             <a:ext cx="6477000" cy="1238250"/>
           </a:xfrm>
-          <a:prstGeom xmlns:a="http://schemas.openxmlformats.org/drawingml/2006/main" prst="rect">
+          <a:prstGeom prst="rect">
             <a:avLst/>
           </a:prstGeom>
-          <a:noFill xmlns:a="http://schemas.openxmlformats.org/drawingml/2006/main"/>
-          <a:ln xmlns:a="http://schemas.openxmlformats.org/drawingml/2006/main" w="0">
+          <a:noFill/>
+          <a:ln w="0">
             <a:noFill/>
           </a:ln>
         </p:spPr>
         <p:txBody>
-          <a:bodyPr xmlns:a="http://schemas.openxmlformats.org/drawingml/2006/main">
+          <a:bodyPr>
             <a:noAutofit/>
           </a:bodyPr>
-          <a:lstStyle xmlns:a="http://schemas.openxmlformats.org/drawingml/2006/main"/>
-          <a:p xmlns:a="http://schemas.openxmlformats.org/drawingml/2006/main">
+          <a:lstStyle/>
+          <a:p>
             <a:pPr>
               <a:defRPr sz="3525" b="1">
                 <a:solidFill>
@@ -1966,7 +1708,7 @@
               <a:t>Checkout requests fail</a:t>
             </a:r>
           </a:p>
-          <a:p xmlns:a="http://schemas.openxmlformats.org/drawingml/2006/main">
+          <a:p>
             <a:pPr>
               <a:defRPr sz="3525" b="1">
                 <a:solidFill>
@@ -1993,37 +1735,37 @@
       </p:sp>
       <p:sp>
         <p:nvSpPr>
-          <p:cNvPr id="4" name="">
-            <a:extLst xmlns:a="http://schemas.openxmlformats.org/drawingml/2006/main">
+          <p:cNvPr id="4" name="Rectangle 3">
+            <a:extLst>
               <a:ext uri="{FF2B5EF4-FFF2-40B4-BE49-F238E27FC236}">
                 <a16:creationId xmlns:a16="http://schemas.microsoft.com/office/drawing/2014/main" id="{14621B5A-2B47-4BEC-8F04-B1FB27D785E1}"/>
               </a:ext>
             </a:extLst>
           </p:cNvPr>
           <p:cNvSpPr>
-            <a:spLocks xmlns:a="http://schemas.openxmlformats.org/drawingml/2006/main" noGrp="1"/>
+            <a:spLocks noGrp="1"/>
           </p:cNvSpPr>
           <p:nvPr/>
         </p:nvSpPr>
         <p:spPr>
-          <a:xfrm xmlns:a="http://schemas.openxmlformats.org/drawingml/2006/main">
+          <a:xfrm>
             <a:off x="723900" y="3219450"/>
             <a:ext cx="6191250" cy="904875"/>
           </a:xfrm>
-          <a:prstGeom xmlns:a="http://schemas.openxmlformats.org/drawingml/2006/main" prst="rect">
+          <a:prstGeom prst="rect">
             <a:avLst/>
           </a:prstGeom>
-          <a:noFill xmlns:a="http://schemas.openxmlformats.org/drawingml/2006/main"/>
-          <a:ln xmlns:a="http://schemas.openxmlformats.org/drawingml/2006/main" w="0">
+          <a:noFill/>
+          <a:ln w="0">
             <a:noFill/>
           </a:ln>
         </p:spPr>
         <p:txBody>
-          <a:bodyPr xmlns:a="http://schemas.openxmlformats.org/drawingml/2006/main">
+          <a:bodyPr>
             <a:noAutofit/>
           </a:bodyPr>
-          <a:lstStyle xmlns:a="http://schemas.openxmlformats.org/drawingml/2006/main"/>
-          <a:p xmlns:a="http://schemas.openxmlformats.org/drawingml/2006/main">
+          <a:lstStyle/>
+          <a:p>
             <a:pPr>
               <a:defRPr sz="2400" b="0">
                 <a:solidFill>
@@ -2046,7 +1788,7 @@
               <a:t>An engineer needs evidence</a:t>
             </a:r>
           </a:p>
-          <a:p xmlns:a="http://schemas.openxmlformats.org/drawingml/2006/main">
+          <a:p>
             <a:pPr>
               <a:defRPr sz="2400" b="0">
                 <a:solidFill>
@@ -2073,37 +1815,37 @@
       </p:sp>
       <p:sp>
         <p:nvSpPr>
-          <p:cNvPr id="5" name="">
-            <a:extLst xmlns:a="http://schemas.openxmlformats.org/drawingml/2006/main">
+          <p:cNvPr id="5" name="Rectangle 4">
+            <a:extLst>
               <a:ext uri="{FF2B5EF4-FFF2-40B4-BE49-F238E27FC236}">
                 <a16:creationId xmlns:a16="http://schemas.microsoft.com/office/drawing/2014/main" id="{53AED9C2-9B7B-4E7F-AC69-F6F7B330E57B}"/>
               </a:ext>
             </a:extLst>
           </p:cNvPr>
           <p:cNvSpPr>
-            <a:spLocks xmlns:a="http://schemas.openxmlformats.org/drawingml/2006/main" noGrp="1"/>
+            <a:spLocks noGrp="1"/>
           </p:cNvSpPr>
           <p:nvPr/>
         </p:nvSpPr>
         <p:spPr>
-          <a:xfrm xmlns:a="http://schemas.openxmlformats.org/drawingml/2006/main">
+          <a:xfrm>
             <a:off x="8001000" y="1724025"/>
             <a:ext cx="3333750" cy="381000"/>
           </a:xfrm>
-          <a:prstGeom xmlns:a="http://schemas.openxmlformats.org/drawingml/2006/main" prst="rect">
+          <a:prstGeom prst="rect">
             <a:avLst/>
           </a:prstGeom>
-          <a:noFill xmlns:a="http://schemas.openxmlformats.org/drawingml/2006/main"/>
-          <a:ln xmlns:a="http://schemas.openxmlformats.org/drawingml/2006/main" w="0">
+          <a:noFill/>
+          <a:ln w="0">
             <a:noFill/>
           </a:ln>
         </p:spPr>
         <p:txBody>
-          <a:bodyPr xmlns:a="http://schemas.openxmlformats.org/drawingml/2006/main">
+          <a:bodyPr>
             <a:noAutofit/>
           </a:bodyPr>
-          <a:lstStyle xmlns:a="http://schemas.openxmlformats.org/drawingml/2006/main"/>
-          <a:p xmlns:a="http://schemas.openxmlformats.org/drawingml/2006/main">
+          <a:lstStyle/>
+          <a:p>
             <a:pPr>
               <a:defRPr sz="1950" b="1">
                 <a:solidFill>
@@ -2130,37 +1872,37 @@
       </p:sp>
       <p:sp>
         <p:nvSpPr>
-          <p:cNvPr id="6" name="">
-            <a:extLst xmlns:a="http://schemas.openxmlformats.org/drawingml/2006/main">
+          <p:cNvPr id="6" name="Rectangle 5">
+            <a:extLst>
               <a:ext uri="{FF2B5EF4-FFF2-40B4-BE49-F238E27FC236}">
                 <a16:creationId xmlns:a16="http://schemas.microsoft.com/office/drawing/2014/main" id="{E74B90F8-AC72-4110-9CF9-3604F52635B5}"/>
               </a:ext>
             </a:extLst>
           </p:cNvPr>
           <p:cNvSpPr>
-            <a:spLocks xmlns:a="http://schemas.openxmlformats.org/drawingml/2006/main" noGrp="1"/>
+            <a:spLocks noGrp="1"/>
           </p:cNvSpPr>
           <p:nvPr/>
         </p:nvSpPr>
         <p:spPr>
-          <a:xfrm xmlns:a="http://schemas.openxmlformats.org/drawingml/2006/main">
+          <a:xfrm>
             <a:off x="8001000" y="2362200"/>
             <a:ext cx="3333750" cy="400050"/>
           </a:xfrm>
-          <a:prstGeom xmlns:a="http://schemas.openxmlformats.org/drawingml/2006/main" prst="rect">
+          <a:prstGeom prst="rect">
             <a:avLst/>
           </a:prstGeom>
-          <a:noFill xmlns:a="http://schemas.openxmlformats.org/drawingml/2006/main"/>
-          <a:ln xmlns:a="http://schemas.openxmlformats.org/drawingml/2006/main" w="0">
+          <a:noFill/>
+          <a:ln w="0">
             <a:noFill/>
           </a:ln>
         </p:spPr>
         <p:txBody>
-          <a:bodyPr xmlns:a="http://schemas.openxmlformats.org/drawingml/2006/main">
+          <a:bodyPr>
             <a:noAutofit/>
           </a:bodyPr>
-          <a:lstStyle xmlns:a="http://schemas.openxmlformats.org/drawingml/2006/main"/>
-          <a:p xmlns:a="http://schemas.openxmlformats.org/drawingml/2006/main">
+          <a:lstStyle/>
+          <a:p>
             <a:pPr>
               <a:defRPr sz="2175" b="0">
                 <a:solidFill>
@@ -2187,37 +1929,37 @@
       </p:sp>
       <p:sp>
         <p:nvSpPr>
-          <p:cNvPr id="7" name="">
-            <a:extLst xmlns:a="http://schemas.openxmlformats.org/drawingml/2006/main">
+          <p:cNvPr id="7" name="Rectangle 6">
+            <a:extLst>
               <a:ext uri="{FF2B5EF4-FFF2-40B4-BE49-F238E27FC236}">
                 <a16:creationId xmlns:a16="http://schemas.microsoft.com/office/drawing/2014/main" id="{6A2D2D1C-2213-4A8E-A119-992240AA4416}"/>
               </a:ext>
             </a:extLst>
           </p:cNvPr>
           <p:cNvSpPr>
-            <a:spLocks xmlns:a="http://schemas.openxmlformats.org/drawingml/2006/main" noGrp="1"/>
+            <a:spLocks noGrp="1"/>
           </p:cNvSpPr>
           <p:nvPr/>
         </p:nvSpPr>
         <p:spPr>
-          <a:xfrm xmlns:a="http://schemas.openxmlformats.org/drawingml/2006/main">
+          <a:xfrm>
             <a:off x="8001000" y="2952750"/>
             <a:ext cx="3333750" cy="400050"/>
           </a:xfrm>
-          <a:prstGeom xmlns:a="http://schemas.openxmlformats.org/drawingml/2006/main" prst="rect">
+          <a:prstGeom prst="rect">
             <a:avLst/>
           </a:prstGeom>
-          <a:noFill xmlns:a="http://schemas.openxmlformats.org/drawingml/2006/main"/>
-          <a:ln xmlns:a="http://schemas.openxmlformats.org/drawingml/2006/main" w="0">
+          <a:noFill/>
+          <a:ln w="0">
             <a:noFill/>
           </a:ln>
         </p:spPr>
         <p:txBody>
-          <a:bodyPr xmlns:a="http://schemas.openxmlformats.org/drawingml/2006/main">
+          <a:bodyPr>
             <a:noAutofit/>
           </a:bodyPr>
-          <a:lstStyle xmlns:a="http://schemas.openxmlformats.org/drawingml/2006/main"/>
-          <a:p xmlns:a="http://schemas.openxmlformats.org/drawingml/2006/main">
+          <a:lstStyle/>
+          <a:p>
             <a:pPr>
               <a:defRPr sz="2175" b="0">
                 <a:solidFill>
@@ -2244,37 +1986,37 @@
       </p:sp>
       <p:sp>
         <p:nvSpPr>
-          <p:cNvPr id="8" name="">
-            <a:extLst xmlns:a="http://schemas.openxmlformats.org/drawingml/2006/main">
+          <p:cNvPr id="8" name="Rectangle 7">
+            <a:extLst>
               <a:ext uri="{FF2B5EF4-FFF2-40B4-BE49-F238E27FC236}">
                 <a16:creationId xmlns:a16="http://schemas.microsoft.com/office/drawing/2014/main" id="{069459BE-F60B-48D4-8E35-A0B677F86618}"/>
               </a:ext>
             </a:extLst>
           </p:cNvPr>
           <p:cNvSpPr>
-            <a:spLocks xmlns:a="http://schemas.openxmlformats.org/drawingml/2006/main" noGrp="1"/>
+            <a:spLocks noGrp="1"/>
           </p:cNvSpPr>
           <p:nvPr/>
         </p:nvSpPr>
         <p:spPr>
-          <a:xfrm xmlns:a="http://schemas.openxmlformats.org/drawingml/2006/main">
+          <a:xfrm>
             <a:off x="8001000" y="3543300"/>
             <a:ext cx="3333750" cy="400050"/>
           </a:xfrm>
-          <a:prstGeom xmlns:a="http://schemas.openxmlformats.org/drawingml/2006/main" prst="rect">
+          <a:prstGeom prst="rect">
             <a:avLst/>
           </a:prstGeom>
-          <a:noFill xmlns:a="http://schemas.openxmlformats.org/drawingml/2006/main"/>
-          <a:ln xmlns:a="http://schemas.openxmlformats.org/drawingml/2006/main" w="0">
+          <a:noFill/>
+          <a:ln w="0">
             <a:noFill/>
           </a:ln>
         </p:spPr>
         <p:txBody>
-          <a:bodyPr xmlns:a="http://schemas.openxmlformats.org/drawingml/2006/main">
+          <a:bodyPr>
             <a:noAutofit/>
           </a:bodyPr>
-          <a:lstStyle xmlns:a="http://schemas.openxmlformats.org/drawingml/2006/main"/>
-          <a:p xmlns:a="http://schemas.openxmlformats.org/drawingml/2006/main">
+          <a:lstStyle/>
+          <a:p>
             <a:pPr>
               <a:defRPr sz="2175" b="0">
                 <a:solidFill>
@@ -2301,37 +2043,37 @@
       </p:sp>
       <p:sp>
         <p:nvSpPr>
-          <p:cNvPr id="9" name="">
-            <a:extLst xmlns:a="http://schemas.openxmlformats.org/drawingml/2006/main">
+          <p:cNvPr id="9" name="Rectangle 8">
+            <a:extLst>
               <a:ext uri="{FF2B5EF4-FFF2-40B4-BE49-F238E27FC236}">
                 <a16:creationId xmlns:a16="http://schemas.microsoft.com/office/drawing/2014/main" id="{A2E54C14-F4F3-40D8-BA9E-766EF1B0E9CF}"/>
               </a:ext>
             </a:extLst>
           </p:cNvPr>
           <p:cNvSpPr>
-            <a:spLocks xmlns:a="http://schemas.openxmlformats.org/drawingml/2006/main" noGrp="1"/>
+            <a:spLocks noGrp="1"/>
           </p:cNvSpPr>
           <p:nvPr/>
         </p:nvSpPr>
         <p:spPr>
-          <a:xfrm xmlns:a="http://schemas.openxmlformats.org/drawingml/2006/main">
+          <a:xfrm>
             <a:off x="8001000" y="4133850"/>
             <a:ext cx="3333750" cy="400050"/>
           </a:xfrm>
-          <a:prstGeom xmlns:a="http://schemas.openxmlformats.org/drawingml/2006/main" prst="rect">
+          <a:prstGeom prst="rect">
             <a:avLst/>
           </a:prstGeom>
-          <a:noFill xmlns:a="http://schemas.openxmlformats.org/drawingml/2006/main"/>
-          <a:ln xmlns:a="http://schemas.openxmlformats.org/drawingml/2006/main" w="0">
+          <a:noFill/>
+          <a:ln w="0">
             <a:noFill/>
           </a:ln>
         </p:spPr>
         <p:txBody>
-          <a:bodyPr xmlns:a="http://schemas.openxmlformats.org/drawingml/2006/main">
+          <a:bodyPr>
             <a:noAutofit/>
           </a:bodyPr>
-          <a:lstStyle xmlns:a="http://schemas.openxmlformats.org/drawingml/2006/main"/>
-          <a:p xmlns:a="http://schemas.openxmlformats.org/drawingml/2006/main">
+          <a:lstStyle/>
+          <a:p>
             <a:pPr>
               <a:defRPr sz="2175" b="0">
                 <a:solidFill>
@@ -2358,37 +2100,37 @@
       </p:sp>
       <p:sp>
         <p:nvSpPr>
-          <p:cNvPr id="10" name="">
-            <a:extLst xmlns:a="http://schemas.openxmlformats.org/drawingml/2006/main">
+          <p:cNvPr id="10" name="Rectangle 9">
+            <a:extLst>
               <a:ext uri="{FF2B5EF4-FFF2-40B4-BE49-F238E27FC236}">
                 <a16:creationId xmlns:a16="http://schemas.microsoft.com/office/drawing/2014/main" id="{62817D7E-0DD3-4243-AA24-FBB3B2A0FB70}"/>
               </a:ext>
             </a:extLst>
           </p:cNvPr>
           <p:cNvSpPr>
-            <a:spLocks xmlns:a="http://schemas.openxmlformats.org/drawingml/2006/main" noGrp="1"/>
+            <a:spLocks noGrp="1"/>
           </p:cNvSpPr>
           <p:nvPr/>
         </p:nvSpPr>
         <p:spPr>
-          <a:xfrm xmlns:a="http://schemas.openxmlformats.org/drawingml/2006/main">
+          <a:xfrm>
             <a:off x="723900" y="5257800"/>
             <a:ext cx="10287000" cy="742950"/>
           </a:xfrm>
-          <a:prstGeom xmlns:a="http://schemas.openxmlformats.org/drawingml/2006/main" prst="rect">
+          <a:prstGeom prst="rect">
             <a:avLst/>
           </a:prstGeom>
-          <a:noFill xmlns:a="http://schemas.openxmlformats.org/drawingml/2006/main"/>
-          <a:ln xmlns:a="http://schemas.openxmlformats.org/drawingml/2006/main" w="0">
+          <a:noFill/>
+          <a:ln w="0">
             <a:noFill/>
           </a:ln>
         </p:spPr>
         <p:txBody>
-          <a:bodyPr xmlns:a="http://schemas.openxmlformats.org/drawingml/2006/main">
+          <a:bodyPr>
             <a:noAutofit/>
           </a:bodyPr>
-          <a:lstStyle xmlns:a="http://schemas.openxmlformats.org/drawingml/2006/main"/>
-          <a:p xmlns:a="http://schemas.openxmlformats.org/drawingml/2006/main">
+          <a:lstStyle/>
+          <a:p>
             <a:pPr>
               <a:defRPr sz="2475" b="0">
                 <a:solidFill>
@@ -2420,17 +2162,21 @@
       </p:ext>
     </p:extLst>
   </p:cSld>
+  <p:clrMapOvr>
+    <a:masterClrMapping/>
+  </p:clrMapOvr>
 </p:sld>
 </file>
 
 <file path=ppt/slides/slide3.xml><?xml version="1.0" encoding="utf-8"?>
-<p:sld xmlns:p="http://schemas.openxmlformats.org/presentationml/2006/main">
+<p:sld xmlns:a="http://schemas.openxmlformats.org/drawingml/2006/main" xmlns:r="http://schemas.openxmlformats.org/officeDocument/2006/relationships" xmlns:p="http://schemas.openxmlformats.org/presentationml/2006/main">
   <p:cSld>
     <p:bg>
       <p:bgPr>
-        <a:solidFill xmlns:a="http://schemas.openxmlformats.org/drawingml/2006/main">
+        <a:solidFill>
           <a:srgbClr val="0B1425"/>
         </a:solidFill>
+        <a:effectLst/>
       </p:bgPr>
     </p:bg>
     <p:spTree>
@@ -2440,41 +2186,46 @@
         <p:nvPr/>
       </p:nvGrpSpPr>
       <p:grpSpPr>
-        <a:xfrm xmlns:a="http://schemas.openxmlformats.org/drawingml/2006/main"/>
+        <a:xfrm>
+          <a:off x="0" y="0"/>
+          <a:ext cx="0" cy="0"/>
+          <a:chOff x="0" y="0"/>
+          <a:chExt cx="0" cy="0"/>
+        </a:xfrm>
       </p:grpSpPr>
       <p:sp>
         <p:nvSpPr>
-          <p:cNvPr id="4" name="">
-            <a:extLst xmlns:a="http://schemas.openxmlformats.org/drawingml/2006/main">
+          <p:cNvPr id="4" name="Rectangle 3">
+            <a:extLst>
               <a:ext uri="{FF2B5EF4-FFF2-40B4-BE49-F238E27FC236}">
                 <a16:creationId xmlns:a16="http://schemas.microsoft.com/office/drawing/2014/main" id="{1CA426E4-367B-42FD-A085-E4A85B40A916}"/>
               </a:ext>
             </a:extLst>
           </p:cNvPr>
           <p:cNvSpPr>
-            <a:spLocks xmlns:a="http://schemas.openxmlformats.org/drawingml/2006/main" noGrp="1"/>
+            <a:spLocks noGrp="1"/>
           </p:cNvSpPr>
           <p:nvPr/>
         </p:nvSpPr>
         <p:spPr>
-          <a:xfrm xmlns:a="http://schemas.openxmlformats.org/drawingml/2006/main">
+          <a:xfrm>
             <a:off x="685800" y="495300"/>
             <a:ext cx="10820400" cy="762000"/>
           </a:xfrm>
-          <a:prstGeom xmlns:a="http://schemas.openxmlformats.org/drawingml/2006/main" prst="rect">
+          <a:prstGeom prst="rect">
             <a:avLst/>
           </a:prstGeom>
-          <a:noFill xmlns:a="http://schemas.openxmlformats.org/drawingml/2006/main"/>
-          <a:ln xmlns:a="http://schemas.openxmlformats.org/drawingml/2006/main" w="0">
+          <a:noFill/>
+          <a:ln w="0">
             <a:noFill/>
           </a:ln>
         </p:spPr>
         <p:txBody>
-          <a:bodyPr xmlns:a="http://schemas.openxmlformats.org/drawingml/2006/main">
+          <a:bodyPr>
             <a:noAutofit/>
           </a:bodyPr>
-          <a:lstStyle xmlns:a="http://schemas.openxmlformats.org/drawingml/2006/main"/>
-          <a:p xmlns:a="http://schemas.openxmlformats.org/drawingml/2006/main">
+          <a:lstStyle/>
+          <a:p>
             <a:pPr>
               <a:defRPr sz="3450" b="1">
                 <a:solidFill>
@@ -2501,37 +2252,37 @@
       </p:sp>
       <p:sp>
         <p:nvSpPr>
-          <p:cNvPr id="2" name="">
-            <a:extLst xmlns:a="http://schemas.openxmlformats.org/drawingml/2006/main">
+          <p:cNvPr id="2" name="Rectangle 1">
+            <a:extLst>
               <a:ext uri="{FF2B5EF4-FFF2-40B4-BE49-F238E27FC236}">
                 <a16:creationId xmlns:a16="http://schemas.microsoft.com/office/drawing/2014/main" id="{9C02C3EE-B974-421C-B66D-426F0FBDD700}"/>
               </a:ext>
             </a:extLst>
           </p:cNvPr>
           <p:cNvSpPr>
-            <a:spLocks xmlns:a="http://schemas.openxmlformats.org/drawingml/2006/main" noGrp="1"/>
+            <a:spLocks noGrp="1"/>
           </p:cNvSpPr>
           <p:nvPr/>
         </p:nvSpPr>
         <p:spPr>
-          <a:xfrm xmlns:a="http://schemas.openxmlformats.org/drawingml/2006/main">
+          <a:xfrm>
             <a:off x="11049000" y="6286500"/>
             <a:ext cx="476250" cy="266700"/>
           </a:xfrm>
-          <a:prstGeom xmlns:a="http://schemas.openxmlformats.org/drawingml/2006/main" prst="rect">
+          <a:prstGeom prst="rect">
             <a:avLst/>
           </a:prstGeom>
-          <a:noFill xmlns:a="http://schemas.openxmlformats.org/drawingml/2006/main"/>
-          <a:ln xmlns:a="http://schemas.openxmlformats.org/drawingml/2006/main" w="0">
+          <a:noFill/>
+          <a:ln w="0">
             <a:noFill/>
           </a:ln>
         </p:spPr>
         <p:txBody>
-          <a:bodyPr xmlns:a="http://schemas.openxmlformats.org/drawingml/2006/main">
+          <a:bodyPr>
             <a:noAutofit/>
           </a:bodyPr>
-          <a:lstStyle xmlns:a="http://schemas.openxmlformats.org/drawingml/2006/main"/>
-          <a:p xmlns:a="http://schemas.openxmlformats.org/drawingml/2006/main">
+          <a:lstStyle/>
+          <a:p>
             <a:pPr>
               <a:defRPr sz="1350" b="0">
                 <a:solidFill>
@@ -2558,21 +2309,33 @@
       </p:sp>
       <p:graphicFrame>
         <p:nvGraphicFramePr>
-          <p:cNvPr id="6" name=""/>
+          <p:cNvPr id="6" name="Table 5"/>
           <p:cNvGraphicFramePr/>
           <p:nvPr/>
         </p:nvGraphicFramePr>
         <p:xfrm>
-          <a:off xmlns:a="http://schemas.openxmlformats.org/drawingml/2006/main" x="723900" y="1685925"/>
-          <a:ext xmlns:a="http://schemas.openxmlformats.org/drawingml/2006/main" cx="10744200" cy="4200525"/>
+          <a:off x="723900" y="1685925"/>
+          <a:ext cx="10744200" cy="4200525"/>
         </p:xfrm>
-        <a:graphic xmlns:a="http://schemas.openxmlformats.org/drawingml/2006/main">
+        <a:graphic>
           <a:graphicData uri="http://schemas.openxmlformats.org/drawingml/2006/table">
             <a:tbl>
               <a:tblPr/>
               <a:tblGrid>
-                <a:gridCol w="4572000"/>
-                <a:gridCol w="6172200"/>
+                <a:gridCol w="4572000">
+                  <a:extLst>
+                    <a:ext uri="{9D8B030D-6E8A-4147-A177-3AD203B41FA5}">
+                      <a16:colId xmlns:a16="http://schemas.microsoft.com/office/drawing/2014/main" val="20000"/>
+                    </a:ext>
+                  </a:extLst>
+                </a:gridCol>
+                <a:gridCol w="6172200">
+                  <a:extLst>
+                    <a:ext uri="{9D8B030D-6E8A-4147-A177-3AD203B41FA5}">
+                      <a16:colId xmlns:a16="http://schemas.microsoft.com/office/drawing/2014/main" val="20001"/>
+                    </a:ext>
+                  </a:extLst>
+                </a:gridCol>
               </a:tblGrid>
               <a:tr h="600075">
                 <a:tc>
@@ -2623,6 +2386,11 @@
                     </a:solidFill>
                   </a:tcPr>
                 </a:tc>
+                <a:extLst>
+                  <a:ext uri="{0D108BD9-81ED-4DB2-BD59-A6C34878D82A}">
+                    <a16:rowId xmlns:a16="http://schemas.microsoft.com/office/drawing/2014/main" val="10000"/>
+                  </a:ext>
+                </a:extLst>
               </a:tr>
               <a:tr h="600075">
                 <a:tc>
@@ -2673,6 +2441,11 @@
                     </a:solidFill>
                   </a:tcPr>
                 </a:tc>
+                <a:extLst>
+                  <a:ext uri="{0D108BD9-81ED-4DB2-BD59-A6C34878D82A}">
+                    <a16:rowId xmlns:a16="http://schemas.microsoft.com/office/drawing/2014/main" val="10001"/>
+                  </a:ext>
+                </a:extLst>
               </a:tr>
               <a:tr h="600075">
                 <a:tc>
@@ -2723,6 +2496,11 @@
                     </a:solidFill>
                   </a:tcPr>
                 </a:tc>
+                <a:extLst>
+                  <a:ext uri="{0D108BD9-81ED-4DB2-BD59-A6C34878D82A}">
+                    <a16:rowId xmlns:a16="http://schemas.microsoft.com/office/drawing/2014/main" val="10002"/>
+                  </a:ext>
+                </a:extLst>
               </a:tr>
               <a:tr h="600075">
                 <a:tc>
@@ -2773,6 +2551,11 @@
                     </a:solidFill>
                   </a:tcPr>
                 </a:tc>
+                <a:extLst>
+                  <a:ext uri="{0D108BD9-81ED-4DB2-BD59-A6C34878D82A}">
+                    <a16:rowId xmlns:a16="http://schemas.microsoft.com/office/drawing/2014/main" val="10003"/>
+                  </a:ext>
+                </a:extLst>
               </a:tr>
               <a:tr h="600075">
                 <a:tc>
@@ -2823,6 +2606,11 @@
                     </a:solidFill>
                   </a:tcPr>
                 </a:tc>
+                <a:extLst>
+                  <a:ext uri="{0D108BD9-81ED-4DB2-BD59-A6C34878D82A}">
+                    <a16:rowId xmlns:a16="http://schemas.microsoft.com/office/drawing/2014/main" val="10004"/>
+                  </a:ext>
+                </a:extLst>
               </a:tr>
               <a:tr h="600075">
                 <a:tc>
@@ -2873,6 +2661,11 @@
                     </a:solidFill>
                   </a:tcPr>
                 </a:tc>
+                <a:extLst>
+                  <a:ext uri="{0D108BD9-81ED-4DB2-BD59-A6C34878D82A}">
+                    <a16:rowId xmlns:a16="http://schemas.microsoft.com/office/drawing/2014/main" val="10005"/>
+                  </a:ext>
+                </a:extLst>
               </a:tr>
               <a:tr h="600075">
                 <a:tc>
@@ -2923,6 +2716,11 @@
                     </a:solidFill>
                   </a:tcPr>
                 </a:tc>
+                <a:extLst>
+                  <a:ext uri="{0D108BD9-81ED-4DB2-BD59-A6C34878D82A}">
+                    <a16:rowId xmlns:a16="http://schemas.microsoft.com/office/drawing/2014/main" val="10006"/>
+                  </a:ext>
+                </a:extLst>
               </a:tr>
             </a:tbl>
           </a:graphicData>
@@ -2935,17 +2733,21 @@
       </p:ext>
     </p:extLst>
   </p:cSld>
+  <p:clrMapOvr>
+    <a:masterClrMapping/>
+  </p:clrMapOvr>
 </p:sld>
 </file>
 
 <file path=ppt/slides/slide4.xml><?xml version="1.0" encoding="utf-8"?>
-<p:sld xmlns:p="http://schemas.openxmlformats.org/presentationml/2006/main">
+<p:sld xmlns:a="http://schemas.openxmlformats.org/drawingml/2006/main" xmlns:r="http://schemas.openxmlformats.org/officeDocument/2006/relationships" xmlns:p="http://schemas.openxmlformats.org/presentationml/2006/main">
   <p:cSld>
     <p:bg>
       <p:bgPr>
-        <a:solidFill xmlns:a="http://schemas.openxmlformats.org/drawingml/2006/main">
+        <a:solidFill>
           <a:srgbClr val="0B1425"/>
         </a:solidFill>
+        <a:effectLst/>
       </p:bgPr>
     </p:bg>
     <p:spTree>
@@ -2955,41 +2757,46 @@
         <p:nvPr/>
       </p:nvGrpSpPr>
       <p:grpSpPr>
-        <a:xfrm xmlns:a="http://schemas.openxmlformats.org/drawingml/2006/main"/>
+        <a:xfrm>
+          <a:off x="0" y="0"/>
+          <a:ext cx="0" cy="0"/>
+          <a:chOff x="0" y="0"/>
+          <a:chExt cx="0" cy="0"/>
+        </a:xfrm>
       </p:grpSpPr>
       <p:sp>
         <p:nvSpPr>
-          <p:cNvPr id="15" name="">
-            <a:extLst xmlns:a="http://schemas.openxmlformats.org/drawingml/2006/main">
+          <p:cNvPr id="15" name="Rectangle 14">
+            <a:extLst>
               <a:ext uri="{FF2B5EF4-FFF2-40B4-BE49-F238E27FC236}">
                 <a16:creationId xmlns:a16="http://schemas.microsoft.com/office/drawing/2014/main" id="{AD4720DF-5959-4358-AEDA-9B9922EA4F66}"/>
               </a:ext>
             </a:extLst>
           </p:cNvPr>
           <p:cNvSpPr>
-            <a:spLocks xmlns:a="http://schemas.openxmlformats.org/drawingml/2006/main" noGrp="1"/>
+            <a:spLocks noGrp="1"/>
           </p:cNvSpPr>
           <p:nvPr/>
         </p:nvSpPr>
         <p:spPr>
-          <a:xfrm xmlns:a="http://schemas.openxmlformats.org/drawingml/2006/main">
+          <a:xfrm>
             <a:off x="685800" y="495300"/>
             <a:ext cx="10820400" cy="762000"/>
           </a:xfrm>
-          <a:prstGeom xmlns:a="http://schemas.openxmlformats.org/drawingml/2006/main" prst="rect">
+          <a:prstGeom prst="rect">
             <a:avLst/>
           </a:prstGeom>
-          <a:noFill xmlns:a="http://schemas.openxmlformats.org/drawingml/2006/main"/>
-          <a:ln xmlns:a="http://schemas.openxmlformats.org/drawingml/2006/main" w="0">
+          <a:noFill/>
+          <a:ln w="0">
             <a:noFill/>
           </a:ln>
         </p:spPr>
         <p:txBody>
-          <a:bodyPr xmlns:a="http://schemas.openxmlformats.org/drawingml/2006/main">
+          <a:bodyPr>
             <a:noAutofit/>
           </a:bodyPr>
-          <a:lstStyle xmlns:a="http://schemas.openxmlformats.org/drawingml/2006/main"/>
-          <a:p xmlns:a="http://schemas.openxmlformats.org/drawingml/2006/main">
+          <a:lstStyle/>
+          <a:p>
             <a:pPr>
               <a:defRPr sz="3450" b="1">
                 <a:solidFill>
@@ -3016,37 +2823,37 @@
       </p:sp>
       <p:sp>
         <p:nvSpPr>
-          <p:cNvPr id="2" name="">
-            <a:extLst xmlns:a="http://schemas.openxmlformats.org/drawingml/2006/main">
+          <p:cNvPr id="2" name="Rectangle 1">
+            <a:extLst>
               <a:ext uri="{FF2B5EF4-FFF2-40B4-BE49-F238E27FC236}">
                 <a16:creationId xmlns:a16="http://schemas.microsoft.com/office/drawing/2014/main" id="{980149EC-D055-472D-8216-777F8795EA52}"/>
               </a:ext>
             </a:extLst>
           </p:cNvPr>
           <p:cNvSpPr>
-            <a:spLocks xmlns:a="http://schemas.openxmlformats.org/drawingml/2006/main" noGrp="1"/>
+            <a:spLocks noGrp="1"/>
           </p:cNvSpPr>
           <p:nvPr/>
         </p:nvSpPr>
         <p:spPr>
-          <a:xfrm xmlns:a="http://schemas.openxmlformats.org/drawingml/2006/main">
+          <a:xfrm>
             <a:off x="11049000" y="6286500"/>
             <a:ext cx="476250" cy="266700"/>
           </a:xfrm>
-          <a:prstGeom xmlns:a="http://schemas.openxmlformats.org/drawingml/2006/main" prst="rect">
+          <a:prstGeom prst="rect">
             <a:avLst/>
           </a:prstGeom>
-          <a:noFill xmlns:a="http://schemas.openxmlformats.org/drawingml/2006/main"/>
-          <a:ln xmlns:a="http://schemas.openxmlformats.org/drawingml/2006/main" w="0">
+          <a:noFill/>
+          <a:ln w="0">
             <a:noFill/>
           </a:ln>
         </p:spPr>
         <p:txBody>
-          <a:bodyPr xmlns:a="http://schemas.openxmlformats.org/drawingml/2006/main">
+          <a:bodyPr>
             <a:noAutofit/>
           </a:bodyPr>
-          <a:lstStyle xmlns:a="http://schemas.openxmlformats.org/drawingml/2006/main"/>
-          <a:p xmlns:a="http://schemas.openxmlformats.org/drawingml/2006/main">
+          <a:lstStyle/>
+          <a:p>
             <a:pPr>
               <a:defRPr sz="1350" b="0">
                 <a:solidFill>
@@ -3073,37 +2880,37 @@
       </p:sp>
       <p:sp>
         <p:nvSpPr>
-          <p:cNvPr id="3" name="">
-            <a:extLst xmlns:a="http://schemas.openxmlformats.org/drawingml/2006/main">
+          <p:cNvPr id="3" name="Rectangle 2">
+            <a:extLst>
               <a:ext uri="{FF2B5EF4-FFF2-40B4-BE49-F238E27FC236}">
                 <a16:creationId xmlns:a16="http://schemas.microsoft.com/office/drawing/2014/main" id="{8AC3B045-BC70-42FC-B87E-D80267536105}"/>
               </a:ext>
             </a:extLst>
           </p:cNvPr>
           <p:cNvSpPr>
-            <a:spLocks xmlns:a="http://schemas.openxmlformats.org/drawingml/2006/main" noGrp="1"/>
+            <a:spLocks noGrp="1"/>
           </p:cNvSpPr>
           <p:nvPr/>
         </p:nvSpPr>
         <p:spPr>
-          <a:xfrm xmlns:a="http://schemas.openxmlformats.org/drawingml/2006/main">
+          <a:xfrm>
             <a:off x="723900" y="1695450"/>
             <a:ext cx="619125" cy="533400"/>
           </a:xfrm>
-          <a:prstGeom xmlns:a="http://schemas.openxmlformats.org/drawingml/2006/main" prst="rect">
+          <a:prstGeom prst="rect">
             <a:avLst/>
           </a:prstGeom>
-          <a:noFill xmlns:a="http://schemas.openxmlformats.org/drawingml/2006/main"/>
-          <a:ln xmlns:a="http://schemas.openxmlformats.org/drawingml/2006/main" w="0">
+          <a:noFill/>
+          <a:ln w="0">
             <a:noFill/>
           </a:ln>
         </p:spPr>
         <p:txBody>
-          <a:bodyPr xmlns:a="http://schemas.openxmlformats.org/drawingml/2006/main">
+          <a:bodyPr>
             <a:noAutofit/>
           </a:bodyPr>
-          <a:lstStyle xmlns:a="http://schemas.openxmlformats.org/drawingml/2006/main"/>
-          <a:p xmlns:a="http://schemas.openxmlformats.org/drawingml/2006/main">
+          <a:lstStyle/>
+          <a:p>
             <a:pPr>
               <a:defRPr sz="2850" b="0">
                 <a:solidFill>
@@ -3130,37 +2937,37 @@
       </p:sp>
       <p:sp>
         <p:nvSpPr>
-          <p:cNvPr id="4" name="">
-            <a:extLst xmlns:a="http://schemas.openxmlformats.org/drawingml/2006/main">
+          <p:cNvPr id="4" name="Rectangle 3">
+            <a:extLst>
               <a:ext uri="{FF2B5EF4-FFF2-40B4-BE49-F238E27FC236}">
                 <a16:creationId xmlns:a16="http://schemas.microsoft.com/office/drawing/2014/main" id="{317EF441-F8C3-4617-B3FC-35646CBD27E9}"/>
               </a:ext>
             </a:extLst>
           </p:cNvPr>
           <p:cNvSpPr>
-            <a:spLocks xmlns:a="http://schemas.openxmlformats.org/drawingml/2006/main" noGrp="1"/>
+            <a:spLocks noGrp="1"/>
           </p:cNvSpPr>
           <p:nvPr/>
         </p:nvSpPr>
         <p:spPr>
-          <a:xfrm xmlns:a="http://schemas.openxmlformats.org/drawingml/2006/main">
+          <a:xfrm>
             <a:off x="1619250" y="1695450"/>
             <a:ext cx="2190750" cy="533400"/>
           </a:xfrm>
-          <a:prstGeom xmlns:a="http://schemas.openxmlformats.org/drawingml/2006/main" prst="rect">
+          <a:prstGeom prst="rect">
             <a:avLst/>
           </a:prstGeom>
-          <a:noFill xmlns:a="http://schemas.openxmlformats.org/drawingml/2006/main"/>
-          <a:ln xmlns:a="http://schemas.openxmlformats.org/drawingml/2006/main" w="0">
+          <a:noFill/>
+          <a:ln w="0">
             <a:noFill/>
           </a:ln>
         </p:spPr>
         <p:txBody>
-          <a:bodyPr xmlns:a="http://schemas.openxmlformats.org/drawingml/2006/main">
+          <a:bodyPr>
             <a:noAutofit/>
           </a:bodyPr>
-          <a:lstStyle xmlns:a="http://schemas.openxmlformats.org/drawingml/2006/main"/>
-          <a:p xmlns:a="http://schemas.openxmlformats.org/drawingml/2006/main">
+          <a:lstStyle/>
+          <a:p>
             <a:pPr>
               <a:defRPr sz="2625" b="1">
                 <a:solidFill>
@@ -3187,37 +2994,37 @@
       </p:sp>
       <p:sp>
         <p:nvSpPr>
-          <p:cNvPr id="5" name="">
-            <a:extLst xmlns:a="http://schemas.openxmlformats.org/drawingml/2006/main">
+          <p:cNvPr id="5" name="Rectangle 4">
+            <a:extLst>
               <a:ext uri="{FF2B5EF4-FFF2-40B4-BE49-F238E27FC236}">
                 <a16:creationId xmlns:a16="http://schemas.microsoft.com/office/drawing/2014/main" id="{637E2B3B-5A2C-42F9-AB94-25804A4138FB}"/>
               </a:ext>
             </a:extLst>
           </p:cNvPr>
           <p:cNvSpPr>
-            <a:spLocks xmlns:a="http://schemas.openxmlformats.org/drawingml/2006/main" noGrp="1"/>
+            <a:spLocks noGrp="1"/>
           </p:cNvSpPr>
           <p:nvPr/>
         </p:nvSpPr>
         <p:spPr>
-          <a:xfrm xmlns:a="http://schemas.openxmlformats.org/drawingml/2006/main">
+          <a:xfrm>
             <a:off x="4191000" y="1724025"/>
             <a:ext cx="7219950" cy="762000"/>
           </a:xfrm>
-          <a:prstGeom xmlns:a="http://schemas.openxmlformats.org/drawingml/2006/main" prst="rect">
+          <a:prstGeom prst="rect">
             <a:avLst/>
           </a:prstGeom>
-          <a:noFill xmlns:a="http://schemas.openxmlformats.org/drawingml/2006/main"/>
-          <a:ln xmlns:a="http://schemas.openxmlformats.org/drawingml/2006/main" w="0">
+          <a:noFill/>
+          <a:ln w="0">
             <a:noFill/>
           </a:ln>
         </p:spPr>
         <p:txBody>
-          <a:bodyPr xmlns:a="http://schemas.openxmlformats.org/drawingml/2006/main">
+          <a:bodyPr>
             <a:noAutofit/>
           </a:bodyPr>
-          <a:lstStyle xmlns:a="http://schemas.openxmlformats.org/drawingml/2006/main"/>
-          <a:p xmlns:a="http://schemas.openxmlformats.org/drawingml/2006/main">
+          <a:lstStyle/>
+          <a:p>
             <a:pPr>
               <a:defRPr sz="2100" b="0">
                 <a:solidFill>
@@ -3244,37 +3051,37 @@
       </p:sp>
       <p:sp>
         <p:nvSpPr>
-          <p:cNvPr id="6" name="">
-            <a:extLst xmlns:a="http://schemas.openxmlformats.org/drawingml/2006/main">
+          <p:cNvPr id="6" name="Rectangle 5">
+            <a:extLst>
               <a:ext uri="{FF2B5EF4-FFF2-40B4-BE49-F238E27FC236}">
                 <a16:creationId xmlns:a16="http://schemas.microsoft.com/office/drawing/2014/main" id="{DA64C53B-35FC-4492-B5B5-98D7EE7C96DF}"/>
               </a:ext>
             </a:extLst>
           </p:cNvPr>
           <p:cNvSpPr>
-            <a:spLocks xmlns:a="http://schemas.openxmlformats.org/drawingml/2006/main" noGrp="1"/>
+            <a:spLocks noGrp="1"/>
           </p:cNvSpPr>
           <p:nvPr/>
         </p:nvSpPr>
         <p:spPr>
-          <a:xfrm xmlns:a="http://schemas.openxmlformats.org/drawingml/2006/main">
+          <a:xfrm>
             <a:off x="723900" y="2705100"/>
             <a:ext cx="619125" cy="533400"/>
           </a:xfrm>
-          <a:prstGeom xmlns:a="http://schemas.openxmlformats.org/drawingml/2006/main" prst="rect">
+          <a:prstGeom prst="rect">
             <a:avLst/>
           </a:prstGeom>
-          <a:noFill xmlns:a="http://schemas.openxmlformats.org/drawingml/2006/main"/>
-          <a:ln xmlns:a="http://schemas.openxmlformats.org/drawingml/2006/main" w="0">
+          <a:noFill/>
+          <a:ln w="0">
             <a:noFill/>
           </a:ln>
         </p:spPr>
         <p:txBody>
-          <a:bodyPr xmlns:a="http://schemas.openxmlformats.org/drawingml/2006/main">
+          <a:bodyPr>
             <a:noAutofit/>
           </a:bodyPr>
-          <a:lstStyle xmlns:a="http://schemas.openxmlformats.org/drawingml/2006/main"/>
-          <a:p xmlns:a="http://schemas.openxmlformats.org/drawingml/2006/main">
+          <a:lstStyle/>
+          <a:p>
             <a:pPr>
               <a:defRPr sz="2850" b="0">
                 <a:solidFill>
@@ -3301,37 +3108,37 @@
       </p:sp>
       <p:sp>
         <p:nvSpPr>
-          <p:cNvPr id="7" name="">
-            <a:extLst xmlns:a="http://schemas.openxmlformats.org/drawingml/2006/main">
+          <p:cNvPr id="7" name="Rectangle 6">
+            <a:extLst>
               <a:ext uri="{FF2B5EF4-FFF2-40B4-BE49-F238E27FC236}">
                 <a16:creationId xmlns:a16="http://schemas.microsoft.com/office/drawing/2014/main" id="{5DD9A2ED-09DE-415D-99B7-3A05DD56BD41}"/>
               </a:ext>
             </a:extLst>
           </p:cNvPr>
           <p:cNvSpPr>
-            <a:spLocks xmlns:a="http://schemas.openxmlformats.org/drawingml/2006/main" noGrp="1"/>
+            <a:spLocks noGrp="1"/>
           </p:cNvSpPr>
           <p:nvPr/>
         </p:nvSpPr>
         <p:spPr>
-          <a:xfrm xmlns:a="http://schemas.openxmlformats.org/drawingml/2006/main">
+          <a:xfrm>
             <a:off x="1619250" y="2705100"/>
             <a:ext cx="2190750" cy="533400"/>
           </a:xfrm>
-          <a:prstGeom xmlns:a="http://schemas.openxmlformats.org/drawingml/2006/main" prst="rect">
+          <a:prstGeom prst="rect">
             <a:avLst/>
           </a:prstGeom>
-          <a:noFill xmlns:a="http://schemas.openxmlformats.org/drawingml/2006/main"/>
-          <a:ln xmlns:a="http://schemas.openxmlformats.org/drawingml/2006/main" w="0">
+          <a:noFill/>
+          <a:ln w="0">
             <a:noFill/>
           </a:ln>
         </p:spPr>
         <p:txBody>
-          <a:bodyPr xmlns:a="http://schemas.openxmlformats.org/drawingml/2006/main">
+          <a:bodyPr>
             <a:noAutofit/>
           </a:bodyPr>
-          <a:lstStyle xmlns:a="http://schemas.openxmlformats.org/drawingml/2006/main"/>
-          <a:p xmlns:a="http://schemas.openxmlformats.org/drawingml/2006/main">
+          <a:lstStyle/>
+          <a:p>
             <a:pPr>
               <a:defRPr sz="2625" b="1">
                 <a:solidFill>
@@ -3358,37 +3165,37 @@
       </p:sp>
       <p:sp>
         <p:nvSpPr>
-          <p:cNvPr id="8" name="">
-            <a:extLst xmlns:a="http://schemas.openxmlformats.org/drawingml/2006/main">
+          <p:cNvPr id="8" name="Rectangle 7">
+            <a:extLst>
               <a:ext uri="{FF2B5EF4-FFF2-40B4-BE49-F238E27FC236}">
                 <a16:creationId xmlns:a16="http://schemas.microsoft.com/office/drawing/2014/main" id="{C8154AF2-49BA-4839-BCB9-FC5518213760}"/>
               </a:ext>
             </a:extLst>
           </p:cNvPr>
           <p:cNvSpPr>
-            <a:spLocks xmlns:a="http://schemas.openxmlformats.org/drawingml/2006/main" noGrp="1"/>
+            <a:spLocks noGrp="1"/>
           </p:cNvSpPr>
           <p:nvPr/>
         </p:nvSpPr>
         <p:spPr>
-          <a:xfrm xmlns:a="http://schemas.openxmlformats.org/drawingml/2006/main">
+          <a:xfrm>
             <a:off x="4191000" y="2733675"/>
             <a:ext cx="7219950" cy="762000"/>
           </a:xfrm>
-          <a:prstGeom xmlns:a="http://schemas.openxmlformats.org/drawingml/2006/main" prst="rect">
+          <a:prstGeom prst="rect">
             <a:avLst/>
           </a:prstGeom>
-          <a:noFill xmlns:a="http://schemas.openxmlformats.org/drawingml/2006/main"/>
-          <a:ln xmlns:a="http://schemas.openxmlformats.org/drawingml/2006/main" w="0">
+          <a:noFill/>
+          <a:ln w="0">
             <a:noFill/>
           </a:ln>
         </p:spPr>
         <p:txBody>
-          <a:bodyPr xmlns:a="http://schemas.openxmlformats.org/drawingml/2006/main">
+          <a:bodyPr>
             <a:noAutofit/>
           </a:bodyPr>
-          <a:lstStyle xmlns:a="http://schemas.openxmlformats.org/drawingml/2006/main"/>
-          <a:p xmlns:a="http://schemas.openxmlformats.org/drawingml/2006/main">
+          <a:lstStyle/>
+          <a:p>
             <a:pPr>
               <a:defRPr sz="2100" b="0">
                 <a:solidFill>
@@ -3415,37 +3222,37 @@
       </p:sp>
       <p:sp>
         <p:nvSpPr>
-          <p:cNvPr id="9" name="">
-            <a:extLst xmlns:a="http://schemas.openxmlformats.org/drawingml/2006/main">
+          <p:cNvPr id="9" name="Rectangle 8">
+            <a:extLst>
               <a:ext uri="{FF2B5EF4-FFF2-40B4-BE49-F238E27FC236}">
                 <a16:creationId xmlns:a16="http://schemas.microsoft.com/office/drawing/2014/main" id="{2FD67F07-01E5-4F85-A501-1B9AD8DC1480}"/>
               </a:ext>
             </a:extLst>
           </p:cNvPr>
           <p:cNvSpPr>
-            <a:spLocks xmlns:a="http://schemas.openxmlformats.org/drawingml/2006/main" noGrp="1"/>
+            <a:spLocks noGrp="1"/>
           </p:cNvSpPr>
           <p:nvPr/>
         </p:nvSpPr>
         <p:spPr>
-          <a:xfrm xmlns:a="http://schemas.openxmlformats.org/drawingml/2006/main">
+          <a:xfrm>
             <a:off x="723900" y="3714750"/>
             <a:ext cx="619125" cy="533400"/>
           </a:xfrm>
-          <a:prstGeom xmlns:a="http://schemas.openxmlformats.org/drawingml/2006/main" prst="rect">
+          <a:prstGeom prst="rect">
             <a:avLst/>
           </a:prstGeom>
-          <a:noFill xmlns:a="http://schemas.openxmlformats.org/drawingml/2006/main"/>
-          <a:ln xmlns:a="http://schemas.openxmlformats.org/drawingml/2006/main" w="0">
+          <a:noFill/>
+          <a:ln w="0">
             <a:noFill/>
           </a:ln>
         </p:spPr>
         <p:txBody>
-          <a:bodyPr xmlns:a="http://schemas.openxmlformats.org/drawingml/2006/main">
+          <a:bodyPr>
             <a:noAutofit/>
           </a:bodyPr>
-          <a:lstStyle xmlns:a="http://schemas.openxmlformats.org/drawingml/2006/main"/>
-          <a:p xmlns:a="http://schemas.openxmlformats.org/drawingml/2006/main">
+          <a:lstStyle/>
+          <a:p>
             <a:pPr>
               <a:defRPr sz="2850" b="0">
                 <a:solidFill>
@@ -3472,37 +3279,37 @@
       </p:sp>
       <p:sp>
         <p:nvSpPr>
-          <p:cNvPr id="10" name="">
-            <a:extLst xmlns:a="http://schemas.openxmlformats.org/drawingml/2006/main">
+          <p:cNvPr id="10" name="Rectangle 9">
+            <a:extLst>
               <a:ext uri="{FF2B5EF4-FFF2-40B4-BE49-F238E27FC236}">
                 <a16:creationId xmlns:a16="http://schemas.microsoft.com/office/drawing/2014/main" id="{887E76F0-E438-4A7E-B9D7-AF4BCC3AFEE2}"/>
               </a:ext>
             </a:extLst>
           </p:cNvPr>
           <p:cNvSpPr>
-            <a:spLocks xmlns:a="http://schemas.openxmlformats.org/drawingml/2006/main" noGrp="1"/>
+            <a:spLocks noGrp="1"/>
           </p:cNvSpPr>
           <p:nvPr/>
         </p:nvSpPr>
         <p:spPr>
-          <a:xfrm xmlns:a="http://schemas.openxmlformats.org/drawingml/2006/main">
+          <a:xfrm>
             <a:off x="1619250" y="3714750"/>
             <a:ext cx="2190750" cy="533400"/>
           </a:xfrm>
-          <a:prstGeom xmlns:a="http://schemas.openxmlformats.org/drawingml/2006/main" prst="rect">
+          <a:prstGeom prst="rect">
             <a:avLst/>
           </a:prstGeom>
-          <a:noFill xmlns:a="http://schemas.openxmlformats.org/drawingml/2006/main"/>
-          <a:ln xmlns:a="http://schemas.openxmlformats.org/drawingml/2006/main" w="0">
+          <a:noFill/>
+          <a:ln w="0">
             <a:noFill/>
           </a:ln>
         </p:spPr>
         <p:txBody>
-          <a:bodyPr xmlns:a="http://schemas.openxmlformats.org/drawingml/2006/main">
+          <a:bodyPr>
             <a:noAutofit/>
           </a:bodyPr>
-          <a:lstStyle xmlns:a="http://schemas.openxmlformats.org/drawingml/2006/main"/>
-          <a:p xmlns:a="http://schemas.openxmlformats.org/drawingml/2006/main">
+          <a:lstStyle/>
+          <a:p>
             <a:pPr>
               <a:defRPr sz="2625" b="1">
                 <a:solidFill>
@@ -3529,37 +3336,37 @@
       </p:sp>
       <p:sp>
         <p:nvSpPr>
-          <p:cNvPr id="11" name="">
-            <a:extLst xmlns:a="http://schemas.openxmlformats.org/drawingml/2006/main">
+          <p:cNvPr id="11" name="Rectangle 10">
+            <a:extLst>
               <a:ext uri="{FF2B5EF4-FFF2-40B4-BE49-F238E27FC236}">
                 <a16:creationId xmlns:a16="http://schemas.microsoft.com/office/drawing/2014/main" id="{4D157305-D179-486A-9678-861AD5A54E77}"/>
               </a:ext>
             </a:extLst>
           </p:cNvPr>
           <p:cNvSpPr>
-            <a:spLocks xmlns:a="http://schemas.openxmlformats.org/drawingml/2006/main" noGrp="1"/>
+            <a:spLocks noGrp="1"/>
           </p:cNvSpPr>
           <p:nvPr/>
         </p:nvSpPr>
         <p:spPr>
-          <a:xfrm xmlns:a="http://schemas.openxmlformats.org/drawingml/2006/main">
+          <a:xfrm>
             <a:off x="4191000" y="3743325"/>
             <a:ext cx="7219950" cy="762000"/>
           </a:xfrm>
-          <a:prstGeom xmlns:a="http://schemas.openxmlformats.org/drawingml/2006/main" prst="rect">
+          <a:prstGeom prst="rect">
             <a:avLst/>
           </a:prstGeom>
-          <a:noFill xmlns:a="http://schemas.openxmlformats.org/drawingml/2006/main"/>
-          <a:ln xmlns:a="http://schemas.openxmlformats.org/drawingml/2006/main" w="0">
+          <a:noFill/>
+          <a:ln w="0">
             <a:noFill/>
           </a:ln>
         </p:spPr>
         <p:txBody>
-          <a:bodyPr xmlns:a="http://schemas.openxmlformats.org/drawingml/2006/main">
+          <a:bodyPr>
             <a:noAutofit/>
           </a:bodyPr>
-          <a:lstStyle xmlns:a="http://schemas.openxmlformats.org/drawingml/2006/main"/>
-          <a:p xmlns:a="http://schemas.openxmlformats.org/drawingml/2006/main">
+          <a:lstStyle/>
+          <a:p>
             <a:pPr>
               <a:defRPr sz="2100" b="0">
                 <a:solidFill>
@@ -3586,37 +3393,37 @@
       </p:sp>
       <p:sp>
         <p:nvSpPr>
-          <p:cNvPr id="12" name="">
-            <a:extLst xmlns:a="http://schemas.openxmlformats.org/drawingml/2006/main">
+          <p:cNvPr id="12" name="Rectangle 11">
+            <a:extLst>
               <a:ext uri="{FF2B5EF4-FFF2-40B4-BE49-F238E27FC236}">
                 <a16:creationId xmlns:a16="http://schemas.microsoft.com/office/drawing/2014/main" id="{6AD19F0B-0113-4A66-9CA5-F9971F934FA9}"/>
               </a:ext>
             </a:extLst>
           </p:cNvPr>
           <p:cNvSpPr>
-            <a:spLocks xmlns:a="http://schemas.openxmlformats.org/drawingml/2006/main" noGrp="1"/>
+            <a:spLocks noGrp="1"/>
           </p:cNvSpPr>
           <p:nvPr/>
         </p:nvSpPr>
         <p:spPr>
-          <a:xfrm xmlns:a="http://schemas.openxmlformats.org/drawingml/2006/main">
+          <a:xfrm>
             <a:off x="723900" y="4724400"/>
             <a:ext cx="619125" cy="533400"/>
           </a:xfrm>
-          <a:prstGeom xmlns:a="http://schemas.openxmlformats.org/drawingml/2006/main" prst="rect">
+          <a:prstGeom prst="rect">
             <a:avLst/>
           </a:prstGeom>
-          <a:noFill xmlns:a="http://schemas.openxmlformats.org/drawingml/2006/main"/>
-          <a:ln xmlns:a="http://schemas.openxmlformats.org/drawingml/2006/main" w="0">
+          <a:noFill/>
+          <a:ln w="0">
             <a:noFill/>
           </a:ln>
         </p:spPr>
         <p:txBody>
-          <a:bodyPr xmlns:a="http://schemas.openxmlformats.org/drawingml/2006/main">
+          <a:bodyPr>
             <a:noAutofit/>
           </a:bodyPr>
-          <a:lstStyle xmlns:a="http://schemas.openxmlformats.org/drawingml/2006/main"/>
-          <a:p xmlns:a="http://schemas.openxmlformats.org/drawingml/2006/main">
+          <a:lstStyle/>
+          <a:p>
             <a:pPr>
               <a:defRPr sz="2850" b="0">
                 <a:solidFill>
@@ -3643,37 +3450,37 @@
       </p:sp>
       <p:sp>
         <p:nvSpPr>
-          <p:cNvPr id="13" name="">
-            <a:extLst xmlns:a="http://schemas.openxmlformats.org/drawingml/2006/main">
+          <p:cNvPr id="13" name="Rectangle 12">
+            <a:extLst>
               <a:ext uri="{FF2B5EF4-FFF2-40B4-BE49-F238E27FC236}">
                 <a16:creationId xmlns:a16="http://schemas.microsoft.com/office/drawing/2014/main" id="{024D3C04-0D6A-4927-89DE-165CD3F32BBF}"/>
               </a:ext>
             </a:extLst>
           </p:cNvPr>
           <p:cNvSpPr>
-            <a:spLocks xmlns:a="http://schemas.openxmlformats.org/drawingml/2006/main" noGrp="1"/>
+            <a:spLocks noGrp="1"/>
           </p:cNvSpPr>
           <p:nvPr/>
         </p:nvSpPr>
         <p:spPr>
-          <a:xfrm xmlns:a="http://schemas.openxmlformats.org/drawingml/2006/main">
+          <a:xfrm>
             <a:off x="1619250" y="4724400"/>
             <a:ext cx="2190750" cy="533400"/>
           </a:xfrm>
-          <a:prstGeom xmlns:a="http://schemas.openxmlformats.org/drawingml/2006/main" prst="rect">
+          <a:prstGeom prst="rect">
             <a:avLst/>
           </a:prstGeom>
-          <a:noFill xmlns:a="http://schemas.openxmlformats.org/drawingml/2006/main"/>
-          <a:ln xmlns:a="http://schemas.openxmlformats.org/drawingml/2006/main" w="0">
+          <a:noFill/>
+          <a:ln w="0">
             <a:noFill/>
           </a:ln>
         </p:spPr>
         <p:txBody>
-          <a:bodyPr xmlns:a="http://schemas.openxmlformats.org/drawingml/2006/main">
+          <a:bodyPr>
             <a:noAutofit/>
           </a:bodyPr>
-          <a:lstStyle xmlns:a="http://schemas.openxmlformats.org/drawingml/2006/main"/>
-          <a:p xmlns:a="http://schemas.openxmlformats.org/drawingml/2006/main">
+          <a:lstStyle/>
+          <a:p>
             <a:pPr>
               <a:defRPr sz="2625" b="1">
                 <a:solidFill>
@@ -3700,37 +3507,37 @@
       </p:sp>
       <p:sp>
         <p:nvSpPr>
-          <p:cNvPr id="14" name="">
-            <a:extLst xmlns:a="http://schemas.openxmlformats.org/drawingml/2006/main">
+          <p:cNvPr id="14" name="Rectangle 13">
+            <a:extLst>
               <a:ext uri="{FF2B5EF4-FFF2-40B4-BE49-F238E27FC236}">
                 <a16:creationId xmlns:a16="http://schemas.microsoft.com/office/drawing/2014/main" id="{2F951CE0-0FFE-4893-BC88-FAE11B41FFB5}"/>
               </a:ext>
             </a:extLst>
           </p:cNvPr>
           <p:cNvSpPr>
-            <a:spLocks xmlns:a="http://schemas.openxmlformats.org/drawingml/2006/main" noGrp="1"/>
+            <a:spLocks noGrp="1"/>
           </p:cNvSpPr>
           <p:nvPr/>
         </p:nvSpPr>
         <p:spPr>
-          <a:xfrm xmlns:a="http://schemas.openxmlformats.org/drawingml/2006/main">
+          <a:xfrm>
             <a:off x="4191000" y="4752975"/>
             <a:ext cx="7219950" cy="762000"/>
           </a:xfrm>
-          <a:prstGeom xmlns:a="http://schemas.openxmlformats.org/drawingml/2006/main" prst="rect">
+          <a:prstGeom prst="rect">
             <a:avLst/>
           </a:prstGeom>
-          <a:noFill xmlns:a="http://schemas.openxmlformats.org/drawingml/2006/main"/>
-          <a:ln xmlns:a="http://schemas.openxmlformats.org/drawingml/2006/main" w="0">
+          <a:noFill/>
+          <a:ln w="0">
             <a:noFill/>
           </a:ln>
         </p:spPr>
         <p:txBody>
-          <a:bodyPr xmlns:a="http://schemas.openxmlformats.org/drawingml/2006/main">
+          <a:bodyPr>
             <a:noAutofit/>
           </a:bodyPr>
-          <a:lstStyle xmlns:a="http://schemas.openxmlformats.org/drawingml/2006/main"/>
-          <a:p xmlns:a="http://schemas.openxmlformats.org/drawingml/2006/main">
+          <a:lstStyle/>
+          <a:p>
             <a:pPr>
               <a:defRPr sz="2100" b="0">
                 <a:solidFill>
@@ -3762,17 +3569,21 @@
       </p:ext>
     </p:extLst>
   </p:cSld>
+  <p:clrMapOvr>
+    <a:masterClrMapping/>
+  </p:clrMapOvr>
 </p:sld>
 </file>
 
 <file path=ppt/slides/slide5.xml><?xml version="1.0" encoding="utf-8"?>
-<p:sld xmlns:p="http://schemas.openxmlformats.org/presentationml/2006/main">
+<p:sld xmlns:a="http://schemas.openxmlformats.org/drawingml/2006/main" xmlns:r="http://schemas.openxmlformats.org/officeDocument/2006/relationships" xmlns:p="http://schemas.openxmlformats.org/presentationml/2006/main">
   <p:cSld>
     <p:bg>
       <p:bgPr>
-        <a:solidFill xmlns:a="http://schemas.openxmlformats.org/drawingml/2006/main">
+        <a:solidFill>
           <a:srgbClr val="0B1425"/>
         </a:solidFill>
+        <a:effectLst/>
       </p:bgPr>
     </p:bg>
     <p:spTree>
@@ -3782,41 +3593,46 @@
         <p:nvPr/>
       </p:nvGrpSpPr>
       <p:grpSpPr>
-        <a:xfrm xmlns:a="http://schemas.openxmlformats.org/drawingml/2006/main"/>
+        <a:xfrm>
+          <a:off x="0" y="0"/>
+          <a:ext cx="0" cy="0"/>
+          <a:chOff x="0" y="0"/>
+          <a:chExt cx="0" cy="0"/>
+        </a:xfrm>
       </p:grpSpPr>
       <p:sp>
         <p:nvSpPr>
-          <p:cNvPr id="8" name="">
-            <a:extLst xmlns:a="http://schemas.openxmlformats.org/drawingml/2006/main">
+          <p:cNvPr id="8" name="Rectangle 7">
+            <a:extLst>
               <a:ext uri="{FF2B5EF4-FFF2-40B4-BE49-F238E27FC236}">
                 <a16:creationId xmlns:a16="http://schemas.microsoft.com/office/drawing/2014/main" id="{85C6F81B-FA43-4AD8-9BFC-1E900F07C193}"/>
               </a:ext>
             </a:extLst>
           </p:cNvPr>
           <p:cNvSpPr>
-            <a:spLocks xmlns:a="http://schemas.openxmlformats.org/drawingml/2006/main" noGrp="1"/>
+            <a:spLocks noGrp="1"/>
           </p:cNvSpPr>
           <p:nvPr/>
         </p:nvSpPr>
         <p:spPr>
-          <a:xfrm xmlns:a="http://schemas.openxmlformats.org/drawingml/2006/main">
+          <a:xfrm>
             <a:off x="685800" y="495300"/>
             <a:ext cx="10820400" cy="762000"/>
           </a:xfrm>
-          <a:prstGeom xmlns:a="http://schemas.openxmlformats.org/drawingml/2006/main" prst="rect">
+          <a:prstGeom prst="rect">
             <a:avLst/>
           </a:prstGeom>
-          <a:noFill xmlns:a="http://schemas.openxmlformats.org/drawingml/2006/main"/>
-          <a:ln xmlns:a="http://schemas.openxmlformats.org/drawingml/2006/main" w="0">
+          <a:noFill/>
+          <a:ln w="0">
             <a:noFill/>
           </a:ln>
         </p:spPr>
         <p:txBody>
-          <a:bodyPr xmlns:a="http://schemas.openxmlformats.org/drawingml/2006/main">
+          <a:bodyPr>
             <a:noAutofit/>
           </a:bodyPr>
-          <a:lstStyle xmlns:a="http://schemas.openxmlformats.org/drawingml/2006/main"/>
-          <a:p xmlns:a="http://schemas.openxmlformats.org/drawingml/2006/main">
+          <a:lstStyle/>
+          <a:p>
             <a:pPr>
               <a:defRPr sz="3450" b="1">
                 <a:solidFill>
@@ -3843,37 +3659,37 @@
       </p:sp>
       <p:sp>
         <p:nvSpPr>
-          <p:cNvPr id="2" name="">
-            <a:extLst xmlns:a="http://schemas.openxmlformats.org/drawingml/2006/main">
+          <p:cNvPr id="2" name="Rectangle 1">
+            <a:extLst>
               <a:ext uri="{FF2B5EF4-FFF2-40B4-BE49-F238E27FC236}">
                 <a16:creationId xmlns:a16="http://schemas.microsoft.com/office/drawing/2014/main" id="{33721771-3241-4828-87EA-3F3B7BB29442}"/>
               </a:ext>
             </a:extLst>
           </p:cNvPr>
           <p:cNvSpPr>
-            <a:spLocks xmlns:a="http://schemas.openxmlformats.org/drawingml/2006/main" noGrp="1"/>
+            <a:spLocks noGrp="1"/>
           </p:cNvSpPr>
           <p:nvPr/>
         </p:nvSpPr>
         <p:spPr>
-          <a:xfrm xmlns:a="http://schemas.openxmlformats.org/drawingml/2006/main">
+          <a:xfrm>
             <a:off x="11049000" y="6286500"/>
             <a:ext cx="476250" cy="266700"/>
           </a:xfrm>
-          <a:prstGeom xmlns:a="http://schemas.openxmlformats.org/drawingml/2006/main" prst="rect">
+          <a:prstGeom prst="rect">
             <a:avLst/>
           </a:prstGeom>
-          <a:noFill xmlns:a="http://schemas.openxmlformats.org/drawingml/2006/main"/>
-          <a:ln xmlns:a="http://schemas.openxmlformats.org/drawingml/2006/main" w="0">
+          <a:noFill/>
+          <a:ln w="0">
             <a:noFill/>
           </a:ln>
         </p:spPr>
         <p:txBody>
-          <a:bodyPr xmlns:a="http://schemas.openxmlformats.org/drawingml/2006/main">
+          <a:bodyPr>
             <a:noAutofit/>
           </a:bodyPr>
-          <a:lstStyle xmlns:a="http://schemas.openxmlformats.org/drawingml/2006/main"/>
-          <a:p xmlns:a="http://schemas.openxmlformats.org/drawingml/2006/main">
+          <a:lstStyle/>
+          <a:p>
             <a:pPr>
               <a:defRPr sz="1350" b="0">
                 <a:solidFill>
@@ -3900,37 +3716,37 @@
       </p:sp>
       <p:sp>
         <p:nvSpPr>
-          <p:cNvPr id="3" name="">
-            <a:extLst xmlns:a="http://schemas.openxmlformats.org/drawingml/2006/main">
+          <p:cNvPr id="3" name="Rectangle 2">
+            <a:extLst>
               <a:ext uri="{FF2B5EF4-FFF2-40B4-BE49-F238E27FC236}">
                 <a16:creationId xmlns:a16="http://schemas.microsoft.com/office/drawing/2014/main" id="{3171B5A1-CA64-45F1-8D16-A28D99AFD670}"/>
               </a:ext>
             </a:extLst>
           </p:cNvPr>
           <p:cNvSpPr>
-            <a:spLocks xmlns:a="http://schemas.openxmlformats.org/drawingml/2006/main" noGrp="1"/>
+            <a:spLocks noGrp="1"/>
           </p:cNvSpPr>
           <p:nvPr/>
         </p:nvSpPr>
         <p:spPr>
-          <a:xfrm xmlns:a="http://schemas.openxmlformats.org/drawingml/2006/main">
+          <a:xfrm>
             <a:off x="723900" y="1800225"/>
             <a:ext cx="4857750" cy="476250"/>
           </a:xfrm>
-          <a:prstGeom xmlns:a="http://schemas.openxmlformats.org/drawingml/2006/main" prst="rect">
+          <a:prstGeom prst="rect">
             <a:avLst/>
           </a:prstGeom>
-          <a:noFill xmlns:a="http://schemas.openxmlformats.org/drawingml/2006/main"/>
-          <a:ln xmlns:a="http://schemas.openxmlformats.org/drawingml/2006/main" w="0">
+          <a:noFill/>
+          <a:ln w="0">
             <a:noFill/>
           </a:ln>
         </p:spPr>
         <p:txBody>
-          <a:bodyPr xmlns:a="http://schemas.openxmlformats.org/drawingml/2006/main">
+          <a:bodyPr>
             <a:noAutofit/>
           </a:bodyPr>
-          <a:lstStyle xmlns:a="http://schemas.openxmlformats.org/drawingml/2006/main"/>
-          <a:p xmlns:a="http://schemas.openxmlformats.org/drawingml/2006/main">
+          <a:lstStyle/>
+          <a:p>
             <a:pPr>
               <a:defRPr sz="2550" b="1">
                 <a:solidFill>
@@ -3957,37 +3773,37 @@
       </p:sp>
       <p:sp>
         <p:nvSpPr>
-          <p:cNvPr id="4" name="">
-            <a:extLst xmlns:a="http://schemas.openxmlformats.org/drawingml/2006/main">
+          <p:cNvPr id="4" name="Rectangle 3">
+            <a:extLst>
               <a:ext uri="{FF2B5EF4-FFF2-40B4-BE49-F238E27FC236}">
                 <a16:creationId xmlns:a16="http://schemas.microsoft.com/office/drawing/2014/main" id="{2B9F49E1-6953-4C38-AF2F-0483194177EF}"/>
               </a:ext>
             </a:extLst>
           </p:cNvPr>
           <p:cNvSpPr>
-            <a:spLocks xmlns:a="http://schemas.openxmlformats.org/drawingml/2006/main" noGrp="1"/>
+            <a:spLocks noGrp="1"/>
           </p:cNvSpPr>
           <p:nvPr/>
         </p:nvSpPr>
         <p:spPr>
-          <a:xfrm xmlns:a="http://schemas.openxmlformats.org/drawingml/2006/main">
+          <a:xfrm>
             <a:off x="723900" y="2543175"/>
             <a:ext cx="5000625" cy="1857375"/>
           </a:xfrm>
-          <a:prstGeom xmlns:a="http://schemas.openxmlformats.org/drawingml/2006/main" prst="rect">
+          <a:prstGeom prst="rect">
             <a:avLst/>
           </a:prstGeom>
-          <a:noFill xmlns:a="http://schemas.openxmlformats.org/drawingml/2006/main"/>
-          <a:ln xmlns:a="http://schemas.openxmlformats.org/drawingml/2006/main" w="0">
+          <a:noFill/>
+          <a:ln w="0">
             <a:noFill/>
           </a:ln>
         </p:spPr>
         <p:txBody>
-          <a:bodyPr xmlns:a="http://schemas.openxmlformats.org/drawingml/2006/main">
+          <a:bodyPr>
             <a:noAutofit/>
           </a:bodyPr>
-          <a:lstStyle xmlns:a="http://schemas.openxmlformats.org/drawingml/2006/main"/>
-          <a:p xmlns:a="http://schemas.openxmlformats.org/drawingml/2006/main">
+          <a:lstStyle/>
+          <a:p>
             <a:pPr>
               <a:defRPr sz="2250" b="0">
                 <a:solidFill>
@@ -4010,7 +3826,7 @@
               <a:t>Interprets the available evidence</a:t>
             </a:r>
           </a:p>
-          <a:p xmlns:a="http://schemas.openxmlformats.org/drawingml/2006/main">
+          <a:p>
             <a:pPr>
               <a:defRPr sz="2250" b="0">
                 <a:solidFill>
@@ -4033,7 +3849,7 @@
               <a:t>Suggests the next useful check</a:t>
             </a:r>
           </a:p>
-          <a:p xmlns:a="http://schemas.openxmlformats.org/drawingml/2006/main">
+          <a:p>
             <a:pPr>
               <a:defRPr sz="2250" b="0">
                 <a:solidFill>
@@ -4060,37 +3876,37 @@
       </p:sp>
       <p:sp>
         <p:nvSpPr>
-          <p:cNvPr id="5" name="">
-            <a:extLst xmlns:a="http://schemas.openxmlformats.org/drawingml/2006/main">
+          <p:cNvPr id="5" name="Rectangle 4">
+            <a:extLst>
               <a:ext uri="{FF2B5EF4-FFF2-40B4-BE49-F238E27FC236}">
                 <a16:creationId xmlns:a16="http://schemas.microsoft.com/office/drawing/2014/main" id="{E5554505-D0DF-465C-ADF4-4207A9470233}"/>
               </a:ext>
             </a:extLst>
           </p:cNvPr>
           <p:cNvSpPr>
-            <a:spLocks xmlns:a="http://schemas.openxmlformats.org/drawingml/2006/main" noGrp="1"/>
+            <a:spLocks noGrp="1"/>
           </p:cNvSpPr>
           <p:nvPr/>
         </p:nvSpPr>
         <p:spPr>
-          <a:xfrm xmlns:a="http://schemas.openxmlformats.org/drawingml/2006/main">
+          <a:xfrm>
             <a:off x="6667500" y="1800225"/>
             <a:ext cx="4857750" cy="476250"/>
           </a:xfrm>
-          <a:prstGeom xmlns:a="http://schemas.openxmlformats.org/drawingml/2006/main" prst="rect">
+          <a:prstGeom prst="rect">
             <a:avLst/>
           </a:prstGeom>
-          <a:noFill xmlns:a="http://schemas.openxmlformats.org/drawingml/2006/main"/>
-          <a:ln xmlns:a="http://schemas.openxmlformats.org/drawingml/2006/main" w="0">
+          <a:noFill/>
+          <a:ln w="0">
             <a:noFill/>
           </a:ln>
         </p:spPr>
         <p:txBody>
-          <a:bodyPr xmlns:a="http://schemas.openxmlformats.org/drawingml/2006/main">
+          <a:bodyPr>
             <a:noAutofit/>
           </a:bodyPr>
-          <a:lstStyle xmlns:a="http://schemas.openxmlformats.org/drawingml/2006/main"/>
-          <a:p xmlns:a="http://schemas.openxmlformats.org/drawingml/2006/main">
+          <a:lstStyle/>
+          <a:p>
             <a:pPr>
               <a:defRPr sz="2550" b="1">
                 <a:solidFill>
@@ -4117,37 +3933,37 @@
       </p:sp>
       <p:sp>
         <p:nvSpPr>
-          <p:cNvPr id="6" name="">
-            <a:extLst xmlns:a="http://schemas.openxmlformats.org/drawingml/2006/main">
+          <p:cNvPr id="6" name="Rectangle 5">
+            <a:extLst>
               <a:ext uri="{FF2B5EF4-FFF2-40B4-BE49-F238E27FC236}">
                 <a16:creationId xmlns:a16="http://schemas.microsoft.com/office/drawing/2014/main" id="{D3EC1021-0EDE-4E9B-A7AE-3F3EBD44CFC0}"/>
               </a:ext>
             </a:extLst>
           </p:cNvPr>
           <p:cNvSpPr>
-            <a:spLocks xmlns:a="http://schemas.openxmlformats.org/drawingml/2006/main" noGrp="1"/>
+            <a:spLocks noGrp="1"/>
           </p:cNvSpPr>
           <p:nvPr/>
         </p:nvSpPr>
         <p:spPr>
-          <a:xfrm xmlns:a="http://schemas.openxmlformats.org/drawingml/2006/main">
+          <a:xfrm>
             <a:off x="6667500" y="2543175"/>
             <a:ext cx="4857750" cy="1857375"/>
           </a:xfrm>
-          <a:prstGeom xmlns:a="http://schemas.openxmlformats.org/drawingml/2006/main" prst="rect">
+          <a:prstGeom prst="rect">
             <a:avLst/>
           </a:prstGeom>
-          <a:noFill xmlns:a="http://schemas.openxmlformats.org/drawingml/2006/main"/>
-          <a:ln xmlns:a="http://schemas.openxmlformats.org/drawingml/2006/main" w="0">
+          <a:noFill/>
+          <a:ln w="0">
             <a:noFill/>
           </a:ln>
         </p:spPr>
         <p:txBody>
-          <a:bodyPr xmlns:a="http://schemas.openxmlformats.org/drawingml/2006/main">
+          <a:bodyPr>
             <a:noAutofit/>
           </a:bodyPr>
-          <a:lstStyle xmlns:a="http://schemas.openxmlformats.org/drawingml/2006/main"/>
-          <a:p xmlns:a="http://schemas.openxmlformats.org/drawingml/2006/main">
+          <a:lstStyle/>
+          <a:p>
             <a:pPr>
               <a:defRPr sz="2250" b="0">
                 <a:solidFill>
@@ -4170,7 +3986,7 @@
               <a:t>Applies deterministic policy</a:t>
             </a:r>
           </a:p>
-          <a:p xmlns:a="http://schemas.openxmlformats.org/drawingml/2006/main">
+          <a:p>
             <a:pPr>
               <a:defRPr sz="2250" b="0">
                 <a:solidFill>
@@ -4193,7 +4009,7 @@
               <a:t>Requires review for risky actions</a:t>
             </a:r>
           </a:p>
-          <a:p xmlns:a="http://schemas.openxmlformats.org/drawingml/2006/main">
+          <a:p>
             <a:pPr>
               <a:defRPr sz="2250" b="0">
                 <a:solidFill>
@@ -4220,37 +4036,37 @@
       </p:sp>
       <p:sp>
         <p:nvSpPr>
-          <p:cNvPr id="7" name="">
-            <a:extLst xmlns:a="http://schemas.openxmlformats.org/drawingml/2006/main">
+          <p:cNvPr id="7" name="Rectangle 6">
+            <a:extLst>
               <a:ext uri="{FF2B5EF4-FFF2-40B4-BE49-F238E27FC236}">
                 <a16:creationId xmlns:a16="http://schemas.microsoft.com/office/drawing/2014/main" id="{3871ABDE-8649-4B7B-B88C-D7C6F1480007}"/>
               </a:ext>
             </a:extLst>
           </p:cNvPr>
           <p:cNvSpPr>
-            <a:spLocks xmlns:a="http://schemas.openxmlformats.org/drawingml/2006/main" noGrp="1"/>
+            <a:spLocks noGrp="1"/>
           </p:cNvSpPr>
           <p:nvPr/>
         </p:nvSpPr>
         <p:spPr>
-          <a:xfrm xmlns:a="http://schemas.openxmlformats.org/drawingml/2006/main">
+          <a:xfrm>
             <a:off x="723900" y="5219700"/>
             <a:ext cx="10668000" cy="876300"/>
           </a:xfrm>
-          <a:prstGeom xmlns:a="http://schemas.openxmlformats.org/drawingml/2006/main" prst="rect">
+          <a:prstGeom prst="rect">
             <a:avLst/>
           </a:prstGeom>
-          <a:noFill xmlns:a="http://schemas.openxmlformats.org/drawingml/2006/main"/>
-          <a:ln xmlns:a="http://schemas.openxmlformats.org/drawingml/2006/main" w="0">
+          <a:noFill/>
+          <a:ln w="0">
             <a:noFill/>
           </a:ln>
         </p:spPr>
         <p:txBody>
-          <a:bodyPr xmlns:a="http://schemas.openxmlformats.org/drawingml/2006/main">
+          <a:bodyPr>
             <a:noAutofit/>
           </a:bodyPr>
-          <a:lstStyle xmlns:a="http://schemas.openxmlformats.org/drawingml/2006/main"/>
-          <a:p xmlns:a="http://schemas.openxmlformats.org/drawingml/2006/main">
+          <a:lstStyle/>
+          <a:p>
             <a:pPr>
               <a:defRPr sz="2550" b="0">
                 <a:solidFill>
@@ -4282,17 +4098,81 @@
       </p:ext>
     </p:extLst>
   </p:cSld>
+  <p:clrMapOvr>
+    <a:masterClrMapping/>
+  </p:clrMapOvr>
 </p:sld>
 </file>
 
 <file path=ppt/slides/slide6.xml><?xml version="1.0" encoding="utf-8"?>
-<p:sld xmlns:p="http://schemas.openxmlformats.org/presentationml/2006/main">
+<p:sld xmlns:a="http://schemas.openxmlformats.org/drawingml/2006/main" xmlns:r="http://schemas.openxmlformats.org/officeDocument/2006/relationships" xmlns:p="http://schemas.openxmlformats.org/presentationml/2006/main">
+  <p:cSld>
+    <p:spTree>
+      <p:nvGrpSpPr>
+        <p:cNvPr id="1" name=""/>
+        <p:cNvGrpSpPr/>
+        <p:nvPr/>
+      </p:nvGrpSpPr>
+      <p:grpSpPr>
+        <a:xfrm>
+          <a:off x="0" y="0"/>
+          <a:ext cx="0" cy="0"/>
+          <a:chOff x="0" y="0"/>
+          <a:chExt cx="0" cy="0"/>
+        </a:xfrm>
+      </p:grpSpPr>
+      <p:pic>
+        <p:nvPicPr>
+          <p:cNvPr id="2" name="Picture 1">
+            <a:extLst>
+              <a:ext uri="{FF2B5EF4-FFF2-40B4-BE49-F238E27FC236}">
+                <a16:creationId xmlns:a16="http://schemas.microsoft.com/office/drawing/2014/main" id="{F8AD8463-7C70-6E0E-D0DE-35BD02073261}"/>
+              </a:ext>
+            </a:extLst>
+          </p:cNvPr>
+          <p:cNvPicPr>
+            <a:picLocks noChangeAspect="1"/>
+          </p:cNvPicPr>
+          <p:nvPr/>
+        </p:nvPicPr>
+        <p:blipFill>
+          <a:blip r:embed="rId2"/>
+          <a:stretch>
+            <a:fillRect/>
+          </a:stretch>
+        </p:blipFill>
+        <p:spPr>
+          <a:xfrm>
+            <a:off x="2209800" y="247574"/>
+            <a:ext cx="7772400" cy="6362851"/>
+          </a:xfrm>
+          <a:prstGeom prst="rect">
+            <a:avLst/>
+          </a:prstGeom>
+        </p:spPr>
+      </p:pic>
+    </p:spTree>
+    <p:extLst>
+      <p:ext uri="{BB962C8B-B14F-4D97-AF65-F5344CB8AC3E}">
+        <p14:creationId xmlns:p14="http://schemas.microsoft.com/office/powerpoint/2010/main" val="4136886652"/>
+      </p:ext>
+    </p:extLst>
+  </p:cSld>
+  <p:clrMapOvr>
+    <a:masterClrMapping/>
+  </p:clrMapOvr>
+</p:sld>
+</file>
+
+<file path=ppt/slides/slide7.xml><?xml version="1.0" encoding="utf-8"?>
+<p:sld xmlns:a="http://schemas.openxmlformats.org/drawingml/2006/main" xmlns:r="http://schemas.openxmlformats.org/officeDocument/2006/relationships" xmlns:p="http://schemas.openxmlformats.org/presentationml/2006/main">
   <p:cSld>
     <p:bg>
       <p:bgPr>
-        <a:solidFill xmlns:a="http://schemas.openxmlformats.org/drawingml/2006/main">
+        <a:solidFill>
           <a:srgbClr val="0B1425"/>
         </a:solidFill>
+        <a:effectLst/>
       </p:bgPr>
     </p:bg>
     <p:spTree>
@@ -4302,41 +4182,46 @@
         <p:nvPr/>
       </p:nvGrpSpPr>
       <p:grpSpPr>
-        <a:xfrm xmlns:a="http://schemas.openxmlformats.org/drawingml/2006/main"/>
+        <a:xfrm>
+          <a:off x="0" y="0"/>
+          <a:ext cx="0" cy="0"/>
+          <a:chOff x="0" y="0"/>
+          <a:chExt cx="0" cy="0"/>
+        </a:xfrm>
       </p:grpSpPr>
       <p:sp>
         <p:nvSpPr>
-          <p:cNvPr id="8" name="">
-            <a:extLst xmlns:a="http://schemas.openxmlformats.org/drawingml/2006/main">
+          <p:cNvPr id="8" name="Rectangle 7">
+            <a:extLst>
               <a:ext uri="{FF2B5EF4-FFF2-40B4-BE49-F238E27FC236}">
                 <a16:creationId xmlns:a16="http://schemas.microsoft.com/office/drawing/2014/main" id="{E8C52278-C245-4BD0-864C-AA976CE03557}"/>
               </a:ext>
             </a:extLst>
           </p:cNvPr>
           <p:cNvSpPr>
-            <a:spLocks xmlns:a="http://schemas.openxmlformats.org/drawingml/2006/main" noGrp="1"/>
+            <a:spLocks noGrp="1"/>
           </p:cNvSpPr>
           <p:nvPr/>
         </p:nvSpPr>
         <p:spPr>
-          <a:xfrm xmlns:a="http://schemas.openxmlformats.org/drawingml/2006/main">
+          <a:xfrm>
             <a:off x="685800" y="495300"/>
             <a:ext cx="10820400" cy="762000"/>
           </a:xfrm>
-          <a:prstGeom xmlns:a="http://schemas.openxmlformats.org/drawingml/2006/main" prst="rect">
+          <a:prstGeom prst="rect">
             <a:avLst/>
           </a:prstGeom>
-          <a:noFill xmlns:a="http://schemas.openxmlformats.org/drawingml/2006/main"/>
-          <a:ln xmlns:a="http://schemas.openxmlformats.org/drawingml/2006/main" w="0">
+          <a:noFill/>
+          <a:ln w="0">
             <a:noFill/>
           </a:ln>
         </p:spPr>
         <p:txBody>
-          <a:bodyPr xmlns:a="http://schemas.openxmlformats.org/drawingml/2006/main">
+          <a:bodyPr>
             <a:noAutofit/>
           </a:bodyPr>
-          <a:lstStyle xmlns:a="http://schemas.openxmlformats.org/drawingml/2006/main"/>
-          <a:p xmlns:a="http://schemas.openxmlformats.org/drawingml/2006/main">
+          <a:lstStyle/>
+          <a:p>
             <a:pPr>
               <a:defRPr sz="3450" b="1">
                 <a:solidFill>
@@ -4363,37 +4248,37 @@
       </p:sp>
       <p:sp>
         <p:nvSpPr>
-          <p:cNvPr id="2" name="">
-            <a:extLst xmlns:a="http://schemas.openxmlformats.org/drawingml/2006/main">
+          <p:cNvPr id="2" name="Rectangle 1">
+            <a:extLst>
               <a:ext uri="{FF2B5EF4-FFF2-40B4-BE49-F238E27FC236}">
                 <a16:creationId xmlns:a16="http://schemas.microsoft.com/office/drawing/2014/main" id="{E644A755-E630-4096-A34D-E86A940E5B9C}"/>
               </a:ext>
             </a:extLst>
           </p:cNvPr>
           <p:cNvSpPr>
-            <a:spLocks xmlns:a="http://schemas.openxmlformats.org/drawingml/2006/main" noGrp="1"/>
+            <a:spLocks noGrp="1"/>
           </p:cNvSpPr>
           <p:nvPr/>
         </p:nvSpPr>
         <p:spPr>
-          <a:xfrm xmlns:a="http://schemas.openxmlformats.org/drawingml/2006/main">
+          <a:xfrm>
             <a:off x="11049000" y="6286500"/>
             <a:ext cx="476250" cy="266700"/>
           </a:xfrm>
-          <a:prstGeom xmlns:a="http://schemas.openxmlformats.org/drawingml/2006/main" prst="rect">
+          <a:prstGeom prst="rect">
             <a:avLst/>
           </a:prstGeom>
-          <a:noFill xmlns:a="http://schemas.openxmlformats.org/drawingml/2006/main"/>
-          <a:ln xmlns:a="http://schemas.openxmlformats.org/drawingml/2006/main" w="0">
+          <a:noFill/>
+          <a:ln w="0">
             <a:noFill/>
           </a:ln>
         </p:spPr>
         <p:txBody>
-          <a:bodyPr xmlns:a="http://schemas.openxmlformats.org/drawingml/2006/main">
+          <a:bodyPr>
             <a:noAutofit/>
           </a:bodyPr>
-          <a:lstStyle xmlns:a="http://schemas.openxmlformats.org/drawingml/2006/main"/>
-          <a:p xmlns:a="http://schemas.openxmlformats.org/drawingml/2006/main">
+          <a:lstStyle/>
+          <a:p>
             <a:pPr>
               <a:defRPr sz="1350" b="0">
                 <a:solidFill>
@@ -4420,37 +4305,37 @@
       </p:sp>
       <p:sp>
         <p:nvSpPr>
-          <p:cNvPr id="3" name="">
-            <a:extLst xmlns:a="http://schemas.openxmlformats.org/drawingml/2006/main">
+          <p:cNvPr id="3" name="Rectangle 2">
+            <a:extLst>
               <a:ext uri="{FF2B5EF4-FFF2-40B4-BE49-F238E27FC236}">
                 <a16:creationId xmlns:a16="http://schemas.microsoft.com/office/drawing/2014/main" id="{05307140-EB58-4453-8347-8CA82F771519}"/>
               </a:ext>
             </a:extLst>
           </p:cNvPr>
           <p:cNvSpPr>
-            <a:spLocks xmlns:a="http://schemas.openxmlformats.org/drawingml/2006/main" noGrp="1"/>
+            <a:spLocks noGrp="1"/>
           </p:cNvSpPr>
           <p:nvPr/>
         </p:nvSpPr>
         <p:spPr>
-          <a:xfrm xmlns:a="http://schemas.openxmlformats.org/drawingml/2006/main">
+          <a:xfrm>
             <a:off x="723900" y="1752600"/>
             <a:ext cx="5048250" cy="523875"/>
           </a:xfrm>
-          <a:prstGeom xmlns:a="http://schemas.openxmlformats.org/drawingml/2006/main" prst="rect">
+          <a:prstGeom prst="rect">
             <a:avLst/>
           </a:prstGeom>
-          <a:noFill xmlns:a="http://schemas.openxmlformats.org/drawingml/2006/main"/>
-          <a:ln xmlns:a="http://schemas.openxmlformats.org/drawingml/2006/main" w="0">
+          <a:noFill/>
+          <a:ln w="0">
             <a:noFill/>
           </a:ln>
         </p:spPr>
         <p:txBody>
-          <a:bodyPr xmlns:a="http://schemas.openxmlformats.org/drawingml/2006/main">
+          <a:bodyPr>
             <a:noAutofit/>
           </a:bodyPr>
-          <a:lstStyle xmlns:a="http://schemas.openxmlformats.org/drawingml/2006/main"/>
-          <a:p xmlns:a="http://schemas.openxmlformats.org/drawingml/2006/main">
+          <a:lstStyle/>
+          <a:p>
             <a:pPr>
               <a:defRPr sz="2625" b="1">
                 <a:solidFill>
@@ -4477,37 +4362,37 @@
       </p:sp>
       <p:sp>
         <p:nvSpPr>
-          <p:cNvPr id="4" name="">
-            <a:extLst xmlns:a="http://schemas.openxmlformats.org/drawingml/2006/main">
+          <p:cNvPr id="4" name="Rectangle 3">
+            <a:extLst>
               <a:ext uri="{FF2B5EF4-FFF2-40B4-BE49-F238E27FC236}">
                 <a16:creationId xmlns:a16="http://schemas.microsoft.com/office/drawing/2014/main" id="{BF0D22C6-C7FC-4227-B8D3-5944649F7CF6}"/>
               </a:ext>
             </a:extLst>
           </p:cNvPr>
           <p:cNvSpPr>
-            <a:spLocks xmlns:a="http://schemas.openxmlformats.org/drawingml/2006/main" noGrp="1"/>
+            <a:spLocks noGrp="1"/>
           </p:cNvSpPr>
           <p:nvPr/>
         </p:nvSpPr>
         <p:spPr>
-          <a:xfrm xmlns:a="http://schemas.openxmlformats.org/drawingml/2006/main">
+          <a:xfrm>
             <a:off x="723900" y="2524125"/>
             <a:ext cx="5095875" cy="1857375"/>
           </a:xfrm>
-          <a:prstGeom xmlns:a="http://schemas.openxmlformats.org/drawingml/2006/main" prst="rect">
+          <a:prstGeom prst="rect">
             <a:avLst/>
           </a:prstGeom>
-          <a:noFill xmlns:a="http://schemas.openxmlformats.org/drawingml/2006/main"/>
-          <a:ln xmlns:a="http://schemas.openxmlformats.org/drawingml/2006/main" w="0">
+          <a:noFill/>
+          <a:ln w="0">
             <a:noFill/>
           </a:ln>
         </p:spPr>
         <p:txBody>
-          <a:bodyPr xmlns:a="http://schemas.openxmlformats.org/drawingml/2006/main">
+          <a:bodyPr>
             <a:noAutofit/>
           </a:bodyPr>
-          <a:lstStyle xmlns:a="http://schemas.openxmlformats.org/drawingml/2006/main"/>
-          <a:p xmlns:a="http://schemas.openxmlformats.org/drawingml/2006/main">
+          <a:lstStyle/>
+          <a:p>
             <a:pPr>
               <a:defRPr sz="2325" b="0">
                 <a:solidFill>
@@ -4530,7 +4415,7 @@
               <a:t>Local checkout application</a:t>
             </a:r>
           </a:p>
-          <a:p xmlns:a="http://schemas.openxmlformats.org/drawingml/2006/main">
+          <a:p>
             <a:pPr>
               <a:defRPr sz="2325" b="0">
                 <a:solidFill>
@@ -4553,7 +4438,7 @@
               <a:t>Prometheus health metrics</a:t>
             </a:r>
           </a:p>
-          <a:p xmlns:a="http://schemas.openxmlformats.org/drawingml/2006/main">
+          <a:p>
             <a:pPr>
               <a:defRPr sz="2325" b="0">
                 <a:solidFill>
@@ -4580,37 +4465,37 @@
       </p:sp>
       <p:sp>
         <p:nvSpPr>
-          <p:cNvPr id="5" name="">
-            <a:extLst xmlns:a="http://schemas.openxmlformats.org/drawingml/2006/main">
+          <p:cNvPr id="5" name="Rectangle 4">
+            <a:extLst>
               <a:ext uri="{FF2B5EF4-FFF2-40B4-BE49-F238E27FC236}">
                 <a16:creationId xmlns:a16="http://schemas.microsoft.com/office/drawing/2014/main" id="{F0835AA4-1BBD-406A-B4DF-D77E7B31B12F}"/>
               </a:ext>
             </a:extLst>
           </p:cNvPr>
           <p:cNvSpPr>
-            <a:spLocks xmlns:a="http://schemas.openxmlformats.org/drawingml/2006/main" noGrp="1"/>
+            <a:spLocks noGrp="1"/>
           </p:cNvSpPr>
           <p:nvPr/>
         </p:nvSpPr>
         <p:spPr>
-          <a:xfrm xmlns:a="http://schemas.openxmlformats.org/drawingml/2006/main">
+          <a:xfrm>
             <a:off x="6667500" y="1752600"/>
             <a:ext cx="4857750" cy="523875"/>
           </a:xfrm>
-          <a:prstGeom xmlns:a="http://schemas.openxmlformats.org/drawingml/2006/main" prst="rect">
+          <a:prstGeom prst="rect">
             <a:avLst/>
           </a:prstGeom>
-          <a:noFill xmlns:a="http://schemas.openxmlformats.org/drawingml/2006/main"/>
-          <a:ln xmlns:a="http://schemas.openxmlformats.org/drawingml/2006/main" w="0">
+          <a:noFill/>
+          <a:ln w="0">
             <a:noFill/>
           </a:ln>
         </p:spPr>
         <p:txBody>
-          <a:bodyPr xmlns:a="http://schemas.openxmlformats.org/drawingml/2006/main">
+          <a:bodyPr>
             <a:noAutofit/>
           </a:bodyPr>
-          <a:lstStyle xmlns:a="http://schemas.openxmlformats.org/drawingml/2006/main"/>
-          <a:p xmlns:a="http://schemas.openxmlformats.org/drawingml/2006/main">
+          <a:lstStyle/>
+          <a:p>
             <a:pPr>
               <a:defRPr sz="2625" b="1">
                 <a:solidFill>
@@ -4637,37 +4522,37 @@
       </p:sp>
       <p:sp>
         <p:nvSpPr>
-          <p:cNvPr id="6" name="">
-            <a:extLst xmlns:a="http://schemas.openxmlformats.org/drawingml/2006/main">
+          <p:cNvPr id="6" name="Rectangle 5">
+            <a:extLst>
               <a:ext uri="{FF2B5EF4-FFF2-40B4-BE49-F238E27FC236}">
                 <a16:creationId xmlns:a16="http://schemas.microsoft.com/office/drawing/2014/main" id="{F8426CEC-D9FD-4C9E-AADE-1E519998819A}"/>
               </a:ext>
             </a:extLst>
           </p:cNvPr>
           <p:cNvSpPr>
-            <a:spLocks xmlns:a="http://schemas.openxmlformats.org/drawingml/2006/main" noGrp="1"/>
+            <a:spLocks noGrp="1"/>
           </p:cNvSpPr>
           <p:nvPr/>
         </p:nvSpPr>
         <p:spPr>
-          <a:xfrm xmlns:a="http://schemas.openxmlformats.org/drawingml/2006/main">
+          <a:xfrm>
             <a:off x="6667500" y="2524125"/>
             <a:ext cx="4857750" cy="1857375"/>
           </a:xfrm>
-          <a:prstGeom xmlns:a="http://schemas.openxmlformats.org/drawingml/2006/main" prst="rect">
+          <a:prstGeom prst="rect">
             <a:avLst/>
           </a:prstGeom>
-          <a:noFill xmlns:a="http://schemas.openxmlformats.org/drawingml/2006/main"/>
-          <a:ln xmlns:a="http://schemas.openxmlformats.org/drawingml/2006/main" w="0">
+          <a:noFill/>
+          <a:ln w="0">
             <a:noFill/>
           </a:ln>
         </p:spPr>
         <p:txBody>
-          <a:bodyPr xmlns:a="http://schemas.openxmlformats.org/drawingml/2006/main">
+          <a:bodyPr>
             <a:noAutofit/>
           </a:bodyPr>
-          <a:lstStyle xmlns:a="http://schemas.openxmlformats.org/drawingml/2006/main"/>
-          <a:p xmlns:a="http://schemas.openxmlformats.org/drawingml/2006/main">
+          <a:lstStyle/>
+          <a:p>
             <a:pPr>
               <a:defRPr sz="2325" b="0">
                 <a:solidFill>
@@ -4690,7 +4575,7 @@
               <a:t>Controlled memory failure</a:t>
             </a:r>
           </a:p>
-          <a:p xmlns:a="http://schemas.openxmlformats.org/drawingml/2006/main">
+          <a:p>
             <a:pPr>
               <a:defRPr sz="2325" b="0">
                 <a:solidFill>
@@ -4713,7 +4598,7 @@
               <a:t>Knowledge retrieval example</a:t>
             </a:r>
           </a:p>
-          <a:p xmlns:a="http://schemas.openxmlformats.org/drawingml/2006/main">
+          <a:p>
             <a:pPr>
               <a:defRPr sz="2325" b="0">
                 <a:solidFill>
@@ -4740,37 +4625,37 @@
       </p:sp>
       <p:sp>
         <p:nvSpPr>
-          <p:cNvPr id="7" name="">
-            <a:extLst xmlns:a="http://schemas.openxmlformats.org/drawingml/2006/main">
+          <p:cNvPr id="7" name="Rectangle 6">
+            <a:extLst>
               <a:ext uri="{FF2B5EF4-FFF2-40B4-BE49-F238E27FC236}">
                 <a16:creationId xmlns:a16="http://schemas.microsoft.com/office/drawing/2014/main" id="{8B1333A4-7252-4A60-9CCE-B245E3A3906B}"/>
               </a:ext>
             </a:extLst>
           </p:cNvPr>
           <p:cNvSpPr>
-            <a:spLocks xmlns:a="http://schemas.openxmlformats.org/drawingml/2006/main" noGrp="1"/>
+            <a:spLocks noGrp="1"/>
           </p:cNvSpPr>
           <p:nvPr/>
         </p:nvSpPr>
         <p:spPr>
-          <a:xfrm xmlns:a="http://schemas.openxmlformats.org/drawingml/2006/main">
+          <a:xfrm>
             <a:off x="723900" y="5238750"/>
             <a:ext cx="10572750" cy="571500"/>
           </a:xfrm>
-          <a:prstGeom xmlns:a="http://schemas.openxmlformats.org/drawingml/2006/main" prst="rect">
+          <a:prstGeom prst="rect">
             <a:avLst/>
           </a:prstGeom>
-          <a:noFill xmlns:a="http://schemas.openxmlformats.org/drawingml/2006/main"/>
-          <a:ln xmlns:a="http://schemas.openxmlformats.org/drawingml/2006/main" w="0">
+          <a:noFill/>
+          <a:ln w="0">
             <a:noFill/>
           </a:ln>
         </p:spPr>
         <p:txBody>
-          <a:bodyPr xmlns:a="http://schemas.openxmlformats.org/drawingml/2006/main">
+          <a:bodyPr>
             <a:noAutofit/>
           </a:bodyPr>
-          <a:lstStyle xmlns:a="http://schemas.openxmlformats.org/drawingml/2006/main"/>
-          <a:p xmlns:a="http://schemas.openxmlformats.org/drawingml/2006/main">
+          <a:lstStyle/>
+          <a:p>
             <a:pPr>
               <a:defRPr sz="3150" b="1">
                 <a:solidFill>
@@ -4802,6 +4687,9 @@
       </p:ext>
     </p:extLst>
   </p:cSld>
+  <p:clrMapOvr>
+    <a:masterClrMapping/>
+  </p:clrMapOvr>
 </p:sld>
 </file>
 
@@ -5047,5 +4935,254 @@
       </a:bgFillStyleLst>
     </a:fmtScheme>
   </a:themeElements>
+  <a:objectDefaults/>
+  <a:extraClrSchemeLst/>
+</a:theme>
+</file>
+
+<file path=ppt/theme/theme2.xml><?xml version="1.0" encoding="utf-8"?>
+<a:theme xmlns:a="http://schemas.openxmlformats.org/drawingml/2006/main" name="ChatGPT">
+  <a:themeElements>
+    <a:clrScheme name="ChatGPT">
+      <a:dk1>
+        <a:srgbClr val="000000"/>
+      </a:dk1>
+      <a:lt1>
+        <a:srgbClr val="FFFFFF"/>
+      </a:lt1>
+      <a:dk2>
+        <a:srgbClr val="0E2841"/>
+      </a:dk2>
+      <a:lt2>
+        <a:srgbClr val="E8E8E8"/>
+      </a:lt2>
+      <a:accent1>
+        <a:srgbClr val="156082"/>
+      </a:accent1>
+      <a:accent2>
+        <a:srgbClr val="E97132"/>
+      </a:accent2>
+      <a:accent3>
+        <a:srgbClr val="196B24"/>
+      </a:accent3>
+      <a:accent4>
+        <a:srgbClr val="0F9ED5"/>
+      </a:accent4>
+      <a:accent5>
+        <a:srgbClr val="A02B93"/>
+      </a:accent5>
+      <a:accent6>
+        <a:srgbClr val="4EA72E"/>
+      </a:accent6>
+      <a:hlink>
+        <a:srgbClr val="467886"/>
+      </a:hlink>
+      <a:folHlink>
+        <a:srgbClr val="96607D"/>
+      </a:folHlink>
+    </a:clrScheme>
+    <a:fontScheme name="Office">
+      <a:majorFont>
+        <a:latin typeface="Calibri Light"/>
+        <a:ea typeface="Calibri Light"/>
+        <a:cs typeface="Calibri Light"/>
+      </a:majorFont>
+      <a:minorFont>
+        <a:latin typeface="Calibri"/>
+        <a:ea typeface="Calibri"/>
+        <a:cs typeface="Calibri"/>
+      </a:minorFont>
+    </a:fontScheme>
+    <a:fmtScheme name="ChatGPT">
+      <a:fillStyleLst>
+        <a:solidFill>
+          <a:schemeClr val="phClr"/>
+        </a:solidFill>
+        <a:gradFill>
+          <a:gsLst>
+            <a:gs pos="0">
+              <a:schemeClr val="phClr">
+                <a:tint val="67000"/>
+                <a:lumMod val="110000"/>
+                <a:satMod val="105000"/>
+              </a:schemeClr>
+            </a:gs>
+            <a:gs pos="50000">
+              <a:schemeClr val="phClr">
+                <a:tint val="73000"/>
+                <a:lumMod val="105000"/>
+                <a:satMod val="103000"/>
+              </a:schemeClr>
+            </a:gs>
+            <a:gs pos="100000">
+              <a:schemeClr val="phClr">
+                <a:tint val="81000"/>
+                <a:lumMod val="105000"/>
+                <a:satMod val="109000"/>
+              </a:schemeClr>
+            </a:gs>
+          </a:gsLst>
+          <a:lin ang="5400000" scaled="0"/>
+        </a:gradFill>
+        <a:gradFill>
+          <a:gsLst>
+            <a:gs pos="0">
+              <a:schemeClr val="phClr">
+                <a:tint val="94000"/>
+                <a:lumMod val="102000"/>
+                <a:satMod val="103000"/>
+              </a:schemeClr>
+            </a:gs>
+            <a:gs pos="50000">
+              <a:schemeClr val="phClr">
+                <a:shade val="100000"/>
+                <a:lumMod val="100000"/>
+                <a:satMod val="110000"/>
+              </a:schemeClr>
+            </a:gs>
+            <a:gs pos="100000">
+              <a:schemeClr val="phClr">
+                <a:shade val="78000"/>
+                <a:lumMod val="99000"/>
+                <a:satMod val="120000"/>
+              </a:schemeClr>
+            </a:gs>
+          </a:gsLst>
+          <a:lin ang="5400000" scaled="0"/>
+        </a:gradFill>
+      </a:fillStyleLst>
+      <a:lnStyleLst>
+        <a:ln w="12700">
+          <a:solidFill>
+            <a:schemeClr val="phClr"/>
+          </a:solidFill>
+          <a:prstDash val="solid"/>
+        </a:ln>
+        <a:ln w="19050">
+          <a:solidFill>
+            <a:schemeClr val="phClr"/>
+          </a:solidFill>
+          <a:prstDash val="solid"/>
+        </a:ln>
+        <a:ln w="25400">
+          <a:solidFill>
+            <a:schemeClr val="phClr"/>
+          </a:solidFill>
+          <a:prstDash val="solid"/>
+        </a:ln>
+      </a:lnStyleLst>
+      <a:effectStyleLst>
+        <a:effectStyle>
+          <a:effectLst/>
+        </a:effectStyle>
+        <a:effectStyle>
+          <a:effectLst/>
+        </a:effectStyle>
+        <a:effectStyle>
+          <a:effectLst>
+            <a:outerShdw blurRad="57150" dist="19050" dir="5400000">
+              <a:srgbClr val="000000">
+                <a:alpha val="16000"/>
+              </a:srgbClr>
+            </a:outerShdw>
+          </a:effectLst>
+        </a:effectStyle>
+        <a:effectStyle>
+          <a:effectLst>
+            <a:outerShdw blurRad="19050" dist="9525" dir="5400000">
+              <a:srgbClr val="000000">
+                <a:alpha val="6000"/>
+              </a:srgbClr>
+            </a:outerShdw>
+          </a:effectLst>
+        </a:effectStyle>
+        <a:effectStyle>
+          <a:effectLst>
+            <a:outerShdw blurRad="28575" dist="9525" dir="5400000">
+              <a:srgbClr val="000000">
+                <a:alpha val="8000"/>
+              </a:srgbClr>
+            </a:outerShdw>
+          </a:effectLst>
+        </a:effectStyle>
+        <a:effectStyle>
+          <a:effectLst>
+            <a:outerShdw blurRad="57150" dist="19050" dir="5400000">
+              <a:srgbClr val="000000">
+                <a:alpha val="10000"/>
+              </a:srgbClr>
+            </a:outerShdw>
+          </a:effectLst>
+        </a:effectStyle>
+        <a:effectStyle>
+          <a:effectLst>
+            <a:outerShdw blurRad="114300" dist="38100" dir="5400000">
+              <a:srgbClr val="000000">
+                <a:alpha val="12000"/>
+              </a:srgbClr>
+            </a:outerShdw>
+          </a:effectLst>
+        </a:effectStyle>
+        <a:effectStyle>
+          <a:effectLst>
+            <a:outerShdw blurRad="171450" dist="57150" dir="5400000">
+              <a:srgbClr val="000000">
+                <a:alpha val="16000"/>
+              </a:srgbClr>
+            </a:outerShdw>
+          </a:effectLst>
+        </a:effectStyle>
+        <a:effectStyle>
+          <a:effectLst>
+            <a:outerShdw blurRad="266700" dist="95250" dir="5400000">
+              <a:srgbClr val="000000">
+                <a:alpha val="24000"/>
+              </a:srgbClr>
+            </a:outerShdw>
+          </a:effectLst>
+        </a:effectStyle>
+      </a:effectStyleLst>
+      <a:bgFillStyleLst>
+        <a:solidFill>
+          <a:schemeClr val="phClr"/>
+        </a:solidFill>
+        <a:solidFill>
+          <a:schemeClr val="phClr">
+            <a:tint val="95000"/>
+            <a:satMod val="170000"/>
+          </a:schemeClr>
+        </a:solidFill>
+        <a:gradFill>
+          <a:gsLst>
+            <a:gs pos="0">
+              <a:schemeClr val="phClr">
+                <a:tint val="93000"/>
+                <a:shade val="98000"/>
+                <a:lumMod val="102000"/>
+                <a:satMod val="150000"/>
+              </a:schemeClr>
+            </a:gs>
+            <a:gs pos="50000">
+              <a:schemeClr val="phClr">
+                <a:tint val="98000"/>
+                <a:shade val="90000"/>
+                <a:lumMod val="103000"/>
+                <a:satMod val="130000"/>
+              </a:schemeClr>
+            </a:gs>
+            <a:gs pos="100000">
+              <a:schemeClr val="phClr">
+                <a:shade val="63000"/>
+                <a:satMod val="120000"/>
+              </a:schemeClr>
+            </a:gs>
+          </a:gsLst>
+          <a:lin ang="5400000" scaled="0"/>
+        </a:gradFill>
+      </a:bgFillStyleLst>
+    </a:fmtScheme>
+  </a:themeElements>
+  <a:objectDefaults/>
+  <a:extraClrSchemeLst/>
 </a:theme>
 </file>
</xml_diff>